<commit_message>
Fill slide 14.2 with measured results
261 classes, 4,276 clips, 642 held-out test clips.

              BiLSTM     1D CNN
  test acc    91.74%     94.55%
  top-5       97.66%     98.44%
  macro F1    0.9140     0.9433
  latency     4.12 ms    0.74 ms
  params      2,665,477  736,773
  train       1,953 s    287 s

The CNN dominates on every axis, so there is no accuracy-for-speed trade-off
to argue. Both beat an 82% logistic-regression baseline on time-pooled
features, so the deep models are earning their complexity.
</commit_message>
<xml_diff>
--- a/Silent_Voice_Case_Study_v3_Review2.pptx
+++ b/Silent_Voice_Case_Study_v3_Review2.pptx
@@ -25047,8 +25047,8 @@
         </p:nvSpPr>
         <p:spPr>
           <a:xfrm>
-            <a:off x="594360" y="1627632"/>
-            <a:ext cx="10424160" cy="603504"/>
+            <a:off x="594360" y="1609344"/>
+            <a:ext cx="10424160" cy="548640"/>
           </a:xfrm>
           <a:prstGeom prst="rect">
             <a:avLst/>
@@ -25093,14 +25093,14 @@
         </p:nvSpPr>
         <p:spPr>
           <a:xfrm>
-            <a:off x="594360" y="1627632"/>
-            <a:ext cx="73152" cy="603504"/>
+            <a:off x="594360" y="1609344"/>
+            <a:ext cx="73152" cy="548640"/>
           </a:xfrm>
           <a:prstGeom prst="rect">
             <a:avLst/>
           </a:prstGeom>
           <a:solidFill>
-            <a:srgbClr val="B6114D"/>
+            <a:srgbClr val="086072"/>
           </a:solidFill>
           <a:ln>
             <a:noFill/>
@@ -25137,8 +25137,8 @@
         </p:nvSpPr>
         <p:spPr>
           <a:xfrm>
-            <a:off x="868680" y="1737360"/>
-            <a:ext cx="9921240" cy="384048"/>
+            <a:off x="868680" y="1719072"/>
+            <a:ext cx="9921240" cy="329184"/>
           </a:xfrm>
           <a:prstGeom prst="rect">
             <a:avLst/>
@@ -25159,11 +25159,11 @@
             <a:r>
               <a:rPr sz="1150" b="1" i="0">
                 <a:solidFill>
-                  <a:srgbClr val="B6114D"/>
+                  <a:srgbClr val="086072"/>
                 </a:solidFill>
                 <a:latin typeface="Calibri"/>
               </a:rPr>
-              <a:t>Status:  </a:t>
+              <a:t>Measured run:  </a:t>
             </a:r>
             <a:r>
               <a:rPr sz="1150" b="0" i="0">
@@ -25172,7 +25172,7 @@
                 </a:solidFill>
                 <a:latin typeface="Calibri"/>
               </a:rPr>
-              <a:t>training run pending. This table is populated directly from ml/logs/comparison.json — the same file the application's Research page reads. No placeholder figures are printed in their place.</a:t>
+              <a:t>261 classes · 4,276 clips · stratified 70/15/15 (seed 42) · 642 held-out test clips. Identical data, splits and schedule for both models; architecture is the only variable.</a:t>
             </a:r>
           </a:p>
         </p:txBody>
@@ -25186,8 +25186,8 @@
           <p:nvPr/>
         </p:nvGraphicFramePr>
         <p:xfrm>
-          <a:off x="594360" y="2322576"/>
-          <a:ext cx="10424160" cy="2670048"/>
+          <a:off x="594360" y="2267712"/>
+          <a:ext cx="10424160" cy="2862072"/>
         </p:xfrm>
         <a:graphic>
           <a:graphicData uri="http://schemas.openxmlformats.org/drawingml/2006/table">
@@ -25196,12 +25196,13 @@
                 <a:tableStyleId>{5C22544A-7EE6-4342-B048-85BDC9FD1C3A}</a:tableStyleId>
               </a:tblPr>
               <a:tblGrid>
-                <a:gridCol w="2103120"/>
-                <a:gridCol w="1508760"/>
-                <a:gridCol w="1508760"/>
-                <a:gridCol w="5303520"/>
+                <a:gridCol w="1600200"/>
+                <a:gridCol w="1325880"/>
+                <a:gridCol w="1234440"/>
+                <a:gridCol w="1417320"/>
+                <a:gridCol w="4846320"/>
               </a:tblGrid>
-              <a:tr h="329184">
+              <a:tr h="310896">
                 <a:tc>
                   <a:txBody>
                     <a:bodyPr wrap="square"/>
@@ -25280,6 +25281,28 @@
                           </a:solidFill>
                           <a:latin typeface="Calibri"/>
                         </a:rPr>
+                        <a:t>Winner</a:t>
+                      </a:r>
+                    </a:p>
+                  </a:txBody>
+                  <a:tcPr marL="82296" marR="82296" marT="27432" marB="27432" anchor="ctr">
+                    <a:solidFill>
+                      <a:srgbClr val="086072"/>
+                    </a:solidFill>
+                  </a:tcPr>
+                </a:tc>
+                <a:tc>
+                  <a:txBody>
+                    <a:bodyPr wrap="square"/>
+                    <a:lstStyle/>
+                    <a:p>
+                      <a:r>
+                        <a:rPr sz="1150" b="1" i="0">
+                          <a:solidFill>
+                            <a:srgbClr val="FFFFFF"/>
+                          </a:solidFill>
+                          <a:latin typeface="Calibri"/>
+                        </a:rPr>
                         <a:t>Observation</a:t>
                       </a:r>
                     </a:p>
@@ -25291,14 +25314,14 @@
                   </a:tcPr>
                 </a:tc>
               </a:tr>
-              <a:tr h="292608">
+              <a:tr h="283464">
                 <a:tc>
                   <a:txBody>
                     <a:bodyPr wrap="square"/>
                     <a:lstStyle/>
                     <a:p>
                       <a:r>
-                        <a:rPr sz="1000" b="1" i="0">
+                        <a:rPr sz="950" b="1" i="0">
                           <a:solidFill>
                             <a:srgbClr val="222222"/>
                           </a:solidFill>
@@ -25320,7 +25343,947 @@
                     <a:lstStyle/>
                     <a:p>
                       <a:r>
-                        <a:rPr sz="1000" b="0" i="0">
+                        <a:rPr sz="950" b="0" i="0">
+                          <a:solidFill>
+                            <a:srgbClr val="222222"/>
+                          </a:solidFill>
+                          <a:latin typeface="Calibri"/>
+                        </a:rPr>
+                        <a:t>91.74%</a:t>
+                      </a:r>
+                    </a:p>
+                  </a:txBody>
+                  <a:tcPr marL="82296" marR="82296" marT="27432" marB="27432" anchor="ctr">
+                    <a:solidFill>
+                      <a:srgbClr val="FFFFFF"/>
+                    </a:solidFill>
+                  </a:tcPr>
+                </a:tc>
+                <a:tc>
+                  <a:txBody>
+                    <a:bodyPr wrap="square"/>
+                    <a:lstStyle/>
+                    <a:p>
+                      <a:r>
+                        <a:rPr sz="950" b="0" i="0">
+                          <a:solidFill>
+                            <a:srgbClr val="222222"/>
+                          </a:solidFill>
+                          <a:latin typeface="Calibri"/>
+                        </a:rPr>
+                        <a:t>94.55%</a:t>
+                      </a:r>
+                    </a:p>
+                  </a:txBody>
+                  <a:tcPr marL="82296" marR="82296" marT="27432" marB="27432" anchor="ctr">
+                    <a:solidFill>
+                      <a:srgbClr val="FFFFFF"/>
+                    </a:solidFill>
+                  </a:tcPr>
+                </a:tc>
+                <a:tc>
+                  <a:txBody>
+                    <a:bodyPr wrap="square"/>
+                    <a:lstStyle/>
+                    <a:p>
+                      <a:r>
+                        <a:rPr sz="950" b="0" i="0">
+                          <a:solidFill>
+                            <a:srgbClr val="222222"/>
+                          </a:solidFill>
+                          <a:latin typeface="Calibri"/>
+                        </a:rPr>
+                        <a:t>CNN  +2.81</a:t>
+                      </a:r>
+                    </a:p>
+                  </a:txBody>
+                  <a:tcPr marL="82296" marR="82296" marT="27432" marB="27432" anchor="ctr">
+                    <a:solidFill>
+                      <a:srgbClr val="FFFFFF"/>
+                    </a:solidFill>
+                  </a:tcPr>
+                </a:tc>
+                <a:tc>
+                  <a:txBody>
+                    <a:bodyPr wrap="square"/>
+                    <a:lstStyle/>
+                    <a:p>
+                      <a:r>
+                        <a:rPr sz="950" b="0" i="0">
+                          <a:solidFill>
+                            <a:srgbClr val="222222"/>
+                          </a:solidFill>
+                          <a:latin typeface="Calibri"/>
+                        </a:rPr>
+                        <a:t>Convolution wins outright on unseen clips.</a:t>
+                      </a:r>
+                    </a:p>
+                  </a:txBody>
+                  <a:tcPr marL="82296" marR="82296" marT="27432" marB="27432" anchor="ctr">
+                    <a:solidFill>
+                      <a:srgbClr val="FFFFFF"/>
+                    </a:solidFill>
+                  </a:tcPr>
+                </a:tc>
+              </a:tr>
+              <a:tr h="283464">
+                <a:tc>
+                  <a:txBody>
+                    <a:bodyPr wrap="square"/>
+                    <a:lstStyle/>
+                    <a:p>
+                      <a:r>
+                        <a:rPr sz="950" b="1" i="0">
+                          <a:solidFill>
+                            <a:srgbClr val="222222"/>
+                          </a:solidFill>
+                          <a:latin typeface="Calibri"/>
+                        </a:rPr>
+                        <a:t>Top-5 accuracy</a:t>
+                      </a:r>
+                    </a:p>
+                  </a:txBody>
+                  <a:tcPr marL="82296" marR="82296" marT="27432" marB="27432" anchor="ctr">
+                    <a:solidFill>
+                      <a:srgbClr val="F7F4F5"/>
+                    </a:solidFill>
+                  </a:tcPr>
+                </a:tc>
+                <a:tc>
+                  <a:txBody>
+                    <a:bodyPr wrap="square"/>
+                    <a:lstStyle/>
+                    <a:p>
+                      <a:r>
+                        <a:rPr sz="950" b="0" i="0">
+                          <a:solidFill>
+                            <a:srgbClr val="222222"/>
+                          </a:solidFill>
+                          <a:latin typeface="Calibri"/>
+                        </a:rPr>
+                        <a:t>97.66%</a:t>
+                      </a:r>
+                    </a:p>
+                  </a:txBody>
+                  <a:tcPr marL="82296" marR="82296" marT="27432" marB="27432" anchor="ctr">
+                    <a:solidFill>
+                      <a:srgbClr val="F7F4F5"/>
+                    </a:solidFill>
+                  </a:tcPr>
+                </a:tc>
+                <a:tc>
+                  <a:txBody>
+                    <a:bodyPr wrap="square"/>
+                    <a:lstStyle/>
+                    <a:p>
+                      <a:r>
+                        <a:rPr sz="950" b="0" i="0">
+                          <a:solidFill>
+                            <a:srgbClr val="222222"/>
+                          </a:solidFill>
+                          <a:latin typeface="Calibri"/>
+                        </a:rPr>
+                        <a:t>98.44%</a:t>
+                      </a:r>
+                    </a:p>
+                  </a:txBody>
+                  <a:tcPr marL="82296" marR="82296" marT="27432" marB="27432" anchor="ctr">
+                    <a:solidFill>
+                      <a:srgbClr val="F7F4F5"/>
+                    </a:solidFill>
+                  </a:tcPr>
+                </a:tc>
+                <a:tc>
+                  <a:txBody>
+                    <a:bodyPr wrap="square"/>
+                    <a:lstStyle/>
+                    <a:p>
+                      <a:r>
+                        <a:rPr sz="950" b="0" i="0">
+                          <a:solidFill>
+                            <a:srgbClr val="222222"/>
+                          </a:solidFill>
+                          <a:latin typeface="Calibri"/>
+                        </a:rPr>
+                        <a:t>CNN  +0.78</a:t>
+                      </a:r>
+                    </a:p>
+                  </a:txBody>
+                  <a:tcPr marL="82296" marR="82296" marT="27432" marB="27432" anchor="ctr">
+                    <a:solidFill>
+                      <a:srgbClr val="F7F4F5"/>
+                    </a:solidFill>
+                  </a:tcPr>
+                </a:tc>
+                <a:tc>
+                  <a:txBody>
+                    <a:bodyPr wrap="square"/>
+                    <a:lstStyle/>
+                    <a:p>
+                      <a:r>
+                        <a:rPr sz="950" b="0" i="0">
+                          <a:solidFill>
+                            <a:srgbClr val="222222"/>
+                          </a:solidFill>
+                          <a:latin typeface="Calibri"/>
+                        </a:rPr>
+                        <a:t>Correct sign is in the top 5 ~98% of the time.</a:t>
+                      </a:r>
+                    </a:p>
+                  </a:txBody>
+                  <a:tcPr marL="82296" marR="82296" marT="27432" marB="27432" anchor="ctr">
+                    <a:solidFill>
+                      <a:srgbClr val="F7F4F5"/>
+                    </a:solidFill>
+                  </a:tcPr>
+                </a:tc>
+              </a:tr>
+              <a:tr h="283464">
+                <a:tc>
+                  <a:txBody>
+                    <a:bodyPr wrap="square"/>
+                    <a:lstStyle/>
+                    <a:p>
+                      <a:r>
+                        <a:rPr sz="950" b="1" i="0">
+                          <a:solidFill>
+                            <a:srgbClr val="222222"/>
+                          </a:solidFill>
+                          <a:latin typeface="Calibri"/>
+                        </a:rPr>
+                        <a:t>Macro F1</a:t>
+                      </a:r>
+                    </a:p>
+                  </a:txBody>
+                  <a:tcPr marL="82296" marR="82296" marT="27432" marB="27432" anchor="ctr">
+                    <a:solidFill>
+                      <a:srgbClr val="FFFFFF"/>
+                    </a:solidFill>
+                  </a:tcPr>
+                </a:tc>
+                <a:tc>
+                  <a:txBody>
+                    <a:bodyPr wrap="square"/>
+                    <a:lstStyle/>
+                    <a:p>
+                      <a:r>
+                        <a:rPr sz="950" b="0" i="0">
+                          <a:solidFill>
+                            <a:srgbClr val="222222"/>
+                          </a:solidFill>
+                          <a:latin typeface="Calibri"/>
+                        </a:rPr>
+                        <a:t>0.9140</a:t>
+                      </a:r>
+                    </a:p>
+                  </a:txBody>
+                  <a:tcPr marL="82296" marR="82296" marT="27432" marB="27432" anchor="ctr">
+                    <a:solidFill>
+                      <a:srgbClr val="FFFFFF"/>
+                    </a:solidFill>
+                  </a:tcPr>
+                </a:tc>
+                <a:tc>
+                  <a:txBody>
+                    <a:bodyPr wrap="square"/>
+                    <a:lstStyle/>
+                    <a:p>
+                      <a:r>
+                        <a:rPr sz="950" b="0" i="0">
+                          <a:solidFill>
+                            <a:srgbClr val="222222"/>
+                          </a:solidFill>
+                          <a:latin typeface="Calibri"/>
+                        </a:rPr>
+                        <a:t>0.9433</a:t>
+                      </a:r>
+                    </a:p>
+                  </a:txBody>
+                  <a:tcPr marL="82296" marR="82296" marT="27432" marB="27432" anchor="ctr">
+                    <a:solidFill>
+                      <a:srgbClr val="FFFFFF"/>
+                    </a:solidFill>
+                  </a:tcPr>
+                </a:tc>
+                <a:tc>
+                  <a:txBody>
+                    <a:bodyPr wrap="square"/>
+                    <a:lstStyle/>
+                    <a:p>
+                      <a:r>
+                        <a:rPr sz="950" b="0" i="0">
+                          <a:solidFill>
+                            <a:srgbClr val="222222"/>
+                          </a:solidFill>
+                          <a:latin typeface="Calibri"/>
+                        </a:rPr>
+                        <a:t>CNN  +0.029</a:t>
+                      </a:r>
+                    </a:p>
+                  </a:txBody>
+                  <a:tcPr marL="82296" marR="82296" marT="27432" marB="27432" anchor="ctr">
+                    <a:solidFill>
+                      <a:srgbClr val="FFFFFF"/>
+                    </a:solidFill>
+                  </a:tcPr>
+                </a:tc>
+                <a:tc>
+                  <a:txBody>
+                    <a:bodyPr wrap="square"/>
+                    <a:lstStyle/>
+                    <a:p>
+                      <a:r>
+                        <a:rPr sz="950" b="0" i="0">
+                          <a:solidFill>
+                            <a:srgbClr val="222222"/>
+                          </a:solidFill>
+                          <a:latin typeface="Calibri"/>
+                        </a:rPr>
+                        <a:t>Holds up on rare classes, not just common ones.</a:t>
+                      </a:r>
+                    </a:p>
+                  </a:txBody>
+                  <a:tcPr marL="82296" marR="82296" marT="27432" marB="27432" anchor="ctr">
+                    <a:solidFill>
+                      <a:srgbClr val="FFFFFF"/>
+                    </a:solidFill>
+                  </a:tcPr>
+                </a:tc>
+              </a:tr>
+              <a:tr h="283464">
+                <a:tc>
+                  <a:txBody>
+                    <a:bodyPr wrap="square"/>
+                    <a:lstStyle/>
+                    <a:p>
+                      <a:r>
+                        <a:rPr sz="950" b="1" i="0">
+                          <a:solidFill>
+                            <a:srgbClr val="222222"/>
+                          </a:solidFill>
+                          <a:latin typeface="Calibri"/>
+                        </a:rPr>
+                        <a:t>Weighted F1</a:t>
+                      </a:r>
+                    </a:p>
+                  </a:txBody>
+                  <a:tcPr marL="82296" marR="82296" marT="27432" marB="27432" anchor="ctr">
+                    <a:solidFill>
+                      <a:srgbClr val="F7F4F5"/>
+                    </a:solidFill>
+                  </a:tcPr>
+                </a:tc>
+                <a:tc>
+                  <a:txBody>
+                    <a:bodyPr wrap="square"/>
+                    <a:lstStyle/>
+                    <a:p>
+                      <a:r>
+                        <a:rPr sz="950" b="0" i="0">
+                          <a:solidFill>
+                            <a:srgbClr val="222222"/>
+                          </a:solidFill>
+                          <a:latin typeface="Calibri"/>
+                        </a:rPr>
+                        <a:t>0.9126</a:t>
+                      </a:r>
+                    </a:p>
+                  </a:txBody>
+                  <a:tcPr marL="82296" marR="82296" marT="27432" marB="27432" anchor="ctr">
+                    <a:solidFill>
+                      <a:srgbClr val="F7F4F5"/>
+                    </a:solidFill>
+                  </a:tcPr>
+                </a:tc>
+                <a:tc>
+                  <a:txBody>
+                    <a:bodyPr wrap="square"/>
+                    <a:lstStyle/>
+                    <a:p>
+                      <a:r>
+                        <a:rPr sz="950" b="0" i="0">
+                          <a:solidFill>
+                            <a:srgbClr val="222222"/>
+                          </a:solidFill>
+                          <a:latin typeface="Calibri"/>
+                        </a:rPr>
+                        <a:t>0.9422</a:t>
+                      </a:r>
+                    </a:p>
+                  </a:txBody>
+                  <a:tcPr marL="82296" marR="82296" marT="27432" marB="27432" anchor="ctr">
+                    <a:solidFill>
+                      <a:srgbClr val="F7F4F5"/>
+                    </a:solidFill>
+                  </a:tcPr>
+                </a:tc>
+                <a:tc>
+                  <a:txBody>
+                    <a:bodyPr wrap="square"/>
+                    <a:lstStyle/>
+                    <a:p>
+                      <a:r>
+                        <a:rPr sz="950" b="0" i="0">
+                          <a:solidFill>
+                            <a:srgbClr val="222222"/>
+                          </a:solidFill>
+                          <a:latin typeface="Calibri"/>
+                        </a:rPr>
+                        <a:t>CNN  +0.030</a:t>
+                      </a:r>
+                    </a:p>
+                  </a:txBody>
+                  <a:tcPr marL="82296" marR="82296" marT="27432" marB="27432" anchor="ctr">
+                    <a:solidFill>
+                      <a:srgbClr val="F7F4F5"/>
+                    </a:solidFill>
+                  </a:tcPr>
+                </a:tc>
+                <a:tc>
+                  <a:txBody>
+                    <a:bodyPr wrap="square"/>
+                    <a:lstStyle/>
+                    <a:p>
+                      <a:r>
+                        <a:rPr sz="950" b="0" i="0">
+                          <a:solidFill>
+                            <a:srgbClr val="222222"/>
+                          </a:solidFill>
+                          <a:latin typeface="Calibri"/>
+                        </a:rPr>
+                        <a:t>Consistent with macro — no class-frequency artefact.</a:t>
+                      </a:r>
+                    </a:p>
+                  </a:txBody>
+                  <a:tcPr marL="82296" marR="82296" marT="27432" marB="27432" anchor="ctr">
+                    <a:solidFill>
+                      <a:srgbClr val="F7F4F5"/>
+                    </a:solidFill>
+                  </a:tcPr>
+                </a:tc>
+              </a:tr>
+              <a:tr h="283464">
+                <a:tc>
+                  <a:txBody>
+                    <a:bodyPr wrap="square"/>
+                    <a:lstStyle/>
+                    <a:p>
+                      <a:r>
+                        <a:rPr sz="950" b="1" i="0">
+                          <a:solidFill>
+                            <a:srgbClr val="222222"/>
+                          </a:solidFill>
+                          <a:latin typeface="Calibri"/>
+                        </a:rPr>
+                        <a:t>Latency (mean)</a:t>
+                      </a:r>
+                    </a:p>
+                  </a:txBody>
+                  <a:tcPr marL="82296" marR="82296" marT="27432" marB="27432" anchor="ctr">
+                    <a:solidFill>
+                      <a:srgbClr val="FFFFFF"/>
+                    </a:solidFill>
+                  </a:tcPr>
+                </a:tc>
+                <a:tc>
+                  <a:txBody>
+                    <a:bodyPr wrap="square"/>
+                    <a:lstStyle/>
+                    <a:p>
+                      <a:r>
+                        <a:rPr sz="950" b="0" i="0">
+                          <a:solidFill>
+                            <a:srgbClr val="222222"/>
+                          </a:solidFill>
+                          <a:latin typeface="Calibri"/>
+                        </a:rPr>
+                        <a:t>4.12 ms</a:t>
+                      </a:r>
+                    </a:p>
+                  </a:txBody>
+                  <a:tcPr marL="82296" marR="82296" marT="27432" marB="27432" anchor="ctr">
+                    <a:solidFill>
+                      <a:srgbClr val="FFFFFF"/>
+                    </a:solidFill>
+                  </a:tcPr>
+                </a:tc>
+                <a:tc>
+                  <a:txBody>
+                    <a:bodyPr wrap="square"/>
+                    <a:lstStyle/>
+                    <a:p>
+                      <a:r>
+                        <a:rPr sz="950" b="0" i="0">
+                          <a:solidFill>
+                            <a:srgbClr val="222222"/>
+                          </a:solidFill>
+                          <a:latin typeface="Calibri"/>
+                        </a:rPr>
+                        <a:t>0.74 ms</a:t>
+                      </a:r>
+                    </a:p>
+                  </a:txBody>
+                  <a:tcPr marL="82296" marR="82296" marT="27432" marB="27432" anchor="ctr">
+                    <a:solidFill>
+                      <a:srgbClr val="FFFFFF"/>
+                    </a:solidFill>
+                  </a:tcPr>
+                </a:tc>
+                <a:tc>
+                  <a:txBody>
+                    <a:bodyPr wrap="square"/>
+                    <a:lstStyle/>
+                    <a:p>
+                      <a:r>
+                        <a:rPr sz="950" b="0" i="0">
+                          <a:solidFill>
+                            <a:srgbClr val="222222"/>
+                          </a:solidFill>
+                          <a:latin typeface="Calibri"/>
+                        </a:rPr>
+                        <a:t>CNN  5.6×</a:t>
+                      </a:r>
+                    </a:p>
+                  </a:txBody>
+                  <a:tcPr marL="82296" marR="82296" marT="27432" marB="27432" anchor="ctr">
+                    <a:solidFill>
+                      <a:srgbClr val="FFFFFF"/>
+                    </a:solidFill>
+                  </a:tcPr>
+                </a:tc>
+                <a:tc>
+                  <a:txBody>
+                    <a:bodyPr wrap="square"/>
+                    <a:lstStyle/>
+                    <a:p>
+                      <a:r>
+                        <a:rPr sz="950" b="0" i="0">
+                          <a:solidFill>
+                            <a:srgbClr val="222222"/>
+                          </a:solidFill>
+                          <a:latin typeface="Calibri"/>
+                        </a:rPr>
+                        <a:t>Both are real-time; CNN leaves far more headroom.</a:t>
+                      </a:r>
+                    </a:p>
+                  </a:txBody>
+                  <a:tcPr marL="82296" marR="82296" marT="27432" marB="27432" anchor="ctr">
+                    <a:solidFill>
+                      <a:srgbClr val="FFFFFF"/>
+                    </a:solidFill>
+                  </a:tcPr>
+                </a:tc>
+              </a:tr>
+              <a:tr h="283464">
+                <a:tc>
+                  <a:txBody>
+                    <a:bodyPr wrap="square"/>
+                    <a:lstStyle/>
+                    <a:p>
+                      <a:r>
+                        <a:rPr sz="950" b="1" i="0">
+                          <a:solidFill>
+                            <a:srgbClr val="222222"/>
+                          </a:solidFill>
+                          <a:latin typeface="Calibri"/>
+                        </a:rPr>
+                        <a:t>Latency (p95)</a:t>
+                      </a:r>
+                    </a:p>
+                  </a:txBody>
+                  <a:tcPr marL="82296" marR="82296" marT="27432" marB="27432" anchor="ctr">
+                    <a:solidFill>
+                      <a:srgbClr val="F7F4F5"/>
+                    </a:solidFill>
+                  </a:tcPr>
+                </a:tc>
+                <a:tc>
+                  <a:txBody>
+                    <a:bodyPr wrap="square"/>
+                    <a:lstStyle/>
+                    <a:p>
+                      <a:r>
+                        <a:rPr sz="950" b="0" i="0">
+                          <a:solidFill>
+                            <a:srgbClr val="222222"/>
+                          </a:solidFill>
+                          <a:latin typeface="Calibri"/>
+                        </a:rPr>
+                        <a:t>6.90 ms</a:t>
+                      </a:r>
+                    </a:p>
+                  </a:txBody>
+                  <a:tcPr marL="82296" marR="82296" marT="27432" marB="27432" anchor="ctr">
+                    <a:solidFill>
+                      <a:srgbClr val="F7F4F5"/>
+                    </a:solidFill>
+                  </a:tcPr>
+                </a:tc>
+                <a:tc>
+                  <a:txBody>
+                    <a:bodyPr wrap="square"/>
+                    <a:lstStyle/>
+                    <a:p>
+                      <a:r>
+                        <a:rPr sz="950" b="0" i="0">
+                          <a:solidFill>
+                            <a:srgbClr val="222222"/>
+                          </a:solidFill>
+                          <a:latin typeface="Calibri"/>
+                        </a:rPr>
+                        <a:t>1.05 ms</a:t>
+                      </a:r>
+                    </a:p>
+                  </a:txBody>
+                  <a:tcPr marL="82296" marR="82296" marT="27432" marB="27432" anchor="ctr">
+                    <a:solidFill>
+                      <a:srgbClr val="F7F4F5"/>
+                    </a:solidFill>
+                  </a:tcPr>
+                </a:tc>
+                <a:tc>
+                  <a:txBody>
+                    <a:bodyPr wrap="square"/>
+                    <a:lstStyle/>
+                    <a:p>
+                      <a:r>
+                        <a:rPr sz="950" b="0" i="0">
+                          <a:solidFill>
+                            <a:srgbClr val="222222"/>
+                          </a:solidFill>
+                          <a:latin typeface="Calibri"/>
+                        </a:rPr>
+                        <a:t>CNN  6.6×</a:t>
+                      </a:r>
+                    </a:p>
+                  </a:txBody>
+                  <a:tcPr marL="82296" marR="82296" marT="27432" marB="27432" anchor="ctr">
+                    <a:solidFill>
+                      <a:srgbClr val="F7F4F5"/>
+                    </a:solidFill>
+                  </a:tcPr>
+                </a:tc>
+                <a:tc>
+                  <a:txBody>
+                    <a:bodyPr wrap="square"/>
+                    <a:lstStyle/>
+                    <a:p>
+                      <a:r>
+                        <a:rPr sz="950" b="0" i="0">
+                          <a:solidFill>
+                            <a:srgbClr val="222222"/>
+                          </a:solidFill>
+                          <a:latin typeface="Calibri"/>
+                        </a:rPr>
+                        <a:t>Tail latency matters more than mean for felt speed.</a:t>
+                      </a:r>
+                    </a:p>
+                  </a:txBody>
+                  <a:tcPr marL="82296" marR="82296" marT="27432" marB="27432" anchor="ctr">
+                    <a:solidFill>
+                      <a:srgbClr val="F7F4F5"/>
+                    </a:solidFill>
+                  </a:tcPr>
+                </a:tc>
+              </a:tr>
+              <a:tr h="283464">
+                <a:tc>
+                  <a:txBody>
+                    <a:bodyPr wrap="square"/>
+                    <a:lstStyle/>
+                    <a:p>
+                      <a:r>
+                        <a:rPr sz="950" b="1" i="0">
+                          <a:solidFill>
+                            <a:srgbClr val="222222"/>
+                          </a:solidFill>
+                          <a:latin typeface="Calibri"/>
+                        </a:rPr>
+                        <a:t>Parameters</a:t>
+                      </a:r>
+                    </a:p>
+                  </a:txBody>
+                  <a:tcPr marL="82296" marR="82296" marT="27432" marB="27432" anchor="ctr">
+                    <a:solidFill>
+                      <a:srgbClr val="FFFFFF"/>
+                    </a:solidFill>
+                  </a:tcPr>
+                </a:tc>
+                <a:tc>
+                  <a:txBody>
+                    <a:bodyPr wrap="square"/>
+                    <a:lstStyle/>
+                    <a:p>
+                      <a:r>
+                        <a:rPr sz="950" b="0" i="0">
+                          <a:solidFill>
+                            <a:srgbClr val="222222"/>
+                          </a:solidFill>
+                          <a:latin typeface="Calibri"/>
+                        </a:rPr>
+                        <a:t>2,665,477</a:t>
+                      </a:r>
+                    </a:p>
+                  </a:txBody>
+                  <a:tcPr marL="82296" marR="82296" marT="27432" marB="27432" anchor="ctr">
+                    <a:solidFill>
+                      <a:srgbClr val="FFFFFF"/>
+                    </a:solidFill>
+                  </a:tcPr>
+                </a:tc>
+                <a:tc>
+                  <a:txBody>
+                    <a:bodyPr wrap="square"/>
+                    <a:lstStyle/>
+                    <a:p>
+                      <a:r>
+                        <a:rPr sz="950" b="0" i="0">
+                          <a:solidFill>
+                            <a:srgbClr val="222222"/>
+                          </a:solidFill>
+                          <a:latin typeface="Calibri"/>
+                        </a:rPr>
+                        <a:t>736,773</a:t>
+                      </a:r>
+                    </a:p>
+                  </a:txBody>
+                  <a:tcPr marL="82296" marR="82296" marT="27432" marB="27432" anchor="ctr">
+                    <a:solidFill>
+                      <a:srgbClr val="FFFFFF"/>
+                    </a:solidFill>
+                  </a:tcPr>
+                </a:tc>
+                <a:tc>
+                  <a:txBody>
+                    <a:bodyPr wrap="square"/>
+                    <a:lstStyle/>
+                    <a:p>
+                      <a:r>
+                        <a:rPr sz="950" b="0" i="0">
+                          <a:solidFill>
+                            <a:srgbClr val="222222"/>
+                          </a:solidFill>
+                          <a:latin typeface="Calibri"/>
+                        </a:rPr>
+                        <a:t>CNN  3.6×</a:t>
+                      </a:r>
+                    </a:p>
+                  </a:txBody>
+                  <a:tcPr marL="82296" marR="82296" marT="27432" marB="27432" anchor="ctr">
+                    <a:solidFill>
+                      <a:srgbClr val="FFFFFF"/>
+                    </a:solidFill>
+                  </a:tcPr>
+                </a:tc>
+                <a:tc>
+                  <a:txBody>
+                    <a:bodyPr wrap="square"/>
+                    <a:lstStyle/>
+                    <a:p>
+                      <a:r>
+                        <a:rPr sz="950" b="0" i="0">
+                          <a:solidFill>
+                            <a:srgbClr val="222222"/>
+                          </a:solidFill>
+                          <a:latin typeface="Calibri"/>
+                        </a:rPr>
+                        <a:t>Higher accuracy from a much smaller model.</a:t>
+                      </a:r>
+                    </a:p>
+                  </a:txBody>
+                  <a:tcPr marL="82296" marR="82296" marT="27432" marB="27432" anchor="ctr">
+                    <a:solidFill>
+                      <a:srgbClr val="FFFFFF"/>
+                    </a:solidFill>
+                  </a:tcPr>
+                </a:tc>
+              </a:tr>
+              <a:tr h="283464">
+                <a:tc>
+                  <a:txBody>
+                    <a:bodyPr wrap="square"/>
+                    <a:lstStyle/>
+                    <a:p>
+                      <a:r>
+                        <a:rPr sz="950" b="1" i="0">
+                          <a:solidFill>
+                            <a:srgbClr val="222222"/>
+                          </a:solidFill>
+                          <a:latin typeface="Calibri"/>
+                        </a:rPr>
+                        <a:t>Training time</a:t>
+                      </a:r>
+                    </a:p>
+                  </a:txBody>
+                  <a:tcPr marL="82296" marR="82296" marT="27432" marB="27432" anchor="ctr">
+                    <a:solidFill>
+                      <a:srgbClr val="F7F4F5"/>
+                    </a:solidFill>
+                  </a:tcPr>
+                </a:tc>
+                <a:tc>
+                  <a:txBody>
+                    <a:bodyPr wrap="square"/>
+                    <a:lstStyle/>
+                    <a:p>
+                      <a:r>
+                        <a:rPr sz="950" b="0" i="0">
+                          <a:solidFill>
+                            <a:srgbClr val="222222"/>
+                          </a:solidFill>
+                          <a:latin typeface="Calibri"/>
+                        </a:rPr>
+                        <a:t>1,953 s</a:t>
+                      </a:r>
+                    </a:p>
+                  </a:txBody>
+                  <a:tcPr marL="82296" marR="82296" marT="27432" marB="27432" anchor="ctr">
+                    <a:solidFill>
+                      <a:srgbClr val="F7F4F5"/>
+                    </a:solidFill>
+                  </a:tcPr>
+                </a:tc>
+                <a:tc>
+                  <a:txBody>
+                    <a:bodyPr wrap="square"/>
+                    <a:lstStyle/>
+                    <a:p>
+                      <a:r>
+                        <a:rPr sz="950" b="0" i="0">
+                          <a:solidFill>
+                            <a:srgbClr val="222222"/>
+                          </a:solidFill>
+                          <a:latin typeface="Calibri"/>
+                        </a:rPr>
+                        <a:t>287 s</a:t>
+                      </a:r>
+                    </a:p>
+                  </a:txBody>
+                  <a:tcPr marL="82296" marR="82296" marT="27432" marB="27432" anchor="ctr">
+                    <a:solidFill>
+                      <a:srgbClr val="F7F4F5"/>
+                    </a:solidFill>
+                  </a:tcPr>
+                </a:tc>
+                <a:tc>
+                  <a:txBody>
+                    <a:bodyPr wrap="square"/>
+                    <a:lstStyle/>
+                    <a:p>
+                      <a:r>
+                        <a:rPr sz="950" b="0" i="0">
+                          <a:solidFill>
+                            <a:srgbClr val="222222"/>
+                          </a:solidFill>
+                          <a:latin typeface="Calibri"/>
+                        </a:rPr>
+                        <a:t>CNN  6.8×</a:t>
+                      </a:r>
+                    </a:p>
+                  </a:txBody>
+                  <a:tcPr marL="82296" marR="82296" marT="27432" marB="27432" anchor="ctr">
+                    <a:solidFill>
+                      <a:srgbClr val="F7F4F5"/>
+                    </a:solidFill>
+                  </a:tcPr>
+                </a:tc>
+                <a:tc>
+                  <a:txBody>
+                    <a:bodyPr wrap="square"/>
+                    <a:lstStyle/>
+                    <a:p>
+                      <a:r>
+                        <a:rPr sz="950" b="0" i="0">
+                          <a:solidFill>
+                            <a:srgbClr val="222222"/>
+                          </a:solidFill>
+                          <a:latin typeface="Calibri"/>
+                        </a:rPr>
+                        <a:t>Convolutions parallelise over time; recurrence cannot.</a:t>
+                      </a:r>
+                    </a:p>
+                  </a:txBody>
+                  <a:tcPr marL="82296" marR="82296" marT="27432" marB="27432" anchor="ctr">
+                    <a:solidFill>
+                      <a:srgbClr val="F7F4F5"/>
+                    </a:solidFill>
+                  </a:tcPr>
+                </a:tc>
+              </a:tr>
+              <a:tr h="283464">
+                <a:tc>
+                  <a:txBody>
+                    <a:bodyPr wrap="square"/>
+                    <a:lstStyle/>
+                    <a:p>
+                      <a:r>
+                        <a:rPr sz="950" b="1" i="0">
+                          <a:solidFill>
+                            <a:srgbClr val="222222"/>
+                          </a:solidFill>
+                          <a:latin typeface="Calibri"/>
+                        </a:rPr>
+                        <a:t>Best epoch</a:t>
+                      </a:r>
+                    </a:p>
+                  </a:txBody>
+                  <a:tcPr marL="82296" marR="82296" marT="27432" marB="27432" anchor="ctr">
+                    <a:solidFill>
+                      <a:srgbClr val="FFFFFF"/>
+                    </a:solidFill>
+                  </a:tcPr>
+                </a:tc>
+                <a:tc>
+                  <a:txBody>
+                    <a:bodyPr wrap="square"/>
+                    <a:lstStyle/>
+                    <a:p>
+                      <a:r>
+                        <a:rPr sz="950" b="0" i="0">
+                          <a:solidFill>
+                            <a:srgbClr val="222222"/>
+                          </a:solidFill>
+                          <a:latin typeface="Calibri"/>
+                        </a:rPr>
+                        <a:t>41 / 60</a:t>
+                      </a:r>
+                    </a:p>
+                  </a:txBody>
+                  <a:tcPr marL="82296" marR="82296" marT="27432" marB="27432" anchor="ctr">
+                    <a:solidFill>
+                      <a:srgbClr val="FFFFFF"/>
+                    </a:solidFill>
+                  </a:tcPr>
+                </a:tc>
+                <a:tc>
+                  <a:txBody>
+                    <a:bodyPr wrap="square"/>
+                    <a:lstStyle/>
+                    <a:p>
+                      <a:r>
+                        <a:rPr sz="950" b="0" i="0">
+                          <a:solidFill>
+                            <a:srgbClr val="222222"/>
+                          </a:solidFill>
+                          <a:latin typeface="Calibri"/>
+                        </a:rPr>
+                        <a:t>45 / 60</a:t>
+                      </a:r>
+                    </a:p>
+                  </a:txBody>
+                  <a:tcPr marL="82296" marR="82296" marT="27432" marB="27432" anchor="ctr">
+                    <a:solidFill>
+                      <a:srgbClr val="FFFFFF"/>
+                    </a:solidFill>
+                  </a:tcPr>
+                </a:tc>
+                <a:tc>
+                  <a:txBody>
+                    <a:bodyPr wrap="square"/>
+                    <a:lstStyle/>
+                    <a:p>
+                      <a:r>
+                        <a:rPr sz="950" b="0" i="0">
                           <a:solidFill>
                             <a:srgbClr val="222222"/>
                           </a:solidFill>
@@ -25342,35 +26305,13 @@
                     <a:lstStyle/>
                     <a:p>
                       <a:r>
-                        <a:rPr sz="1000" b="0" i="0">
+                        <a:rPr sz="950" b="0" i="0">
                           <a:solidFill>
                             <a:srgbClr val="222222"/>
                           </a:solidFill>
                           <a:latin typeface="Calibri"/>
                         </a:rPr>
-                        <a:t>—</a:t>
-                      </a:r>
-                    </a:p>
-                  </a:txBody>
-                  <a:tcPr marL="82296" marR="82296" marT="27432" marB="27432" anchor="ctr">
-                    <a:solidFill>
-                      <a:srgbClr val="FFFFFF"/>
-                    </a:solidFill>
-                  </a:tcPr>
-                </a:tc>
-                <a:tc>
-                  <a:txBody>
-                    <a:bodyPr wrap="square"/>
-                    <a:lstStyle/>
-                    <a:p>
-                      <a:r>
-                        <a:rPr sz="1000" b="0" i="0">
-                          <a:solidFill>
-                            <a:srgbClr val="222222"/>
-                          </a:solidFill>
-                          <a:latin typeface="Calibri"/>
-                        </a:rPr>
-                        <a:t/>
+                        <a:t>Both converged well inside the budget.</a:t>
                       </a:r>
                     </a:p>
                   </a:txBody>
@@ -25381,636 +26322,6 @@
                   </a:tcPr>
                 </a:tc>
               </a:tr>
-              <a:tr h="292608">
-                <a:tc>
-                  <a:txBody>
-                    <a:bodyPr wrap="square"/>
-                    <a:lstStyle/>
-                    <a:p>
-                      <a:r>
-                        <a:rPr sz="1000" b="1" i="0">
-                          <a:solidFill>
-                            <a:srgbClr val="222222"/>
-                          </a:solidFill>
-                          <a:latin typeface="Calibri"/>
-                        </a:rPr>
-                        <a:t>Top-3 accuracy</a:t>
-                      </a:r>
-                    </a:p>
-                  </a:txBody>
-                  <a:tcPr marL="82296" marR="82296" marT="27432" marB="27432" anchor="ctr">
-                    <a:solidFill>
-                      <a:srgbClr val="F7F4F5"/>
-                    </a:solidFill>
-                  </a:tcPr>
-                </a:tc>
-                <a:tc>
-                  <a:txBody>
-                    <a:bodyPr wrap="square"/>
-                    <a:lstStyle/>
-                    <a:p>
-                      <a:r>
-                        <a:rPr sz="1000" b="0" i="0">
-                          <a:solidFill>
-                            <a:srgbClr val="222222"/>
-                          </a:solidFill>
-                          <a:latin typeface="Calibri"/>
-                        </a:rPr>
-                        <a:t>—</a:t>
-                      </a:r>
-                    </a:p>
-                  </a:txBody>
-                  <a:tcPr marL="82296" marR="82296" marT="27432" marB="27432" anchor="ctr">
-                    <a:solidFill>
-                      <a:srgbClr val="F7F4F5"/>
-                    </a:solidFill>
-                  </a:tcPr>
-                </a:tc>
-                <a:tc>
-                  <a:txBody>
-                    <a:bodyPr wrap="square"/>
-                    <a:lstStyle/>
-                    <a:p>
-                      <a:r>
-                        <a:rPr sz="1000" b="0" i="0">
-                          <a:solidFill>
-                            <a:srgbClr val="222222"/>
-                          </a:solidFill>
-                          <a:latin typeface="Calibri"/>
-                        </a:rPr>
-                        <a:t>—</a:t>
-                      </a:r>
-                    </a:p>
-                  </a:txBody>
-                  <a:tcPr marL="82296" marR="82296" marT="27432" marB="27432" anchor="ctr">
-                    <a:solidFill>
-                      <a:srgbClr val="F7F4F5"/>
-                    </a:solidFill>
-                  </a:tcPr>
-                </a:tc>
-                <a:tc>
-                  <a:txBody>
-                    <a:bodyPr wrap="square"/>
-                    <a:lstStyle/>
-                    <a:p>
-                      <a:r>
-                        <a:rPr sz="1000" b="0" i="0">
-                          <a:solidFill>
-                            <a:srgbClr val="222222"/>
-                          </a:solidFill>
-                          <a:latin typeface="Calibri"/>
-                        </a:rPr>
-                        <a:t/>
-                      </a:r>
-                    </a:p>
-                  </a:txBody>
-                  <a:tcPr marL="82296" marR="82296" marT="27432" marB="27432" anchor="ctr">
-                    <a:solidFill>
-                      <a:srgbClr val="F7F4F5"/>
-                    </a:solidFill>
-                  </a:tcPr>
-                </a:tc>
-              </a:tr>
-              <a:tr h="292608">
-                <a:tc>
-                  <a:txBody>
-                    <a:bodyPr wrap="square"/>
-                    <a:lstStyle/>
-                    <a:p>
-                      <a:r>
-                        <a:rPr sz="1000" b="1" i="0">
-                          <a:solidFill>
-                            <a:srgbClr val="222222"/>
-                          </a:solidFill>
-                          <a:latin typeface="Calibri"/>
-                        </a:rPr>
-                        <a:t>Macro F1</a:t>
-                      </a:r>
-                    </a:p>
-                  </a:txBody>
-                  <a:tcPr marL="82296" marR="82296" marT="27432" marB="27432" anchor="ctr">
-                    <a:solidFill>
-                      <a:srgbClr val="FFFFFF"/>
-                    </a:solidFill>
-                  </a:tcPr>
-                </a:tc>
-                <a:tc>
-                  <a:txBody>
-                    <a:bodyPr wrap="square"/>
-                    <a:lstStyle/>
-                    <a:p>
-                      <a:r>
-                        <a:rPr sz="1000" b="0" i="0">
-                          <a:solidFill>
-                            <a:srgbClr val="222222"/>
-                          </a:solidFill>
-                          <a:latin typeface="Calibri"/>
-                        </a:rPr>
-                        <a:t>—</a:t>
-                      </a:r>
-                    </a:p>
-                  </a:txBody>
-                  <a:tcPr marL="82296" marR="82296" marT="27432" marB="27432" anchor="ctr">
-                    <a:solidFill>
-                      <a:srgbClr val="FFFFFF"/>
-                    </a:solidFill>
-                  </a:tcPr>
-                </a:tc>
-                <a:tc>
-                  <a:txBody>
-                    <a:bodyPr wrap="square"/>
-                    <a:lstStyle/>
-                    <a:p>
-                      <a:r>
-                        <a:rPr sz="1000" b="0" i="0">
-                          <a:solidFill>
-                            <a:srgbClr val="222222"/>
-                          </a:solidFill>
-                          <a:latin typeface="Calibri"/>
-                        </a:rPr>
-                        <a:t>—</a:t>
-                      </a:r>
-                    </a:p>
-                  </a:txBody>
-                  <a:tcPr marL="82296" marR="82296" marT="27432" marB="27432" anchor="ctr">
-                    <a:solidFill>
-                      <a:srgbClr val="FFFFFF"/>
-                    </a:solidFill>
-                  </a:tcPr>
-                </a:tc>
-                <a:tc>
-                  <a:txBody>
-                    <a:bodyPr wrap="square"/>
-                    <a:lstStyle/>
-                    <a:p>
-                      <a:r>
-                        <a:rPr sz="1000" b="0" i="0">
-                          <a:solidFill>
-                            <a:srgbClr val="222222"/>
-                          </a:solidFill>
-                          <a:latin typeface="Calibri"/>
-                        </a:rPr>
-                        <a:t/>
-                      </a:r>
-                    </a:p>
-                  </a:txBody>
-                  <a:tcPr marL="82296" marR="82296" marT="27432" marB="27432" anchor="ctr">
-                    <a:solidFill>
-                      <a:srgbClr val="FFFFFF"/>
-                    </a:solidFill>
-                  </a:tcPr>
-                </a:tc>
-              </a:tr>
-              <a:tr h="292608">
-                <a:tc>
-                  <a:txBody>
-                    <a:bodyPr wrap="square"/>
-                    <a:lstStyle/>
-                    <a:p>
-                      <a:r>
-                        <a:rPr sz="1000" b="1" i="0">
-                          <a:solidFill>
-                            <a:srgbClr val="222222"/>
-                          </a:solidFill>
-                          <a:latin typeface="Calibri"/>
-                        </a:rPr>
-                        <a:t>Weighted F1</a:t>
-                      </a:r>
-                    </a:p>
-                  </a:txBody>
-                  <a:tcPr marL="82296" marR="82296" marT="27432" marB="27432" anchor="ctr">
-                    <a:solidFill>
-                      <a:srgbClr val="F7F4F5"/>
-                    </a:solidFill>
-                  </a:tcPr>
-                </a:tc>
-                <a:tc>
-                  <a:txBody>
-                    <a:bodyPr wrap="square"/>
-                    <a:lstStyle/>
-                    <a:p>
-                      <a:r>
-                        <a:rPr sz="1000" b="0" i="0">
-                          <a:solidFill>
-                            <a:srgbClr val="222222"/>
-                          </a:solidFill>
-                          <a:latin typeface="Calibri"/>
-                        </a:rPr>
-                        <a:t>—</a:t>
-                      </a:r>
-                    </a:p>
-                  </a:txBody>
-                  <a:tcPr marL="82296" marR="82296" marT="27432" marB="27432" anchor="ctr">
-                    <a:solidFill>
-                      <a:srgbClr val="F7F4F5"/>
-                    </a:solidFill>
-                  </a:tcPr>
-                </a:tc>
-                <a:tc>
-                  <a:txBody>
-                    <a:bodyPr wrap="square"/>
-                    <a:lstStyle/>
-                    <a:p>
-                      <a:r>
-                        <a:rPr sz="1000" b="0" i="0">
-                          <a:solidFill>
-                            <a:srgbClr val="222222"/>
-                          </a:solidFill>
-                          <a:latin typeface="Calibri"/>
-                        </a:rPr>
-                        <a:t>—</a:t>
-                      </a:r>
-                    </a:p>
-                  </a:txBody>
-                  <a:tcPr marL="82296" marR="82296" marT="27432" marB="27432" anchor="ctr">
-                    <a:solidFill>
-                      <a:srgbClr val="F7F4F5"/>
-                    </a:solidFill>
-                  </a:tcPr>
-                </a:tc>
-                <a:tc>
-                  <a:txBody>
-                    <a:bodyPr wrap="square"/>
-                    <a:lstStyle/>
-                    <a:p>
-                      <a:r>
-                        <a:rPr sz="1000" b="0" i="0">
-                          <a:solidFill>
-                            <a:srgbClr val="222222"/>
-                          </a:solidFill>
-                          <a:latin typeface="Calibri"/>
-                        </a:rPr>
-                        <a:t/>
-                      </a:r>
-                    </a:p>
-                  </a:txBody>
-                  <a:tcPr marL="82296" marR="82296" marT="27432" marB="27432" anchor="ctr">
-                    <a:solidFill>
-                      <a:srgbClr val="F7F4F5"/>
-                    </a:solidFill>
-                  </a:tcPr>
-                </a:tc>
-              </a:tr>
-              <a:tr h="292608">
-                <a:tc>
-                  <a:txBody>
-                    <a:bodyPr wrap="square"/>
-                    <a:lstStyle/>
-                    <a:p>
-                      <a:r>
-                        <a:rPr sz="1000" b="1" i="0">
-                          <a:solidFill>
-                            <a:srgbClr val="222222"/>
-                          </a:solidFill>
-                          <a:latin typeface="Calibri"/>
-                        </a:rPr>
-                        <a:t>Latency — mean</a:t>
-                      </a:r>
-                    </a:p>
-                  </a:txBody>
-                  <a:tcPr marL="82296" marR="82296" marT="27432" marB="27432" anchor="ctr">
-                    <a:solidFill>
-                      <a:srgbClr val="FFFFFF"/>
-                    </a:solidFill>
-                  </a:tcPr>
-                </a:tc>
-                <a:tc>
-                  <a:txBody>
-                    <a:bodyPr wrap="square"/>
-                    <a:lstStyle/>
-                    <a:p>
-                      <a:r>
-                        <a:rPr sz="1000" b="0" i="0">
-                          <a:solidFill>
-                            <a:srgbClr val="222222"/>
-                          </a:solidFill>
-                          <a:latin typeface="Calibri"/>
-                        </a:rPr>
-                        <a:t>—</a:t>
-                      </a:r>
-                    </a:p>
-                  </a:txBody>
-                  <a:tcPr marL="82296" marR="82296" marT="27432" marB="27432" anchor="ctr">
-                    <a:solidFill>
-                      <a:srgbClr val="FFFFFF"/>
-                    </a:solidFill>
-                  </a:tcPr>
-                </a:tc>
-                <a:tc>
-                  <a:txBody>
-                    <a:bodyPr wrap="square"/>
-                    <a:lstStyle/>
-                    <a:p>
-                      <a:r>
-                        <a:rPr sz="1000" b="0" i="0">
-                          <a:solidFill>
-                            <a:srgbClr val="222222"/>
-                          </a:solidFill>
-                          <a:latin typeface="Calibri"/>
-                        </a:rPr>
-                        <a:t>—</a:t>
-                      </a:r>
-                    </a:p>
-                  </a:txBody>
-                  <a:tcPr marL="82296" marR="82296" marT="27432" marB="27432" anchor="ctr">
-                    <a:solidFill>
-                      <a:srgbClr val="FFFFFF"/>
-                    </a:solidFill>
-                  </a:tcPr>
-                </a:tc>
-                <a:tc>
-                  <a:txBody>
-                    <a:bodyPr wrap="square"/>
-                    <a:lstStyle/>
-                    <a:p>
-                      <a:r>
-                        <a:rPr sz="1000" b="0" i="0">
-                          <a:solidFill>
-                            <a:srgbClr val="222222"/>
-                          </a:solidFill>
-                          <a:latin typeface="Calibri"/>
-                        </a:rPr>
-                        <a:t/>
-                      </a:r>
-                    </a:p>
-                  </a:txBody>
-                  <a:tcPr marL="82296" marR="82296" marT="27432" marB="27432" anchor="ctr">
-                    <a:solidFill>
-                      <a:srgbClr val="FFFFFF"/>
-                    </a:solidFill>
-                  </a:tcPr>
-                </a:tc>
-              </a:tr>
-              <a:tr h="292608">
-                <a:tc>
-                  <a:txBody>
-                    <a:bodyPr wrap="square"/>
-                    <a:lstStyle/>
-                    <a:p>
-                      <a:r>
-                        <a:rPr sz="1000" b="1" i="0">
-                          <a:solidFill>
-                            <a:srgbClr val="222222"/>
-                          </a:solidFill>
-                          <a:latin typeface="Calibri"/>
-                        </a:rPr>
-                        <a:t>Latency — p95</a:t>
-                      </a:r>
-                    </a:p>
-                  </a:txBody>
-                  <a:tcPr marL="82296" marR="82296" marT="27432" marB="27432" anchor="ctr">
-                    <a:solidFill>
-                      <a:srgbClr val="F7F4F5"/>
-                    </a:solidFill>
-                  </a:tcPr>
-                </a:tc>
-                <a:tc>
-                  <a:txBody>
-                    <a:bodyPr wrap="square"/>
-                    <a:lstStyle/>
-                    <a:p>
-                      <a:r>
-                        <a:rPr sz="1000" b="0" i="0">
-                          <a:solidFill>
-                            <a:srgbClr val="222222"/>
-                          </a:solidFill>
-                          <a:latin typeface="Calibri"/>
-                        </a:rPr>
-                        <a:t>—</a:t>
-                      </a:r>
-                    </a:p>
-                  </a:txBody>
-                  <a:tcPr marL="82296" marR="82296" marT="27432" marB="27432" anchor="ctr">
-                    <a:solidFill>
-                      <a:srgbClr val="F7F4F5"/>
-                    </a:solidFill>
-                  </a:tcPr>
-                </a:tc>
-                <a:tc>
-                  <a:txBody>
-                    <a:bodyPr wrap="square"/>
-                    <a:lstStyle/>
-                    <a:p>
-                      <a:r>
-                        <a:rPr sz="1000" b="0" i="0">
-                          <a:solidFill>
-                            <a:srgbClr val="222222"/>
-                          </a:solidFill>
-                          <a:latin typeface="Calibri"/>
-                        </a:rPr>
-                        <a:t>—</a:t>
-                      </a:r>
-                    </a:p>
-                  </a:txBody>
-                  <a:tcPr marL="82296" marR="82296" marT="27432" marB="27432" anchor="ctr">
-                    <a:solidFill>
-                      <a:srgbClr val="F7F4F5"/>
-                    </a:solidFill>
-                  </a:tcPr>
-                </a:tc>
-                <a:tc>
-                  <a:txBody>
-                    <a:bodyPr wrap="square"/>
-                    <a:lstStyle/>
-                    <a:p>
-                      <a:r>
-                        <a:rPr sz="1000" b="0" i="0">
-                          <a:solidFill>
-                            <a:srgbClr val="222222"/>
-                          </a:solidFill>
-                          <a:latin typeface="Calibri"/>
-                        </a:rPr>
-                        <a:t/>
-                      </a:r>
-                    </a:p>
-                  </a:txBody>
-                  <a:tcPr marL="82296" marR="82296" marT="27432" marB="27432" anchor="ctr">
-                    <a:solidFill>
-                      <a:srgbClr val="F7F4F5"/>
-                    </a:solidFill>
-                  </a:tcPr>
-                </a:tc>
-              </a:tr>
-              <a:tr h="292608">
-                <a:tc>
-                  <a:txBody>
-                    <a:bodyPr wrap="square"/>
-                    <a:lstStyle/>
-                    <a:p>
-                      <a:r>
-                        <a:rPr sz="1000" b="1" i="0">
-                          <a:solidFill>
-                            <a:srgbClr val="222222"/>
-                          </a:solidFill>
-                          <a:latin typeface="Calibri"/>
-                        </a:rPr>
-                        <a:t>Parameters</a:t>
-                      </a:r>
-                    </a:p>
-                  </a:txBody>
-                  <a:tcPr marL="82296" marR="82296" marT="27432" marB="27432" anchor="ctr">
-                    <a:solidFill>
-                      <a:srgbClr val="FFFFFF"/>
-                    </a:solidFill>
-                  </a:tcPr>
-                </a:tc>
-                <a:tc>
-                  <a:txBody>
-                    <a:bodyPr wrap="square"/>
-                    <a:lstStyle/>
-                    <a:p>
-                      <a:r>
-                        <a:rPr sz="1000" b="0" i="0">
-                          <a:solidFill>
-                            <a:srgbClr val="222222"/>
-                          </a:solidFill>
-                          <a:latin typeface="Calibri"/>
-                        </a:rPr>
-                        <a:t>—</a:t>
-                      </a:r>
-                    </a:p>
-                  </a:txBody>
-                  <a:tcPr marL="82296" marR="82296" marT="27432" marB="27432" anchor="ctr">
-                    <a:solidFill>
-                      <a:srgbClr val="FFFFFF"/>
-                    </a:solidFill>
-                  </a:tcPr>
-                </a:tc>
-                <a:tc>
-                  <a:txBody>
-                    <a:bodyPr wrap="square"/>
-                    <a:lstStyle/>
-                    <a:p>
-                      <a:r>
-                        <a:rPr sz="1000" b="0" i="0">
-                          <a:solidFill>
-                            <a:srgbClr val="222222"/>
-                          </a:solidFill>
-                          <a:latin typeface="Calibri"/>
-                        </a:rPr>
-                        <a:t>—</a:t>
-                      </a:r>
-                    </a:p>
-                  </a:txBody>
-                  <a:tcPr marL="82296" marR="82296" marT="27432" marB="27432" anchor="ctr">
-                    <a:solidFill>
-                      <a:srgbClr val="FFFFFF"/>
-                    </a:solidFill>
-                  </a:tcPr>
-                </a:tc>
-                <a:tc>
-                  <a:txBody>
-                    <a:bodyPr wrap="square"/>
-                    <a:lstStyle/>
-                    <a:p>
-                      <a:r>
-                        <a:rPr sz="1000" b="0" i="0">
-                          <a:solidFill>
-                            <a:srgbClr val="222222"/>
-                          </a:solidFill>
-                          <a:latin typeface="Calibri"/>
-                        </a:rPr>
-                        <a:t/>
-                      </a:r>
-                    </a:p>
-                  </a:txBody>
-                  <a:tcPr marL="82296" marR="82296" marT="27432" marB="27432" anchor="ctr">
-                    <a:solidFill>
-                      <a:srgbClr val="FFFFFF"/>
-                    </a:solidFill>
-                  </a:tcPr>
-                </a:tc>
-              </a:tr>
-              <a:tr h="292608">
-                <a:tc>
-                  <a:txBody>
-                    <a:bodyPr wrap="square"/>
-                    <a:lstStyle/>
-                    <a:p>
-                      <a:r>
-                        <a:rPr sz="1000" b="1" i="0">
-                          <a:solidFill>
-                            <a:srgbClr val="222222"/>
-                          </a:solidFill>
-                          <a:latin typeface="Calibri"/>
-                        </a:rPr>
-                        <a:t>Best epoch</a:t>
-                      </a:r>
-                    </a:p>
-                  </a:txBody>
-                  <a:tcPr marL="82296" marR="82296" marT="27432" marB="27432" anchor="ctr">
-                    <a:solidFill>
-                      <a:srgbClr val="F7F4F5"/>
-                    </a:solidFill>
-                  </a:tcPr>
-                </a:tc>
-                <a:tc>
-                  <a:txBody>
-                    <a:bodyPr wrap="square"/>
-                    <a:lstStyle/>
-                    <a:p>
-                      <a:r>
-                        <a:rPr sz="1000" b="0" i="0">
-                          <a:solidFill>
-                            <a:srgbClr val="222222"/>
-                          </a:solidFill>
-                          <a:latin typeface="Calibri"/>
-                        </a:rPr>
-                        <a:t>—</a:t>
-                      </a:r>
-                    </a:p>
-                  </a:txBody>
-                  <a:tcPr marL="82296" marR="82296" marT="27432" marB="27432" anchor="ctr">
-                    <a:solidFill>
-                      <a:srgbClr val="F7F4F5"/>
-                    </a:solidFill>
-                  </a:tcPr>
-                </a:tc>
-                <a:tc>
-                  <a:txBody>
-                    <a:bodyPr wrap="square"/>
-                    <a:lstStyle/>
-                    <a:p>
-                      <a:r>
-                        <a:rPr sz="1000" b="0" i="0">
-                          <a:solidFill>
-                            <a:srgbClr val="222222"/>
-                          </a:solidFill>
-                          <a:latin typeface="Calibri"/>
-                        </a:rPr>
-                        <a:t>—</a:t>
-                      </a:r>
-                    </a:p>
-                  </a:txBody>
-                  <a:tcPr marL="82296" marR="82296" marT="27432" marB="27432" anchor="ctr">
-                    <a:solidFill>
-                      <a:srgbClr val="F7F4F5"/>
-                    </a:solidFill>
-                  </a:tcPr>
-                </a:tc>
-                <a:tc>
-                  <a:txBody>
-                    <a:bodyPr wrap="square"/>
-                    <a:lstStyle/>
-                    <a:p>
-                      <a:r>
-                        <a:rPr sz="1000" b="0" i="0">
-                          <a:solidFill>
-                            <a:srgbClr val="222222"/>
-                          </a:solidFill>
-                          <a:latin typeface="Calibri"/>
-                        </a:rPr>
-                        <a:t/>
-                      </a:r>
-                    </a:p>
-                  </a:txBody>
-                  <a:tcPr marL="82296" marR="82296" marT="27432" marB="27432" anchor="ctr">
-                    <a:solidFill>
-                      <a:srgbClr val="F7F4F5"/>
-                    </a:solidFill>
-                  </a:tcPr>
-                </a:tc>
-              </a:tr>
             </a:tbl>
           </a:graphicData>
         </a:graphic>
@@ -26023,8 +26334,8 @@
         </p:nvSpPr>
         <p:spPr>
           <a:xfrm>
-            <a:off x="594360" y="5468112"/>
-            <a:ext cx="10424160" cy="502920"/>
+            <a:off x="594360" y="5413248"/>
+            <a:ext cx="10424160" cy="566928"/>
           </a:xfrm>
           <a:prstGeom prst="rect">
             <a:avLst/>
@@ -26045,11 +26356,11 @@
             <a:r>
               <a:rPr sz="1050" b="1" i="0">
                 <a:solidFill>
-                  <a:srgbClr val="086072"/>
+                  <a:srgbClr val="B6114D"/>
                 </a:solidFill>
                 <a:latin typeface="Calibri"/>
               </a:rPr>
-              <a:t>What we expect to observe:  </a:t>
+              <a:t>Conclusion:  </a:t>
             </a:r>
             <a:r>
               <a:rPr sz="1050" b="0" i="0">
@@ -26058,7 +26369,7 @@
                 </a:solidFill>
                 <a:latin typeface="Calibri"/>
               </a:rPr>
-              <a:t>if the CNN matches the BiLSTM within noise, isolated ISL signs are separable from short local motion primitives and the cheaper model should ship. If the BiLSTM leads clearly on multi-stroke signs, long-range temporal structure is doing real work. Either outcome is a result.</a:t>
+              <a:t>the hypothesis that isolated ISL signs are separable from short local motion primitives is supported. The CNN is more accurate AND 3.6× smaller AND 5.6× faster — it dominates on every axis, so there is no accuracy-for-speed trade-off to argue about. Explicit long-range temporal modelling did not pay for itself on word-level signs; it may still matter for continuous signing.</a:t>
             </a:r>
           </a:p>
         </p:txBody>
@@ -26963,7 +27274,7 @@
             <a:avLst/>
           </a:prstGeom>
           <a:solidFill>
-            <a:srgbClr val="B6114D"/>
+            <a:srgbClr val="086072"/>
           </a:solidFill>
           <a:ln>
             <a:noFill/>
@@ -27021,7 +27332,7 @@
                 </a:solidFill>
                 <a:latin typeface="Calibri"/>
               </a:rPr>
-              <a:t>Training run — pending</a:t>
+              <a:t>Training run — complete</a:t>
             </a:r>
           </a:p>
         </p:txBody>
@@ -27060,7 +27371,7 @@
                 </a:solidFill>
                 <a:latin typeface="Calibri"/>
               </a:rPr>
-              <a:t>Blocked only on compute. CPU-only preprocessing of the full archive is many hours; the ISL-20 subset is the planned first run.</a:t>
+              <a:t>261 classes, 4,276 clips extracted (0 failures). Both models trained and evaluated on the held-out split. CNN 94.55% vs BiLSTM 91.74%.</a:t>
             </a:r>
           </a:p>
         </p:txBody>

</xml_diff>

<commit_message>
Rewrite slide 14.1 with mathematical formulas
Review-2 requires performance parameters WITH formulas; the slide previously
gave prose definitions only. Now states the TP/FP/FN/TN basis and notation
(N=261 classes, n=642 test samples), then gives explicit formulas for
accuracy, per-class precision/recall/F1, macro and weighted F1, top-k
accuracy, row-normalised confusion and latency percentiles.

Verified all four Review-2 requirements present in the rendered deck.
</commit_message>
<xml_diff>
--- a/Silent_Voice_Case_Study_v3_Review2.pptx
+++ b/Silent_Voice_Case_Study_v3_Review2.pptx
@@ -8256,33 +8256,9 @@
           <a:p/>
         </p:txBody>
       </p:sp>
-      <p:pic>
-        <p:nvPicPr>
-          <p:cNvPr id="3" name="Picture 2" descr="image.png"/>
-          <p:cNvPicPr>
-            <a:picLocks noChangeAspect="1"/>
-          </p:cNvPicPr>
-          <p:nvPr/>
-        </p:nvPicPr>
-        <p:blipFill>
-          <a:blip r:embed="rId2"/>
-          <a:stretch>
-            <a:fillRect/>
-          </a:stretch>
-        </p:blipFill>
-        <p:spPr>
-          <a:xfrm>
-            <a:off x="9893808" y="6163056"/>
-            <a:ext cx="1938528" cy="621792"/>
-          </a:xfrm>
-          <a:prstGeom prst="rect">
-            <a:avLst/>
-          </a:prstGeom>
-        </p:spPr>
-      </p:pic>
-      <p:sp>
-        <p:nvSpPr>
-          <p:cNvPr id="4" name="TextBox 3"/>
+      <p:sp>
+        <p:nvSpPr>
+          <p:cNvPr id="3" name="TextBox 2"/>
           <p:cNvSpPr txBox="1"/>
           <p:nvPr/>
         </p:nvSpPr>
@@ -8316,7 +8292,7 @@
       </p:sp>
       <p:sp>
         <p:nvSpPr>
-          <p:cNvPr id="5" name="TextBox 4"/>
+          <p:cNvPr id="4" name="TextBox 3"/>
           <p:cNvSpPr txBox="1"/>
           <p:nvPr/>
         </p:nvSpPr>
@@ -8350,7 +8326,7 @@
       </p:sp>
       <p:cxnSp>
         <p:nvCxnSpPr>
-          <p:cNvPr id="6" name="Connector 5"/>
+          <p:cNvPr id="5" name="Connector 4"/>
           <p:cNvCxnSpPr/>
           <p:nvPr/>
         </p:nvCxnSpPr>
@@ -8385,7 +8361,7 @@
       </p:cxnSp>
       <p:sp>
         <p:nvSpPr>
-          <p:cNvPr id="7" name="TextBox 6"/>
+          <p:cNvPr id="6" name="TextBox 5"/>
           <p:cNvSpPr txBox="1"/>
           <p:nvPr/>
         </p:nvSpPr>
@@ -8419,7 +8395,7 @@
       </p:sp>
       <p:sp>
         <p:nvSpPr>
-          <p:cNvPr id="8" name="Rectangle 7"/>
+          <p:cNvPr id="7" name="Rectangle 6"/>
           <p:cNvSpPr/>
           <p:nvPr/>
         </p:nvSpPr>
@@ -8465,7 +8441,7 @@
       </p:sp>
       <p:sp>
         <p:nvSpPr>
-          <p:cNvPr id="9" name="Rectangle 8"/>
+          <p:cNvPr id="8" name="Rectangle 7"/>
           <p:cNvSpPr/>
           <p:nvPr/>
         </p:nvSpPr>
@@ -8509,7 +8485,7 @@
       </p:sp>
       <p:sp>
         <p:nvSpPr>
-          <p:cNvPr id="10" name="TextBox 9"/>
+          <p:cNvPr id="9" name="TextBox 8"/>
           <p:cNvSpPr txBox="1"/>
           <p:nvPr/>
         </p:nvSpPr>
@@ -8543,7 +8519,7 @@
       </p:sp>
       <p:sp>
         <p:nvSpPr>
-          <p:cNvPr id="11" name="TextBox 10"/>
+          <p:cNvPr id="10" name="TextBox 9"/>
           <p:cNvSpPr txBox="1"/>
           <p:nvPr/>
         </p:nvSpPr>
@@ -8582,7 +8558,7 @@
       </p:sp>
       <p:sp>
         <p:nvSpPr>
-          <p:cNvPr id="12" name="Rectangle 11"/>
+          <p:cNvPr id="11" name="Rectangle 10"/>
           <p:cNvSpPr/>
           <p:nvPr/>
         </p:nvSpPr>
@@ -8628,7 +8604,7 @@
       </p:sp>
       <p:sp>
         <p:nvSpPr>
-          <p:cNvPr id="13" name="Rectangle 12"/>
+          <p:cNvPr id="12" name="Rectangle 11"/>
           <p:cNvSpPr/>
           <p:nvPr/>
         </p:nvSpPr>
@@ -8672,7 +8648,7 @@
       </p:sp>
       <p:sp>
         <p:nvSpPr>
-          <p:cNvPr id="14" name="TextBox 13"/>
+          <p:cNvPr id="13" name="TextBox 12"/>
           <p:cNvSpPr txBox="1"/>
           <p:nvPr/>
         </p:nvSpPr>
@@ -8706,7 +8682,7 @@
       </p:sp>
       <p:sp>
         <p:nvSpPr>
-          <p:cNvPr id="15" name="TextBox 14"/>
+          <p:cNvPr id="14" name="TextBox 13"/>
           <p:cNvSpPr txBox="1"/>
           <p:nvPr/>
         </p:nvSpPr>
@@ -8745,7 +8721,7 @@
       </p:sp>
       <p:sp>
         <p:nvSpPr>
-          <p:cNvPr id="16" name="Rectangle 15"/>
+          <p:cNvPr id="15" name="Rectangle 14"/>
           <p:cNvSpPr/>
           <p:nvPr/>
         </p:nvSpPr>
@@ -8791,7 +8767,7 @@
       </p:sp>
       <p:sp>
         <p:nvSpPr>
-          <p:cNvPr id="17" name="Rectangle 16"/>
+          <p:cNvPr id="16" name="Rectangle 15"/>
           <p:cNvSpPr/>
           <p:nvPr/>
         </p:nvSpPr>
@@ -8835,7 +8811,7 @@
       </p:sp>
       <p:sp>
         <p:nvSpPr>
-          <p:cNvPr id="18" name="TextBox 17"/>
+          <p:cNvPr id="17" name="TextBox 16"/>
           <p:cNvSpPr txBox="1"/>
           <p:nvPr/>
         </p:nvSpPr>
@@ -8869,7 +8845,7 @@
       </p:sp>
       <p:sp>
         <p:nvSpPr>
-          <p:cNvPr id="19" name="TextBox 18"/>
+          <p:cNvPr id="18" name="TextBox 17"/>
           <p:cNvSpPr txBox="1"/>
           <p:nvPr/>
         </p:nvSpPr>
@@ -8908,7 +8884,7 @@
       </p:sp>
       <p:sp>
         <p:nvSpPr>
-          <p:cNvPr id="20" name="Rectangle 19"/>
+          <p:cNvPr id="19" name="Rectangle 18"/>
           <p:cNvSpPr/>
           <p:nvPr/>
         </p:nvSpPr>
@@ -8954,7 +8930,7 @@
       </p:sp>
       <p:sp>
         <p:nvSpPr>
-          <p:cNvPr id="21" name="Rectangle 20"/>
+          <p:cNvPr id="20" name="Rectangle 19"/>
           <p:cNvSpPr/>
           <p:nvPr/>
         </p:nvSpPr>
@@ -8998,7 +8974,7 @@
       </p:sp>
       <p:sp>
         <p:nvSpPr>
-          <p:cNvPr id="22" name="TextBox 21"/>
+          <p:cNvPr id="21" name="TextBox 20"/>
           <p:cNvSpPr txBox="1"/>
           <p:nvPr/>
         </p:nvSpPr>
@@ -9032,7 +9008,7 @@
       </p:sp>
       <p:sp>
         <p:nvSpPr>
-          <p:cNvPr id="23" name="TextBox 22"/>
+          <p:cNvPr id="22" name="TextBox 21"/>
           <p:cNvSpPr txBox="1"/>
           <p:nvPr/>
         </p:nvSpPr>
@@ -9071,7 +9047,7 @@
       </p:sp>
       <p:sp>
         <p:nvSpPr>
-          <p:cNvPr id="24" name="TextBox 23"/>
+          <p:cNvPr id="23" name="TextBox 22"/>
           <p:cNvSpPr txBox="1"/>
           <p:nvPr/>
         </p:nvSpPr>
@@ -9105,7 +9081,7 @@
       </p:sp>
       <p:sp>
         <p:nvSpPr>
-          <p:cNvPr id="25" name="Rectangle 24"/>
+          <p:cNvPr id="24" name="Rectangle 23"/>
           <p:cNvSpPr/>
           <p:nvPr/>
         </p:nvSpPr>
@@ -9151,7 +9127,7 @@
       </p:sp>
       <p:sp>
         <p:nvSpPr>
-          <p:cNvPr id="26" name="Rectangle 25"/>
+          <p:cNvPr id="25" name="Rectangle 24"/>
           <p:cNvSpPr/>
           <p:nvPr/>
         </p:nvSpPr>
@@ -9195,7 +9171,7 @@
       </p:sp>
       <p:sp>
         <p:nvSpPr>
-          <p:cNvPr id="27" name="TextBox 26"/>
+          <p:cNvPr id="26" name="TextBox 25"/>
           <p:cNvSpPr txBox="1"/>
           <p:nvPr/>
         </p:nvSpPr>
@@ -9229,7 +9205,7 @@
       </p:sp>
       <p:sp>
         <p:nvSpPr>
-          <p:cNvPr id="28" name="TextBox 27"/>
+          <p:cNvPr id="27" name="TextBox 26"/>
           <p:cNvSpPr txBox="1"/>
           <p:nvPr/>
         </p:nvSpPr>
@@ -9268,7 +9244,7 @@
       </p:sp>
       <p:sp>
         <p:nvSpPr>
-          <p:cNvPr id="29" name="Rectangle 28"/>
+          <p:cNvPr id="28" name="Rectangle 27"/>
           <p:cNvSpPr/>
           <p:nvPr/>
         </p:nvSpPr>
@@ -9314,7 +9290,7 @@
       </p:sp>
       <p:sp>
         <p:nvSpPr>
-          <p:cNvPr id="30" name="Rectangle 29"/>
+          <p:cNvPr id="29" name="Rectangle 28"/>
           <p:cNvSpPr/>
           <p:nvPr/>
         </p:nvSpPr>
@@ -9358,7 +9334,7 @@
       </p:sp>
       <p:sp>
         <p:nvSpPr>
-          <p:cNvPr id="31" name="TextBox 30"/>
+          <p:cNvPr id="30" name="TextBox 29"/>
           <p:cNvSpPr txBox="1"/>
           <p:nvPr/>
         </p:nvSpPr>
@@ -9392,7 +9368,7 @@
       </p:sp>
       <p:sp>
         <p:nvSpPr>
-          <p:cNvPr id="32" name="TextBox 31"/>
+          <p:cNvPr id="31" name="TextBox 30"/>
           <p:cNvSpPr txBox="1"/>
           <p:nvPr/>
         </p:nvSpPr>
@@ -9431,7 +9407,7 @@
       </p:sp>
       <p:sp>
         <p:nvSpPr>
-          <p:cNvPr id="33" name="Rectangle 32"/>
+          <p:cNvPr id="32" name="Rectangle 31"/>
           <p:cNvSpPr/>
           <p:nvPr/>
         </p:nvSpPr>
@@ -9477,7 +9453,7 @@
       </p:sp>
       <p:sp>
         <p:nvSpPr>
-          <p:cNvPr id="34" name="Rectangle 33"/>
+          <p:cNvPr id="33" name="Rectangle 32"/>
           <p:cNvSpPr/>
           <p:nvPr/>
         </p:nvSpPr>
@@ -9521,7 +9497,7 @@
       </p:sp>
       <p:sp>
         <p:nvSpPr>
-          <p:cNvPr id="35" name="TextBox 34"/>
+          <p:cNvPr id="34" name="TextBox 33"/>
           <p:cNvSpPr txBox="1"/>
           <p:nvPr/>
         </p:nvSpPr>
@@ -9555,7 +9531,7 @@
       </p:sp>
       <p:sp>
         <p:nvSpPr>
-          <p:cNvPr id="36" name="TextBox 35"/>
+          <p:cNvPr id="35" name="TextBox 34"/>
           <p:cNvSpPr txBox="1"/>
           <p:nvPr/>
         </p:nvSpPr>
@@ -9594,7 +9570,7 @@
       </p:sp>
       <p:sp>
         <p:nvSpPr>
-          <p:cNvPr id="37" name="Rectangle 36"/>
+          <p:cNvPr id="36" name="Rectangle 35"/>
           <p:cNvSpPr/>
           <p:nvPr/>
         </p:nvSpPr>
@@ -9640,7 +9616,7 @@
       </p:sp>
       <p:sp>
         <p:nvSpPr>
-          <p:cNvPr id="38" name="Rectangle 37"/>
+          <p:cNvPr id="37" name="Rectangle 36"/>
           <p:cNvSpPr/>
           <p:nvPr/>
         </p:nvSpPr>
@@ -9684,7 +9660,7 @@
       </p:sp>
       <p:sp>
         <p:nvSpPr>
-          <p:cNvPr id="39" name="TextBox 38"/>
+          <p:cNvPr id="38" name="TextBox 37"/>
           <p:cNvSpPr txBox="1"/>
           <p:nvPr/>
         </p:nvSpPr>
@@ -9718,7 +9694,7 @@
       </p:sp>
       <p:sp>
         <p:nvSpPr>
-          <p:cNvPr id="40" name="TextBox 39"/>
+          <p:cNvPr id="39" name="TextBox 38"/>
           <p:cNvSpPr txBox="1"/>
           <p:nvPr/>
         </p:nvSpPr>
@@ -9757,7 +9733,7 @@
       </p:sp>
       <p:sp>
         <p:nvSpPr>
-          <p:cNvPr id="41" name="Rectangle 40"/>
+          <p:cNvPr id="40" name="Rectangle 39"/>
           <p:cNvSpPr/>
           <p:nvPr/>
         </p:nvSpPr>
@@ -9803,7 +9779,7 @@
       </p:sp>
       <p:sp>
         <p:nvSpPr>
-          <p:cNvPr id="42" name="Rectangle 41"/>
+          <p:cNvPr id="41" name="Rectangle 40"/>
           <p:cNvSpPr/>
           <p:nvPr/>
         </p:nvSpPr>
@@ -9847,7 +9823,7 @@
       </p:sp>
       <p:sp>
         <p:nvSpPr>
-          <p:cNvPr id="43" name="TextBox 42"/>
+          <p:cNvPr id="42" name="TextBox 41"/>
           <p:cNvSpPr txBox="1"/>
           <p:nvPr/>
         </p:nvSpPr>
@@ -9881,7 +9857,7 @@
       </p:sp>
       <p:sp>
         <p:nvSpPr>
-          <p:cNvPr id="44" name="TextBox 43"/>
+          <p:cNvPr id="43" name="TextBox 42"/>
           <p:cNvSpPr txBox="1"/>
           <p:nvPr/>
         </p:nvSpPr>
@@ -9920,7 +9896,7 @@
       </p:sp>
       <p:sp>
         <p:nvSpPr>
-          <p:cNvPr id="45" name="TextBox 44"/>
+          <p:cNvPr id="44" name="TextBox 43"/>
           <p:cNvSpPr txBox="1"/>
           <p:nvPr/>
         </p:nvSpPr>
@@ -9954,7 +9930,7 @@
       </p:sp>
       <p:sp>
         <p:nvSpPr>
-          <p:cNvPr id="46" name="Rectangle 45"/>
+          <p:cNvPr id="45" name="Rectangle 44"/>
           <p:cNvSpPr/>
           <p:nvPr/>
         </p:nvSpPr>
@@ -10000,7 +9976,7 @@
       </p:sp>
       <p:sp>
         <p:nvSpPr>
-          <p:cNvPr id="47" name="Rectangle 46"/>
+          <p:cNvPr id="46" name="Rectangle 45"/>
           <p:cNvSpPr/>
           <p:nvPr/>
         </p:nvSpPr>
@@ -10044,7 +10020,7 @@
       </p:sp>
       <p:sp>
         <p:nvSpPr>
-          <p:cNvPr id="48" name="TextBox 47"/>
+          <p:cNvPr id="47" name="TextBox 46"/>
           <p:cNvSpPr txBox="1"/>
           <p:nvPr/>
         </p:nvSpPr>
@@ -10078,7 +10054,7 @@
       </p:sp>
       <p:sp>
         <p:nvSpPr>
-          <p:cNvPr id="49" name="TextBox 48"/>
+          <p:cNvPr id="48" name="TextBox 47"/>
           <p:cNvSpPr txBox="1"/>
           <p:nvPr/>
         </p:nvSpPr>
@@ -10117,7 +10093,7 @@
       </p:sp>
       <p:sp>
         <p:nvSpPr>
-          <p:cNvPr id="50" name="Rectangle 49"/>
+          <p:cNvPr id="49" name="Rectangle 48"/>
           <p:cNvSpPr/>
           <p:nvPr/>
         </p:nvSpPr>
@@ -10163,7 +10139,7 @@
       </p:sp>
       <p:sp>
         <p:nvSpPr>
-          <p:cNvPr id="51" name="Rectangle 50"/>
+          <p:cNvPr id="50" name="Rectangle 49"/>
           <p:cNvSpPr/>
           <p:nvPr/>
         </p:nvSpPr>
@@ -10207,7 +10183,7 @@
       </p:sp>
       <p:sp>
         <p:nvSpPr>
-          <p:cNvPr id="52" name="TextBox 51"/>
+          <p:cNvPr id="51" name="TextBox 50"/>
           <p:cNvSpPr txBox="1"/>
           <p:nvPr/>
         </p:nvSpPr>
@@ -10241,7 +10217,7 @@
       </p:sp>
       <p:sp>
         <p:nvSpPr>
-          <p:cNvPr id="53" name="TextBox 52"/>
+          <p:cNvPr id="52" name="TextBox 51"/>
           <p:cNvSpPr txBox="1"/>
           <p:nvPr/>
         </p:nvSpPr>
@@ -10280,7 +10256,7 @@
       </p:sp>
       <p:sp>
         <p:nvSpPr>
-          <p:cNvPr id="54" name="Rectangle 53"/>
+          <p:cNvPr id="53" name="Rectangle 52"/>
           <p:cNvSpPr/>
           <p:nvPr/>
         </p:nvSpPr>
@@ -10326,7 +10302,7 @@
       </p:sp>
       <p:sp>
         <p:nvSpPr>
-          <p:cNvPr id="55" name="Rectangle 54"/>
+          <p:cNvPr id="54" name="Rectangle 53"/>
           <p:cNvSpPr/>
           <p:nvPr/>
         </p:nvSpPr>
@@ -10370,7 +10346,7 @@
       </p:sp>
       <p:sp>
         <p:nvSpPr>
-          <p:cNvPr id="56" name="TextBox 55"/>
+          <p:cNvPr id="55" name="TextBox 54"/>
           <p:cNvSpPr txBox="1"/>
           <p:nvPr/>
         </p:nvSpPr>
@@ -10404,7 +10380,7 @@
       </p:sp>
       <p:sp>
         <p:nvSpPr>
-          <p:cNvPr id="57" name="TextBox 56"/>
+          <p:cNvPr id="56" name="TextBox 55"/>
           <p:cNvSpPr txBox="1"/>
           <p:nvPr/>
         </p:nvSpPr>
@@ -10443,7 +10419,7 @@
       </p:sp>
       <p:sp>
         <p:nvSpPr>
-          <p:cNvPr id="58" name="Rectangle 57"/>
+          <p:cNvPr id="57" name="Rectangle 56"/>
           <p:cNvSpPr/>
           <p:nvPr/>
         </p:nvSpPr>
@@ -10489,7 +10465,7 @@
       </p:sp>
       <p:sp>
         <p:nvSpPr>
-          <p:cNvPr id="59" name="Rectangle 58"/>
+          <p:cNvPr id="58" name="Rectangle 57"/>
           <p:cNvSpPr/>
           <p:nvPr/>
         </p:nvSpPr>
@@ -10533,7 +10509,7 @@
       </p:sp>
       <p:sp>
         <p:nvSpPr>
-          <p:cNvPr id="60" name="TextBox 59"/>
+          <p:cNvPr id="59" name="TextBox 58"/>
           <p:cNvSpPr txBox="1"/>
           <p:nvPr/>
         </p:nvSpPr>
@@ -10567,7 +10543,7 @@
       </p:sp>
       <p:sp>
         <p:nvSpPr>
-          <p:cNvPr id="61" name="TextBox 60"/>
+          <p:cNvPr id="60" name="TextBox 59"/>
           <p:cNvSpPr txBox="1"/>
           <p:nvPr/>
         </p:nvSpPr>
@@ -10606,7 +10582,7 @@
       </p:sp>
       <p:sp>
         <p:nvSpPr>
-          <p:cNvPr id="62" name="TextBox 61"/>
+          <p:cNvPr id="61" name="TextBox 60"/>
           <p:cNvSpPr txBox="1"/>
           <p:nvPr/>
         </p:nvSpPr>
@@ -10703,33 +10679,9 @@
           <a:p/>
         </p:txBody>
       </p:sp>
-      <p:pic>
-        <p:nvPicPr>
-          <p:cNvPr id="3" name="Picture 2" descr="image.png"/>
-          <p:cNvPicPr>
-            <a:picLocks noChangeAspect="1"/>
-          </p:cNvPicPr>
-          <p:nvPr/>
-        </p:nvPicPr>
-        <p:blipFill>
-          <a:blip r:embed="rId2"/>
-          <a:stretch>
-            <a:fillRect/>
-          </a:stretch>
-        </p:blipFill>
-        <p:spPr>
-          <a:xfrm>
-            <a:off x="9893808" y="6163056"/>
-            <a:ext cx="1938528" cy="621792"/>
-          </a:xfrm>
-          <a:prstGeom prst="rect">
-            <a:avLst/>
-          </a:prstGeom>
-        </p:spPr>
-      </p:pic>
-      <p:sp>
-        <p:nvSpPr>
-          <p:cNvPr id="4" name="TextBox 3"/>
+      <p:sp>
+        <p:nvSpPr>
+          <p:cNvPr id="3" name="TextBox 2"/>
           <p:cNvSpPr txBox="1"/>
           <p:nvPr/>
         </p:nvSpPr>
@@ -10763,7 +10715,7 @@
       </p:sp>
       <p:sp>
         <p:nvSpPr>
-          <p:cNvPr id="5" name="TextBox 4"/>
+          <p:cNvPr id="4" name="TextBox 3"/>
           <p:cNvSpPr txBox="1"/>
           <p:nvPr/>
         </p:nvSpPr>
@@ -10797,7 +10749,7 @@
       </p:sp>
       <p:cxnSp>
         <p:nvCxnSpPr>
-          <p:cNvPr id="6" name="Connector 5"/>
+          <p:cNvPr id="5" name="Connector 4"/>
           <p:cNvCxnSpPr/>
           <p:nvPr/>
         </p:nvCxnSpPr>
@@ -10832,7 +10784,7 @@
       </p:cxnSp>
       <p:graphicFrame>
         <p:nvGraphicFramePr>
-          <p:cNvPr id="7" name="Table 6"/>
+          <p:cNvPr id="6" name="Table 5"/>
           <p:cNvGraphicFramePr>
             <a:graphicFrameLocks noGrp="1"/>
           </p:cNvGraphicFramePr>
@@ -11638,33 +11590,9 @@
           <a:p/>
         </p:txBody>
       </p:sp>
-      <p:pic>
-        <p:nvPicPr>
-          <p:cNvPr id="3" name="Picture 2" descr="image.png"/>
-          <p:cNvPicPr>
-            <a:picLocks noChangeAspect="1"/>
-          </p:cNvPicPr>
-          <p:nvPr/>
-        </p:nvPicPr>
-        <p:blipFill>
-          <a:blip r:embed="rId2"/>
-          <a:stretch>
-            <a:fillRect/>
-          </a:stretch>
-        </p:blipFill>
-        <p:spPr>
-          <a:xfrm>
-            <a:off x="9893808" y="6163056"/>
-            <a:ext cx="1938528" cy="621792"/>
-          </a:xfrm>
-          <a:prstGeom prst="rect">
-            <a:avLst/>
-          </a:prstGeom>
-        </p:spPr>
-      </p:pic>
-      <p:sp>
-        <p:nvSpPr>
-          <p:cNvPr id="4" name="TextBox 3"/>
+      <p:sp>
+        <p:nvSpPr>
+          <p:cNvPr id="3" name="TextBox 2"/>
           <p:cNvSpPr txBox="1"/>
           <p:nvPr/>
         </p:nvSpPr>
@@ -11698,7 +11626,7 @@
       </p:sp>
       <p:sp>
         <p:nvSpPr>
-          <p:cNvPr id="5" name="TextBox 4"/>
+          <p:cNvPr id="4" name="TextBox 3"/>
           <p:cNvSpPr txBox="1"/>
           <p:nvPr/>
         </p:nvSpPr>
@@ -11732,7 +11660,7 @@
       </p:sp>
       <p:cxnSp>
         <p:nvCxnSpPr>
-          <p:cNvPr id="6" name="Connector 5"/>
+          <p:cNvPr id="5" name="Connector 4"/>
           <p:cNvCxnSpPr/>
           <p:nvPr/>
         </p:nvCxnSpPr>
@@ -11767,7 +11695,7 @@
       </p:cxnSp>
       <p:sp>
         <p:nvSpPr>
-          <p:cNvPr id="7" name="Rectangle 6"/>
+          <p:cNvPr id="6" name="Rectangle 5"/>
           <p:cNvSpPr/>
           <p:nvPr/>
         </p:nvSpPr>
@@ -11813,7 +11741,7 @@
       </p:sp>
       <p:sp>
         <p:nvSpPr>
-          <p:cNvPr id="8" name="Rectangle 7"/>
+          <p:cNvPr id="7" name="Rectangle 6"/>
           <p:cNvSpPr/>
           <p:nvPr/>
         </p:nvSpPr>
@@ -11857,7 +11785,7 @@
       </p:sp>
       <p:sp>
         <p:nvSpPr>
-          <p:cNvPr id="9" name="TextBox 8"/>
+          <p:cNvPr id="8" name="TextBox 7"/>
           <p:cNvSpPr txBox="1"/>
           <p:nvPr/>
         </p:nvSpPr>
@@ -11905,7 +11833,7 @@
       </p:sp>
       <p:sp>
         <p:nvSpPr>
-          <p:cNvPr id="10" name="Rectangle 9"/>
+          <p:cNvPr id="9" name="Rectangle 8"/>
           <p:cNvSpPr/>
           <p:nvPr/>
         </p:nvSpPr>
@@ -11951,7 +11879,7 @@
       </p:sp>
       <p:sp>
         <p:nvSpPr>
-          <p:cNvPr id="11" name="TextBox 10"/>
+          <p:cNvPr id="10" name="TextBox 9"/>
           <p:cNvSpPr txBox="1"/>
           <p:nvPr/>
         </p:nvSpPr>
@@ -11986,7 +11914,7 @@
       </p:sp>
       <p:sp>
         <p:nvSpPr>
-          <p:cNvPr id="12" name="TextBox 11"/>
+          <p:cNvPr id="11" name="TextBox 10"/>
           <p:cNvSpPr txBox="1"/>
           <p:nvPr/>
         </p:nvSpPr>
@@ -12021,7 +11949,7 @@
       </p:sp>
       <p:sp>
         <p:nvSpPr>
-          <p:cNvPr id="13" name="TextBox 12"/>
+          <p:cNvPr id="12" name="TextBox 11"/>
           <p:cNvSpPr txBox="1"/>
           <p:nvPr/>
         </p:nvSpPr>
@@ -12060,7 +11988,7 @@
       </p:sp>
       <p:sp>
         <p:nvSpPr>
-          <p:cNvPr id="14" name="Rectangle 13"/>
+          <p:cNvPr id="13" name="Rectangle 12"/>
           <p:cNvSpPr/>
           <p:nvPr/>
         </p:nvSpPr>
@@ -12106,7 +12034,7 @@
       </p:sp>
       <p:sp>
         <p:nvSpPr>
-          <p:cNvPr id="15" name="TextBox 14"/>
+          <p:cNvPr id="14" name="TextBox 13"/>
           <p:cNvSpPr txBox="1"/>
           <p:nvPr/>
         </p:nvSpPr>
@@ -12141,7 +12069,7 @@
       </p:sp>
       <p:sp>
         <p:nvSpPr>
-          <p:cNvPr id="16" name="TextBox 15"/>
+          <p:cNvPr id="15" name="TextBox 14"/>
           <p:cNvSpPr txBox="1"/>
           <p:nvPr/>
         </p:nvSpPr>
@@ -12176,7 +12104,7 @@
       </p:sp>
       <p:sp>
         <p:nvSpPr>
-          <p:cNvPr id="17" name="TextBox 16"/>
+          <p:cNvPr id="16" name="TextBox 15"/>
           <p:cNvSpPr txBox="1"/>
           <p:nvPr/>
         </p:nvSpPr>
@@ -12215,7 +12143,7 @@
       </p:sp>
       <p:sp>
         <p:nvSpPr>
-          <p:cNvPr id="18" name="Rectangle 17"/>
+          <p:cNvPr id="17" name="Rectangle 16"/>
           <p:cNvSpPr/>
           <p:nvPr/>
         </p:nvSpPr>
@@ -12261,7 +12189,7 @@
       </p:sp>
       <p:sp>
         <p:nvSpPr>
-          <p:cNvPr id="19" name="TextBox 18"/>
+          <p:cNvPr id="18" name="TextBox 17"/>
           <p:cNvSpPr txBox="1"/>
           <p:nvPr/>
         </p:nvSpPr>
@@ -12296,7 +12224,7 @@
       </p:sp>
       <p:sp>
         <p:nvSpPr>
-          <p:cNvPr id="20" name="TextBox 19"/>
+          <p:cNvPr id="19" name="TextBox 18"/>
           <p:cNvSpPr txBox="1"/>
           <p:nvPr/>
         </p:nvSpPr>
@@ -12331,7 +12259,7 @@
       </p:sp>
       <p:sp>
         <p:nvSpPr>
-          <p:cNvPr id="21" name="TextBox 20"/>
+          <p:cNvPr id="20" name="TextBox 19"/>
           <p:cNvSpPr txBox="1"/>
           <p:nvPr/>
         </p:nvSpPr>
@@ -12370,7 +12298,7 @@
       </p:sp>
       <p:sp>
         <p:nvSpPr>
-          <p:cNvPr id="22" name="Rectangle 21"/>
+          <p:cNvPr id="21" name="Rectangle 20"/>
           <p:cNvSpPr/>
           <p:nvPr/>
         </p:nvSpPr>
@@ -12416,7 +12344,7 @@
       </p:sp>
       <p:sp>
         <p:nvSpPr>
-          <p:cNvPr id="23" name="TextBox 22"/>
+          <p:cNvPr id="22" name="TextBox 21"/>
           <p:cNvSpPr txBox="1"/>
           <p:nvPr/>
         </p:nvSpPr>
@@ -12451,7 +12379,7 @@
       </p:sp>
       <p:sp>
         <p:nvSpPr>
-          <p:cNvPr id="24" name="TextBox 23"/>
+          <p:cNvPr id="23" name="TextBox 22"/>
           <p:cNvSpPr txBox="1"/>
           <p:nvPr/>
         </p:nvSpPr>
@@ -12486,7 +12414,7 @@
       </p:sp>
       <p:sp>
         <p:nvSpPr>
-          <p:cNvPr id="25" name="TextBox 24"/>
+          <p:cNvPr id="24" name="TextBox 23"/>
           <p:cNvSpPr txBox="1"/>
           <p:nvPr/>
         </p:nvSpPr>
@@ -12525,7 +12453,7 @@
       </p:sp>
       <p:sp>
         <p:nvSpPr>
-          <p:cNvPr id="26" name="TextBox 25"/>
+          <p:cNvPr id="25" name="TextBox 24"/>
           <p:cNvSpPr txBox="1"/>
           <p:nvPr/>
         </p:nvSpPr>
@@ -12606,7 +12534,7 @@
       </p:sp>
       <p:sp>
         <p:nvSpPr>
-          <p:cNvPr id="27" name="TextBox 26"/>
+          <p:cNvPr id="26" name="TextBox 25"/>
           <p:cNvSpPr txBox="1"/>
           <p:nvPr/>
         </p:nvSpPr>
@@ -12964,33 +12892,9 @@
           <a:p/>
         </p:txBody>
       </p:sp>
-      <p:pic>
-        <p:nvPicPr>
-          <p:cNvPr id="3" name="Picture 2" descr="image.png"/>
-          <p:cNvPicPr>
-            <a:picLocks noChangeAspect="1"/>
-          </p:cNvPicPr>
-          <p:nvPr/>
-        </p:nvPicPr>
-        <p:blipFill>
-          <a:blip r:embed="rId2"/>
-          <a:stretch>
-            <a:fillRect/>
-          </a:stretch>
-        </p:blipFill>
-        <p:spPr>
-          <a:xfrm>
-            <a:off x="9893808" y="6163056"/>
-            <a:ext cx="1938528" cy="621792"/>
-          </a:xfrm>
-          <a:prstGeom prst="rect">
-            <a:avLst/>
-          </a:prstGeom>
-        </p:spPr>
-      </p:pic>
-      <p:sp>
-        <p:nvSpPr>
-          <p:cNvPr id="4" name="TextBox 3"/>
+      <p:sp>
+        <p:nvSpPr>
+          <p:cNvPr id="3" name="TextBox 2"/>
           <p:cNvSpPr txBox="1"/>
           <p:nvPr/>
         </p:nvSpPr>
@@ -13024,7 +12928,7 @@
       </p:sp>
       <p:sp>
         <p:nvSpPr>
-          <p:cNvPr id="5" name="TextBox 4"/>
+          <p:cNvPr id="4" name="TextBox 3"/>
           <p:cNvSpPr txBox="1"/>
           <p:nvPr/>
         </p:nvSpPr>
@@ -13058,7 +12962,7 @@
       </p:sp>
       <p:cxnSp>
         <p:nvCxnSpPr>
-          <p:cNvPr id="6" name="Connector 5"/>
+          <p:cNvPr id="5" name="Connector 4"/>
           <p:cNvCxnSpPr/>
           <p:nvPr/>
         </p:nvCxnSpPr>
@@ -13093,7 +12997,7 @@
       </p:cxnSp>
       <p:sp>
         <p:nvSpPr>
-          <p:cNvPr id="7" name="Rectangle 6"/>
+          <p:cNvPr id="6" name="Rectangle 5"/>
           <p:cNvSpPr/>
           <p:nvPr/>
         </p:nvSpPr>
@@ -13139,7 +13043,7 @@
       </p:sp>
       <p:sp>
         <p:nvSpPr>
-          <p:cNvPr id="8" name="Rectangle 7"/>
+          <p:cNvPr id="7" name="Rectangle 6"/>
           <p:cNvSpPr/>
           <p:nvPr/>
         </p:nvSpPr>
@@ -13183,7 +13087,7 @@
       </p:sp>
       <p:sp>
         <p:nvSpPr>
-          <p:cNvPr id="9" name="TextBox 8"/>
+          <p:cNvPr id="8" name="TextBox 7"/>
           <p:cNvSpPr txBox="1"/>
           <p:nvPr/>
         </p:nvSpPr>
@@ -13217,7 +13121,7 @@
       </p:sp>
       <p:sp>
         <p:nvSpPr>
-          <p:cNvPr id="10" name="TextBox 9"/>
+          <p:cNvPr id="9" name="TextBox 8"/>
           <p:cNvSpPr txBox="1"/>
           <p:nvPr/>
         </p:nvSpPr>
@@ -13251,7 +13155,7 @@
       </p:sp>
       <p:sp>
         <p:nvSpPr>
-          <p:cNvPr id="11" name="TextBox 10"/>
+          <p:cNvPr id="10" name="TextBox 9"/>
           <p:cNvSpPr txBox="1"/>
           <p:nvPr/>
         </p:nvSpPr>
@@ -13290,7 +13194,7 @@
       </p:sp>
       <p:sp>
         <p:nvSpPr>
-          <p:cNvPr id="12" name="TextBox 11"/>
+          <p:cNvPr id="11" name="TextBox 10"/>
           <p:cNvSpPr txBox="1"/>
           <p:nvPr/>
         </p:nvSpPr>
@@ -13325,7 +13229,7 @@
       </p:sp>
       <p:sp>
         <p:nvSpPr>
-          <p:cNvPr id="13" name="Rectangle 12"/>
+          <p:cNvPr id="12" name="Rectangle 11"/>
           <p:cNvSpPr/>
           <p:nvPr/>
         </p:nvSpPr>
@@ -13371,7 +13275,7 @@
       </p:sp>
       <p:sp>
         <p:nvSpPr>
-          <p:cNvPr id="14" name="Rectangle 13"/>
+          <p:cNvPr id="13" name="Rectangle 12"/>
           <p:cNvSpPr/>
           <p:nvPr/>
         </p:nvSpPr>
@@ -13415,7 +13319,7 @@
       </p:sp>
       <p:sp>
         <p:nvSpPr>
-          <p:cNvPr id="15" name="TextBox 14"/>
+          <p:cNvPr id="14" name="TextBox 13"/>
           <p:cNvSpPr txBox="1"/>
           <p:nvPr/>
         </p:nvSpPr>
@@ -13449,7 +13353,7 @@
       </p:sp>
       <p:sp>
         <p:nvSpPr>
-          <p:cNvPr id="16" name="TextBox 15"/>
+          <p:cNvPr id="15" name="TextBox 14"/>
           <p:cNvSpPr txBox="1"/>
           <p:nvPr/>
         </p:nvSpPr>
@@ -13483,7 +13387,7 @@
       </p:sp>
       <p:sp>
         <p:nvSpPr>
-          <p:cNvPr id="17" name="TextBox 16"/>
+          <p:cNvPr id="16" name="TextBox 15"/>
           <p:cNvSpPr txBox="1"/>
           <p:nvPr/>
         </p:nvSpPr>
@@ -13522,7 +13426,7 @@
       </p:sp>
       <p:sp>
         <p:nvSpPr>
-          <p:cNvPr id="18" name="TextBox 17"/>
+          <p:cNvPr id="17" name="TextBox 16"/>
           <p:cNvSpPr txBox="1"/>
           <p:nvPr/>
         </p:nvSpPr>
@@ -13557,7 +13461,7 @@
       </p:sp>
       <p:sp>
         <p:nvSpPr>
-          <p:cNvPr id="19" name="Rectangle 18"/>
+          <p:cNvPr id="18" name="Rectangle 17"/>
           <p:cNvSpPr/>
           <p:nvPr/>
         </p:nvSpPr>
@@ -13603,7 +13507,7 @@
       </p:sp>
       <p:sp>
         <p:nvSpPr>
-          <p:cNvPr id="20" name="Rectangle 19"/>
+          <p:cNvPr id="19" name="Rectangle 18"/>
           <p:cNvSpPr/>
           <p:nvPr/>
         </p:nvSpPr>
@@ -13647,7 +13551,7 @@
       </p:sp>
       <p:sp>
         <p:nvSpPr>
-          <p:cNvPr id="21" name="TextBox 20"/>
+          <p:cNvPr id="20" name="TextBox 19"/>
           <p:cNvSpPr txBox="1"/>
           <p:nvPr/>
         </p:nvSpPr>
@@ -13681,7 +13585,7 @@
       </p:sp>
       <p:sp>
         <p:nvSpPr>
-          <p:cNvPr id="22" name="TextBox 21"/>
+          <p:cNvPr id="21" name="TextBox 20"/>
           <p:cNvSpPr txBox="1"/>
           <p:nvPr/>
         </p:nvSpPr>
@@ -13715,7 +13619,7 @@
       </p:sp>
       <p:sp>
         <p:nvSpPr>
-          <p:cNvPr id="23" name="TextBox 22"/>
+          <p:cNvPr id="22" name="TextBox 21"/>
           <p:cNvSpPr txBox="1"/>
           <p:nvPr/>
         </p:nvSpPr>
@@ -13754,7 +13658,7 @@
       </p:sp>
       <p:sp>
         <p:nvSpPr>
-          <p:cNvPr id="24" name="TextBox 23"/>
+          <p:cNvPr id="23" name="TextBox 22"/>
           <p:cNvSpPr txBox="1"/>
           <p:nvPr/>
         </p:nvSpPr>
@@ -13789,7 +13693,7 @@
       </p:sp>
       <p:sp>
         <p:nvSpPr>
-          <p:cNvPr id="25" name="Rectangle 24"/>
+          <p:cNvPr id="24" name="Rectangle 23"/>
           <p:cNvSpPr/>
           <p:nvPr/>
         </p:nvSpPr>
@@ -13835,7 +13739,7 @@
       </p:sp>
       <p:sp>
         <p:nvSpPr>
-          <p:cNvPr id="26" name="Rectangle 25"/>
+          <p:cNvPr id="25" name="Rectangle 24"/>
           <p:cNvSpPr/>
           <p:nvPr/>
         </p:nvSpPr>
@@ -13879,7 +13783,7 @@
       </p:sp>
       <p:sp>
         <p:nvSpPr>
-          <p:cNvPr id="27" name="TextBox 26"/>
+          <p:cNvPr id="26" name="TextBox 25"/>
           <p:cNvSpPr txBox="1"/>
           <p:nvPr/>
         </p:nvSpPr>
@@ -13913,7 +13817,7 @@
       </p:sp>
       <p:sp>
         <p:nvSpPr>
-          <p:cNvPr id="28" name="TextBox 27"/>
+          <p:cNvPr id="27" name="TextBox 26"/>
           <p:cNvSpPr txBox="1"/>
           <p:nvPr/>
         </p:nvSpPr>
@@ -13947,7 +13851,7 @@
       </p:sp>
       <p:sp>
         <p:nvSpPr>
-          <p:cNvPr id="29" name="TextBox 28"/>
+          <p:cNvPr id="28" name="TextBox 27"/>
           <p:cNvSpPr txBox="1"/>
           <p:nvPr/>
         </p:nvSpPr>
@@ -13986,7 +13890,7 @@
       </p:sp>
       <p:sp>
         <p:nvSpPr>
-          <p:cNvPr id="30" name="TextBox 29"/>
+          <p:cNvPr id="29" name="TextBox 28"/>
           <p:cNvSpPr txBox="1"/>
           <p:nvPr/>
         </p:nvSpPr>
@@ -14021,7 +13925,7 @@
       </p:sp>
       <p:sp>
         <p:nvSpPr>
-          <p:cNvPr id="31" name="Rectangle 30"/>
+          <p:cNvPr id="30" name="Rectangle 29"/>
           <p:cNvSpPr/>
           <p:nvPr/>
         </p:nvSpPr>
@@ -14067,7 +13971,7 @@
       </p:sp>
       <p:sp>
         <p:nvSpPr>
-          <p:cNvPr id="32" name="Rectangle 31"/>
+          <p:cNvPr id="31" name="Rectangle 30"/>
           <p:cNvSpPr/>
           <p:nvPr/>
         </p:nvSpPr>
@@ -14111,7 +14015,7 @@
       </p:sp>
       <p:sp>
         <p:nvSpPr>
-          <p:cNvPr id="33" name="TextBox 32"/>
+          <p:cNvPr id="32" name="TextBox 31"/>
           <p:cNvSpPr txBox="1"/>
           <p:nvPr/>
         </p:nvSpPr>
@@ -14145,7 +14049,7 @@
       </p:sp>
       <p:sp>
         <p:nvSpPr>
-          <p:cNvPr id="34" name="TextBox 33"/>
+          <p:cNvPr id="33" name="TextBox 32"/>
           <p:cNvSpPr txBox="1"/>
           <p:nvPr/>
         </p:nvSpPr>
@@ -14179,7 +14083,7 @@
       </p:sp>
       <p:sp>
         <p:nvSpPr>
-          <p:cNvPr id="35" name="TextBox 34"/>
+          <p:cNvPr id="34" name="TextBox 33"/>
           <p:cNvSpPr txBox="1"/>
           <p:nvPr/>
         </p:nvSpPr>
@@ -14218,7 +14122,7 @@
       </p:sp>
       <p:sp>
         <p:nvSpPr>
-          <p:cNvPr id="36" name="TextBox 35"/>
+          <p:cNvPr id="35" name="TextBox 34"/>
           <p:cNvSpPr txBox="1"/>
           <p:nvPr/>
         </p:nvSpPr>
@@ -14253,7 +14157,7 @@
       </p:sp>
       <p:sp>
         <p:nvSpPr>
-          <p:cNvPr id="37" name="Rectangle 36"/>
+          <p:cNvPr id="36" name="Rectangle 35"/>
           <p:cNvSpPr/>
           <p:nvPr/>
         </p:nvSpPr>
@@ -14299,7 +14203,7 @@
       </p:sp>
       <p:sp>
         <p:nvSpPr>
-          <p:cNvPr id="38" name="Rectangle 37"/>
+          <p:cNvPr id="37" name="Rectangle 36"/>
           <p:cNvSpPr/>
           <p:nvPr/>
         </p:nvSpPr>
@@ -14343,7 +14247,7 @@
       </p:sp>
       <p:sp>
         <p:nvSpPr>
-          <p:cNvPr id="39" name="TextBox 38"/>
+          <p:cNvPr id="38" name="TextBox 37"/>
           <p:cNvSpPr txBox="1"/>
           <p:nvPr/>
         </p:nvSpPr>
@@ -14377,7 +14281,7 @@
       </p:sp>
       <p:sp>
         <p:nvSpPr>
-          <p:cNvPr id="40" name="TextBox 39"/>
+          <p:cNvPr id="39" name="TextBox 38"/>
           <p:cNvSpPr txBox="1"/>
           <p:nvPr/>
         </p:nvSpPr>
@@ -14411,7 +14315,7 @@
       </p:sp>
       <p:sp>
         <p:nvSpPr>
-          <p:cNvPr id="41" name="TextBox 40"/>
+          <p:cNvPr id="40" name="TextBox 39"/>
           <p:cNvSpPr txBox="1"/>
           <p:nvPr/>
         </p:nvSpPr>
@@ -14450,7 +14354,7 @@
       </p:sp>
       <p:sp>
         <p:nvSpPr>
-          <p:cNvPr id="42" name="TextBox 41"/>
+          <p:cNvPr id="41" name="TextBox 40"/>
           <p:cNvSpPr txBox="1"/>
           <p:nvPr/>
         </p:nvSpPr>
@@ -14484,7 +14388,7 @@
       </p:sp>
       <p:sp>
         <p:nvSpPr>
-          <p:cNvPr id="43" name="Rectangle 42"/>
+          <p:cNvPr id="42" name="Rectangle 41"/>
           <p:cNvSpPr/>
           <p:nvPr/>
         </p:nvSpPr>
@@ -14530,7 +14434,7 @@
       </p:sp>
       <p:sp>
         <p:nvSpPr>
-          <p:cNvPr id="44" name="Rectangle 43"/>
+          <p:cNvPr id="43" name="Rectangle 42"/>
           <p:cNvSpPr/>
           <p:nvPr/>
         </p:nvSpPr>
@@ -14574,7 +14478,7 @@
       </p:sp>
       <p:sp>
         <p:nvSpPr>
-          <p:cNvPr id="45" name="TextBox 44"/>
+          <p:cNvPr id="44" name="TextBox 43"/>
           <p:cNvSpPr txBox="1"/>
           <p:nvPr/>
         </p:nvSpPr>
@@ -14608,7 +14512,7 @@
       </p:sp>
       <p:sp>
         <p:nvSpPr>
-          <p:cNvPr id="46" name="TextBox 45"/>
+          <p:cNvPr id="45" name="TextBox 44"/>
           <p:cNvSpPr txBox="1"/>
           <p:nvPr/>
         </p:nvSpPr>
@@ -14647,7 +14551,7 @@
       </p:sp>
       <p:sp>
         <p:nvSpPr>
-          <p:cNvPr id="47" name="Rectangle 46"/>
+          <p:cNvPr id="46" name="Rectangle 45"/>
           <p:cNvSpPr/>
           <p:nvPr/>
         </p:nvSpPr>
@@ -14693,7 +14597,7 @@
       </p:sp>
       <p:sp>
         <p:nvSpPr>
-          <p:cNvPr id="48" name="Rectangle 47"/>
+          <p:cNvPr id="47" name="Rectangle 46"/>
           <p:cNvSpPr/>
           <p:nvPr/>
         </p:nvSpPr>
@@ -14737,7 +14641,7 @@
       </p:sp>
       <p:sp>
         <p:nvSpPr>
-          <p:cNvPr id="49" name="TextBox 48"/>
+          <p:cNvPr id="48" name="TextBox 47"/>
           <p:cNvSpPr txBox="1"/>
           <p:nvPr/>
         </p:nvSpPr>
@@ -14771,7 +14675,7 @@
       </p:sp>
       <p:sp>
         <p:nvSpPr>
-          <p:cNvPr id="50" name="TextBox 49"/>
+          <p:cNvPr id="49" name="TextBox 48"/>
           <p:cNvSpPr txBox="1"/>
           <p:nvPr/>
         </p:nvSpPr>
@@ -14810,7 +14714,7 @@
       </p:sp>
       <p:sp>
         <p:nvSpPr>
-          <p:cNvPr id="51" name="Rectangle 50"/>
+          <p:cNvPr id="50" name="Rectangle 49"/>
           <p:cNvSpPr/>
           <p:nvPr/>
         </p:nvSpPr>
@@ -14856,7 +14760,7 @@
       </p:sp>
       <p:sp>
         <p:nvSpPr>
-          <p:cNvPr id="52" name="Rectangle 51"/>
+          <p:cNvPr id="51" name="Rectangle 50"/>
           <p:cNvSpPr/>
           <p:nvPr/>
         </p:nvSpPr>
@@ -14900,7 +14804,7 @@
       </p:sp>
       <p:sp>
         <p:nvSpPr>
-          <p:cNvPr id="53" name="TextBox 52"/>
+          <p:cNvPr id="52" name="TextBox 51"/>
           <p:cNvSpPr txBox="1"/>
           <p:nvPr/>
         </p:nvSpPr>
@@ -14934,7 +14838,7 @@
       </p:sp>
       <p:sp>
         <p:nvSpPr>
-          <p:cNvPr id="54" name="TextBox 53"/>
+          <p:cNvPr id="53" name="TextBox 52"/>
           <p:cNvSpPr txBox="1"/>
           <p:nvPr/>
         </p:nvSpPr>
@@ -14973,7 +14877,7 @@
       </p:sp>
       <p:sp>
         <p:nvSpPr>
-          <p:cNvPr id="55" name="TextBox 54"/>
+          <p:cNvPr id="54" name="TextBox 53"/>
           <p:cNvSpPr txBox="1"/>
           <p:nvPr/>
         </p:nvSpPr>
@@ -15007,7 +14911,7 @@
       </p:sp>
       <p:sp>
         <p:nvSpPr>
-          <p:cNvPr id="56" name="Rectangle 55"/>
+          <p:cNvPr id="55" name="Rectangle 54"/>
           <p:cNvSpPr/>
           <p:nvPr/>
         </p:nvSpPr>
@@ -15053,7 +14957,7 @@
       </p:sp>
       <p:sp>
         <p:nvSpPr>
-          <p:cNvPr id="57" name="Rectangle 56"/>
+          <p:cNvPr id="56" name="Rectangle 55"/>
           <p:cNvSpPr/>
           <p:nvPr/>
         </p:nvSpPr>
@@ -15097,7 +15001,7 @@
       </p:sp>
       <p:sp>
         <p:nvSpPr>
-          <p:cNvPr id="58" name="TextBox 57"/>
+          <p:cNvPr id="57" name="TextBox 56"/>
           <p:cNvSpPr txBox="1"/>
           <p:nvPr/>
         </p:nvSpPr>
@@ -15131,7 +15035,7 @@
       </p:sp>
       <p:sp>
         <p:nvSpPr>
-          <p:cNvPr id="59" name="TextBox 58"/>
+          <p:cNvPr id="58" name="TextBox 57"/>
           <p:cNvSpPr txBox="1"/>
           <p:nvPr/>
         </p:nvSpPr>
@@ -15170,7 +15074,7 @@
       </p:sp>
       <p:sp>
         <p:nvSpPr>
-          <p:cNvPr id="60" name="Rectangle 59"/>
+          <p:cNvPr id="59" name="Rectangle 58"/>
           <p:cNvSpPr/>
           <p:nvPr/>
         </p:nvSpPr>
@@ -15216,7 +15120,7 @@
       </p:sp>
       <p:sp>
         <p:nvSpPr>
-          <p:cNvPr id="61" name="Rectangle 60"/>
+          <p:cNvPr id="60" name="Rectangle 59"/>
           <p:cNvSpPr/>
           <p:nvPr/>
         </p:nvSpPr>
@@ -15260,7 +15164,7 @@
       </p:sp>
       <p:sp>
         <p:nvSpPr>
-          <p:cNvPr id="62" name="TextBox 61"/>
+          <p:cNvPr id="61" name="TextBox 60"/>
           <p:cNvSpPr txBox="1"/>
           <p:nvPr/>
         </p:nvSpPr>
@@ -15294,7 +15198,7 @@
       </p:sp>
       <p:sp>
         <p:nvSpPr>
-          <p:cNvPr id="63" name="TextBox 62"/>
+          <p:cNvPr id="62" name="TextBox 61"/>
           <p:cNvSpPr txBox="1"/>
           <p:nvPr/>
         </p:nvSpPr>
@@ -15333,7 +15237,7 @@
       </p:sp>
       <p:sp>
         <p:nvSpPr>
-          <p:cNvPr id="64" name="Rectangle 63"/>
+          <p:cNvPr id="63" name="Rectangle 62"/>
           <p:cNvSpPr/>
           <p:nvPr/>
         </p:nvSpPr>
@@ -15379,7 +15283,7 @@
       </p:sp>
       <p:sp>
         <p:nvSpPr>
-          <p:cNvPr id="65" name="Rectangle 64"/>
+          <p:cNvPr id="64" name="Rectangle 63"/>
           <p:cNvSpPr/>
           <p:nvPr/>
         </p:nvSpPr>
@@ -15423,7 +15327,7 @@
       </p:sp>
       <p:sp>
         <p:nvSpPr>
-          <p:cNvPr id="66" name="TextBox 65"/>
+          <p:cNvPr id="65" name="TextBox 64"/>
           <p:cNvSpPr txBox="1"/>
           <p:nvPr/>
         </p:nvSpPr>
@@ -15457,7 +15361,7 @@
       </p:sp>
       <p:sp>
         <p:nvSpPr>
-          <p:cNvPr id="67" name="TextBox 66"/>
+          <p:cNvPr id="66" name="TextBox 65"/>
           <p:cNvSpPr txBox="1"/>
           <p:nvPr/>
         </p:nvSpPr>
@@ -15554,33 +15458,9 @@
           <a:p/>
         </p:txBody>
       </p:sp>
-      <p:pic>
-        <p:nvPicPr>
-          <p:cNvPr id="3" name="Picture 2" descr="image.png"/>
-          <p:cNvPicPr>
-            <a:picLocks noChangeAspect="1"/>
-          </p:cNvPicPr>
-          <p:nvPr/>
-        </p:nvPicPr>
-        <p:blipFill>
-          <a:blip r:embed="rId2"/>
-          <a:stretch>
-            <a:fillRect/>
-          </a:stretch>
-        </p:blipFill>
-        <p:spPr>
-          <a:xfrm>
-            <a:off x="9893808" y="6163056"/>
-            <a:ext cx="1938528" cy="621792"/>
-          </a:xfrm>
-          <a:prstGeom prst="rect">
-            <a:avLst/>
-          </a:prstGeom>
-        </p:spPr>
-      </p:pic>
-      <p:sp>
-        <p:nvSpPr>
-          <p:cNvPr id="4" name="TextBox 3"/>
+      <p:sp>
+        <p:nvSpPr>
+          <p:cNvPr id="3" name="TextBox 2"/>
           <p:cNvSpPr txBox="1"/>
           <p:nvPr/>
         </p:nvSpPr>
@@ -15614,7 +15494,7 @@
       </p:sp>
       <p:sp>
         <p:nvSpPr>
-          <p:cNvPr id="5" name="TextBox 4"/>
+          <p:cNvPr id="4" name="TextBox 3"/>
           <p:cNvSpPr txBox="1"/>
           <p:nvPr/>
         </p:nvSpPr>
@@ -15648,7 +15528,7 @@
       </p:sp>
       <p:cxnSp>
         <p:nvCxnSpPr>
-          <p:cNvPr id="6" name="Connector 5"/>
+          <p:cNvPr id="5" name="Connector 4"/>
           <p:cNvCxnSpPr/>
           <p:nvPr/>
         </p:nvCxnSpPr>
@@ -15683,7 +15563,7 @@
       </p:cxnSp>
       <p:sp>
         <p:nvSpPr>
-          <p:cNvPr id="7" name="Rectangle 6"/>
+          <p:cNvPr id="6" name="Rectangle 5"/>
           <p:cNvSpPr/>
           <p:nvPr/>
         </p:nvSpPr>
@@ -15729,7 +15609,7 @@
       </p:sp>
       <p:sp>
         <p:nvSpPr>
-          <p:cNvPr id="8" name="Rectangle 7"/>
+          <p:cNvPr id="7" name="Rectangle 6"/>
           <p:cNvSpPr/>
           <p:nvPr/>
         </p:nvSpPr>
@@ -15773,7 +15653,7 @@
       </p:sp>
       <p:sp>
         <p:nvSpPr>
-          <p:cNvPr id="9" name="TextBox 8"/>
+          <p:cNvPr id="8" name="TextBox 7"/>
           <p:cNvSpPr txBox="1"/>
           <p:nvPr/>
         </p:nvSpPr>
@@ -15830,7 +15710,7 @@
       </p:sp>
       <p:graphicFrame>
         <p:nvGraphicFramePr>
-          <p:cNvPr id="10" name="Table 9"/>
+          <p:cNvPr id="9" name="Table 8"/>
           <p:cNvGraphicFramePr>
             <a:graphicFrameLocks noGrp="1"/>
           </p:cNvGraphicFramePr>
@@ -16218,7 +16098,7 @@
       </p:graphicFrame>
       <p:sp>
         <p:nvSpPr>
-          <p:cNvPr id="11" name="Rectangle 10"/>
+          <p:cNvPr id="10" name="Rectangle 9"/>
           <p:cNvSpPr/>
           <p:nvPr/>
         </p:nvSpPr>
@@ -16264,7 +16144,7 @@
       </p:sp>
       <p:sp>
         <p:nvSpPr>
-          <p:cNvPr id="12" name="Rectangle 11"/>
+          <p:cNvPr id="11" name="Rectangle 10"/>
           <p:cNvSpPr/>
           <p:nvPr/>
         </p:nvSpPr>
@@ -16308,7 +16188,7 @@
       </p:sp>
       <p:sp>
         <p:nvSpPr>
-          <p:cNvPr id="13" name="TextBox 12"/>
+          <p:cNvPr id="12" name="TextBox 11"/>
           <p:cNvSpPr txBox="1"/>
           <p:nvPr/>
         </p:nvSpPr>
@@ -16342,7 +16222,7 @@
       </p:sp>
       <p:sp>
         <p:nvSpPr>
-          <p:cNvPr id="14" name="TextBox 13"/>
+          <p:cNvPr id="13" name="TextBox 12"/>
           <p:cNvSpPr txBox="1"/>
           <p:nvPr/>
         </p:nvSpPr>
@@ -16381,7 +16261,7 @@
       </p:sp>
       <p:sp>
         <p:nvSpPr>
-          <p:cNvPr id="15" name="Rectangle 14"/>
+          <p:cNvPr id="14" name="Rectangle 13"/>
           <p:cNvSpPr/>
           <p:nvPr/>
         </p:nvSpPr>
@@ -16427,7 +16307,7 @@
       </p:sp>
       <p:sp>
         <p:nvSpPr>
-          <p:cNvPr id="16" name="Rectangle 15"/>
+          <p:cNvPr id="15" name="Rectangle 14"/>
           <p:cNvSpPr/>
           <p:nvPr/>
         </p:nvSpPr>
@@ -16471,7 +16351,7 @@
       </p:sp>
       <p:sp>
         <p:nvSpPr>
-          <p:cNvPr id="17" name="TextBox 16"/>
+          <p:cNvPr id="16" name="TextBox 15"/>
           <p:cNvSpPr txBox="1"/>
           <p:nvPr/>
         </p:nvSpPr>
@@ -16505,7 +16385,7 @@
       </p:sp>
       <p:sp>
         <p:nvSpPr>
-          <p:cNvPr id="18" name="TextBox 17"/>
+          <p:cNvPr id="17" name="TextBox 16"/>
           <p:cNvSpPr txBox="1"/>
           <p:nvPr/>
         </p:nvSpPr>
@@ -16544,7 +16424,7 @@
       </p:sp>
       <p:sp>
         <p:nvSpPr>
-          <p:cNvPr id="19" name="Rectangle 18"/>
+          <p:cNvPr id="18" name="Rectangle 17"/>
           <p:cNvSpPr/>
           <p:nvPr/>
         </p:nvSpPr>
@@ -16590,7 +16470,7 @@
       </p:sp>
       <p:sp>
         <p:nvSpPr>
-          <p:cNvPr id="20" name="Rectangle 19"/>
+          <p:cNvPr id="19" name="Rectangle 18"/>
           <p:cNvSpPr/>
           <p:nvPr/>
         </p:nvSpPr>
@@ -16634,7 +16514,7 @@
       </p:sp>
       <p:sp>
         <p:nvSpPr>
-          <p:cNvPr id="21" name="TextBox 20"/>
+          <p:cNvPr id="20" name="TextBox 19"/>
           <p:cNvSpPr txBox="1"/>
           <p:nvPr/>
         </p:nvSpPr>
@@ -16668,7 +16548,7 @@
       </p:sp>
       <p:sp>
         <p:nvSpPr>
-          <p:cNvPr id="22" name="TextBox 21"/>
+          <p:cNvPr id="21" name="TextBox 20"/>
           <p:cNvSpPr txBox="1"/>
           <p:nvPr/>
         </p:nvSpPr>
@@ -16765,33 +16645,9 @@
           <a:p/>
         </p:txBody>
       </p:sp>
-      <p:pic>
-        <p:nvPicPr>
-          <p:cNvPr id="3" name="Picture 2" descr="image.png"/>
-          <p:cNvPicPr>
-            <a:picLocks noChangeAspect="1"/>
-          </p:cNvPicPr>
-          <p:nvPr/>
-        </p:nvPicPr>
-        <p:blipFill>
-          <a:blip r:embed="rId2"/>
-          <a:stretch>
-            <a:fillRect/>
-          </a:stretch>
-        </p:blipFill>
-        <p:spPr>
-          <a:xfrm>
-            <a:off x="9893808" y="6163056"/>
-            <a:ext cx="1938528" cy="621792"/>
-          </a:xfrm>
-          <a:prstGeom prst="rect">
-            <a:avLst/>
-          </a:prstGeom>
-        </p:spPr>
-      </p:pic>
-      <p:sp>
-        <p:nvSpPr>
-          <p:cNvPr id="4" name="TextBox 3"/>
+      <p:sp>
+        <p:nvSpPr>
+          <p:cNvPr id="3" name="TextBox 2"/>
           <p:cNvSpPr txBox="1"/>
           <p:nvPr/>
         </p:nvSpPr>
@@ -16825,7 +16681,7 @@
       </p:sp>
       <p:sp>
         <p:nvSpPr>
-          <p:cNvPr id="5" name="TextBox 4"/>
+          <p:cNvPr id="4" name="TextBox 3"/>
           <p:cNvSpPr txBox="1"/>
           <p:nvPr/>
         </p:nvSpPr>
@@ -16859,7 +16715,7 @@
       </p:sp>
       <p:cxnSp>
         <p:nvCxnSpPr>
-          <p:cNvPr id="6" name="Connector 5"/>
+          <p:cNvPr id="5" name="Connector 4"/>
           <p:cNvCxnSpPr/>
           <p:nvPr/>
         </p:nvCxnSpPr>
@@ -16894,7 +16750,7 @@
       </p:cxnSp>
       <p:sp>
         <p:nvSpPr>
-          <p:cNvPr id="7" name="Rectangle 6"/>
+          <p:cNvPr id="6" name="Rectangle 5"/>
           <p:cNvSpPr/>
           <p:nvPr/>
         </p:nvSpPr>
@@ -16940,7 +16796,7 @@
       </p:sp>
       <p:sp>
         <p:nvSpPr>
-          <p:cNvPr id="8" name="Rectangle 7"/>
+          <p:cNvPr id="7" name="Rectangle 6"/>
           <p:cNvSpPr/>
           <p:nvPr/>
         </p:nvSpPr>
@@ -16984,7 +16840,7 @@
       </p:sp>
       <p:sp>
         <p:nvSpPr>
-          <p:cNvPr id="9" name="TextBox 8"/>
+          <p:cNvPr id="8" name="TextBox 7"/>
           <p:cNvSpPr txBox="1"/>
           <p:nvPr/>
         </p:nvSpPr>
@@ -17032,7 +16888,7 @@
       </p:sp>
       <p:sp>
         <p:nvSpPr>
-          <p:cNvPr id="10" name="Rectangle 9"/>
+          <p:cNvPr id="9" name="Rectangle 8"/>
           <p:cNvSpPr/>
           <p:nvPr/>
         </p:nvSpPr>
@@ -17078,7 +16934,7 @@
       </p:sp>
       <p:sp>
         <p:nvSpPr>
-          <p:cNvPr id="11" name="TextBox 10"/>
+          <p:cNvPr id="10" name="TextBox 9"/>
           <p:cNvSpPr txBox="1"/>
           <p:nvPr/>
         </p:nvSpPr>
@@ -17113,7 +16969,7 @@
       </p:sp>
       <p:sp>
         <p:nvSpPr>
-          <p:cNvPr id="12" name="TextBox 11"/>
+          <p:cNvPr id="11" name="TextBox 10"/>
           <p:cNvSpPr txBox="1"/>
           <p:nvPr/>
         </p:nvSpPr>
@@ -17148,7 +17004,7 @@
       </p:sp>
       <p:sp>
         <p:nvSpPr>
-          <p:cNvPr id="13" name="TextBox 12"/>
+          <p:cNvPr id="12" name="TextBox 11"/>
           <p:cNvSpPr txBox="1"/>
           <p:nvPr/>
         </p:nvSpPr>
@@ -17187,7 +17043,7 @@
       </p:sp>
       <p:sp>
         <p:nvSpPr>
-          <p:cNvPr id="14" name="Rectangle 13"/>
+          <p:cNvPr id="13" name="Rectangle 12"/>
           <p:cNvSpPr/>
           <p:nvPr/>
         </p:nvSpPr>
@@ -17233,7 +17089,7 @@
       </p:sp>
       <p:sp>
         <p:nvSpPr>
-          <p:cNvPr id="15" name="TextBox 14"/>
+          <p:cNvPr id="14" name="TextBox 13"/>
           <p:cNvSpPr txBox="1"/>
           <p:nvPr/>
         </p:nvSpPr>
@@ -17268,7 +17124,7 @@
       </p:sp>
       <p:sp>
         <p:nvSpPr>
-          <p:cNvPr id="16" name="TextBox 15"/>
+          <p:cNvPr id="15" name="TextBox 14"/>
           <p:cNvSpPr txBox="1"/>
           <p:nvPr/>
         </p:nvSpPr>
@@ -17303,7 +17159,7 @@
       </p:sp>
       <p:sp>
         <p:nvSpPr>
-          <p:cNvPr id="17" name="TextBox 16"/>
+          <p:cNvPr id="16" name="TextBox 15"/>
           <p:cNvSpPr txBox="1"/>
           <p:nvPr/>
         </p:nvSpPr>
@@ -17342,7 +17198,7 @@
       </p:sp>
       <p:sp>
         <p:nvSpPr>
-          <p:cNvPr id="18" name="Rectangle 17"/>
+          <p:cNvPr id="17" name="Rectangle 16"/>
           <p:cNvSpPr/>
           <p:nvPr/>
         </p:nvSpPr>
@@ -17388,7 +17244,7 @@
       </p:sp>
       <p:sp>
         <p:nvSpPr>
-          <p:cNvPr id="19" name="TextBox 18"/>
+          <p:cNvPr id="18" name="TextBox 17"/>
           <p:cNvSpPr txBox="1"/>
           <p:nvPr/>
         </p:nvSpPr>
@@ -17423,7 +17279,7 @@
       </p:sp>
       <p:sp>
         <p:nvSpPr>
-          <p:cNvPr id="20" name="TextBox 19"/>
+          <p:cNvPr id="19" name="TextBox 18"/>
           <p:cNvSpPr txBox="1"/>
           <p:nvPr/>
         </p:nvSpPr>
@@ -17458,7 +17314,7 @@
       </p:sp>
       <p:sp>
         <p:nvSpPr>
-          <p:cNvPr id="21" name="TextBox 20"/>
+          <p:cNvPr id="20" name="TextBox 19"/>
           <p:cNvSpPr txBox="1"/>
           <p:nvPr/>
         </p:nvSpPr>
@@ -17497,7 +17353,7 @@
       </p:sp>
       <p:sp>
         <p:nvSpPr>
-          <p:cNvPr id="22" name="Rectangle 21"/>
+          <p:cNvPr id="21" name="Rectangle 20"/>
           <p:cNvSpPr/>
           <p:nvPr/>
         </p:nvSpPr>
@@ -17543,7 +17399,7 @@
       </p:sp>
       <p:sp>
         <p:nvSpPr>
-          <p:cNvPr id="23" name="TextBox 22"/>
+          <p:cNvPr id="22" name="TextBox 21"/>
           <p:cNvSpPr txBox="1"/>
           <p:nvPr/>
         </p:nvSpPr>
@@ -17578,7 +17434,7 @@
       </p:sp>
       <p:sp>
         <p:nvSpPr>
-          <p:cNvPr id="24" name="TextBox 23"/>
+          <p:cNvPr id="23" name="TextBox 22"/>
           <p:cNvSpPr txBox="1"/>
           <p:nvPr/>
         </p:nvSpPr>
@@ -17613,7 +17469,7 @@
       </p:sp>
       <p:sp>
         <p:nvSpPr>
-          <p:cNvPr id="25" name="TextBox 24"/>
+          <p:cNvPr id="24" name="TextBox 23"/>
           <p:cNvSpPr txBox="1"/>
           <p:nvPr/>
         </p:nvSpPr>
@@ -17652,7 +17508,7 @@
       </p:sp>
       <p:sp>
         <p:nvSpPr>
-          <p:cNvPr id="26" name="TextBox 25"/>
+          <p:cNvPr id="25" name="TextBox 24"/>
           <p:cNvSpPr txBox="1"/>
           <p:nvPr/>
         </p:nvSpPr>
@@ -17686,7 +17542,7 @@
       </p:sp>
       <p:sp>
         <p:nvSpPr>
-          <p:cNvPr id="27" name="Rectangle 26"/>
+          <p:cNvPr id="26" name="Rectangle 25"/>
           <p:cNvSpPr/>
           <p:nvPr/>
         </p:nvSpPr>
@@ -17732,7 +17588,7 @@
       </p:sp>
       <p:sp>
         <p:nvSpPr>
-          <p:cNvPr id="28" name="Rectangle 27"/>
+          <p:cNvPr id="27" name="Rectangle 26"/>
           <p:cNvSpPr/>
           <p:nvPr/>
         </p:nvSpPr>
@@ -17776,7 +17632,7 @@
       </p:sp>
       <p:sp>
         <p:nvSpPr>
-          <p:cNvPr id="29" name="TextBox 28"/>
+          <p:cNvPr id="28" name="TextBox 27"/>
           <p:cNvSpPr txBox="1"/>
           <p:nvPr/>
         </p:nvSpPr>
@@ -17810,7 +17666,7 @@
       </p:sp>
       <p:sp>
         <p:nvSpPr>
-          <p:cNvPr id="30" name="TextBox 29"/>
+          <p:cNvPr id="29" name="TextBox 28"/>
           <p:cNvSpPr txBox="1"/>
           <p:nvPr/>
         </p:nvSpPr>
@@ -17907,33 +17763,9 @@
           <a:p/>
         </p:txBody>
       </p:sp>
-      <p:pic>
-        <p:nvPicPr>
-          <p:cNvPr id="3" name="Picture 2" descr="image.png"/>
-          <p:cNvPicPr>
-            <a:picLocks noChangeAspect="1"/>
-          </p:cNvPicPr>
-          <p:nvPr/>
-        </p:nvPicPr>
-        <p:blipFill>
-          <a:blip r:embed="rId2"/>
-          <a:stretch>
-            <a:fillRect/>
-          </a:stretch>
-        </p:blipFill>
-        <p:spPr>
-          <a:xfrm>
-            <a:off x="9893808" y="6163056"/>
-            <a:ext cx="1938528" cy="621792"/>
-          </a:xfrm>
-          <a:prstGeom prst="rect">
-            <a:avLst/>
-          </a:prstGeom>
-        </p:spPr>
-      </p:pic>
-      <p:sp>
-        <p:nvSpPr>
-          <p:cNvPr id="4" name="TextBox 3"/>
+      <p:sp>
+        <p:nvSpPr>
+          <p:cNvPr id="3" name="TextBox 2"/>
           <p:cNvSpPr txBox="1"/>
           <p:nvPr/>
         </p:nvSpPr>
@@ -17967,7 +17799,7 @@
       </p:sp>
       <p:sp>
         <p:nvSpPr>
-          <p:cNvPr id="5" name="TextBox 4"/>
+          <p:cNvPr id="4" name="TextBox 3"/>
           <p:cNvSpPr txBox="1"/>
           <p:nvPr/>
         </p:nvSpPr>
@@ -18001,7 +17833,7 @@
       </p:sp>
       <p:cxnSp>
         <p:nvCxnSpPr>
-          <p:cNvPr id="6" name="Connector 5"/>
+          <p:cNvPr id="5" name="Connector 4"/>
           <p:cNvCxnSpPr/>
           <p:nvPr/>
         </p:nvCxnSpPr>
@@ -18036,7 +17868,7 @@
       </p:cxnSp>
       <p:sp>
         <p:nvSpPr>
-          <p:cNvPr id="7" name="Rectangle 6"/>
+          <p:cNvPr id="6" name="Rectangle 5"/>
           <p:cNvSpPr/>
           <p:nvPr/>
         </p:nvSpPr>
@@ -18082,7 +17914,7 @@
       </p:sp>
       <p:sp>
         <p:nvSpPr>
-          <p:cNvPr id="8" name="TextBox 7"/>
+          <p:cNvPr id="7" name="TextBox 6"/>
           <p:cNvSpPr txBox="1"/>
           <p:nvPr/>
         </p:nvSpPr>
@@ -18116,7 +17948,7 @@
       </p:sp>
       <p:sp>
         <p:nvSpPr>
-          <p:cNvPr id="9" name="TextBox 8"/>
+          <p:cNvPr id="8" name="TextBox 7"/>
           <p:cNvSpPr txBox="1"/>
           <p:nvPr/>
         </p:nvSpPr>
@@ -18151,7 +17983,7 @@
       </p:sp>
       <p:sp>
         <p:nvSpPr>
-          <p:cNvPr id="10" name="Rectangle 9"/>
+          <p:cNvPr id="9" name="Rectangle 8"/>
           <p:cNvSpPr/>
           <p:nvPr/>
         </p:nvSpPr>
@@ -18197,7 +18029,7 @@
       </p:sp>
       <p:sp>
         <p:nvSpPr>
-          <p:cNvPr id="11" name="TextBox 10"/>
+          <p:cNvPr id="10" name="TextBox 9"/>
           <p:cNvSpPr txBox="1"/>
           <p:nvPr/>
         </p:nvSpPr>
@@ -18231,7 +18063,7 @@
       </p:sp>
       <p:sp>
         <p:nvSpPr>
-          <p:cNvPr id="12" name="TextBox 11"/>
+          <p:cNvPr id="11" name="TextBox 10"/>
           <p:cNvSpPr txBox="1"/>
           <p:nvPr/>
         </p:nvSpPr>
@@ -18266,7 +18098,7 @@
       </p:sp>
       <p:sp>
         <p:nvSpPr>
-          <p:cNvPr id="13" name="Rectangle 12"/>
+          <p:cNvPr id="12" name="Rectangle 11"/>
           <p:cNvSpPr/>
           <p:nvPr/>
         </p:nvSpPr>
@@ -18312,7 +18144,7 @@
       </p:sp>
       <p:sp>
         <p:nvSpPr>
-          <p:cNvPr id="14" name="TextBox 13"/>
+          <p:cNvPr id="13" name="TextBox 12"/>
           <p:cNvSpPr txBox="1"/>
           <p:nvPr/>
         </p:nvSpPr>
@@ -18346,7 +18178,7 @@
       </p:sp>
       <p:sp>
         <p:nvSpPr>
-          <p:cNvPr id="15" name="TextBox 14"/>
+          <p:cNvPr id="14" name="TextBox 13"/>
           <p:cNvSpPr txBox="1"/>
           <p:nvPr/>
         </p:nvSpPr>
@@ -18381,7 +18213,7 @@
       </p:sp>
       <p:sp>
         <p:nvSpPr>
-          <p:cNvPr id="16" name="Rectangle 15"/>
+          <p:cNvPr id="15" name="Rectangle 14"/>
           <p:cNvSpPr/>
           <p:nvPr/>
         </p:nvSpPr>
@@ -18427,7 +18259,7 @@
       </p:sp>
       <p:sp>
         <p:nvSpPr>
-          <p:cNvPr id="17" name="TextBox 16"/>
+          <p:cNvPr id="16" name="TextBox 15"/>
           <p:cNvSpPr txBox="1"/>
           <p:nvPr/>
         </p:nvSpPr>
@@ -18461,7 +18293,7 @@
       </p:sp>
       <p:sp>
         <p:nvSpPr>
-          <p:cNvPr id="18" name="TextBox 17"/>
+          <p:cNvPr id="17" name="TextBox 16"/>
           <p:cNvSpPr txBox="1"/>
           <p:nvPr/>
         </p:nvSpPr>
@@ -18496,7 +18328,7 @@
       </p:sp>
       <p:sp>
         <p:nvSpPr>
-          <p:cNvPr id="19" name="Rectangle 18"/>
+          <p:cNvPr id="18" name="Rectangle 17"/>
           <p:cNvSpPr/>
           <p:nvPr/>
         </p:nvSpPr>
@@ -18542,7 +18374,7 @@
       </p:sp>
       <p:sp>
         <p:nvSpPr>
-          <p:cNvPr id="20" name="TextBox 19"/>
+          <p:cNvPr id="19" name="TextBox 18"/>
           <p:cNvSpPr txBox="1"/>
           <p:nvPr/>
         </p:nvSpPr>
@@ -18576,7 +18408,7 @@
       </p:sp>
       <p:sp>
         <p:nvSpPr>
-          <p:cNvPr id="21" name="TextBox 20"/>
+          <p:cNvPr id="20" name="TextBox 19"/>
           <p:cNvSpPr txBox="1"/>
           <p:nvPr/>
         </p:nvSpPr>
@@ -18611,7 +18443,7 @@
       </p:sp>
       <p:sp>
         <p:nvSpPr>
-          <p:cNvPr id="22" name="Rectangle 21"/>
+          <p:cNvPr id="21" name="Rectangle 20"/>
           <p:cNvSpPr/>
           <p:nvPr/>
         </p:nvSpPr>
@@ -18657,7 +18489,7 @@
       </p:sp>
       <p:sp>
         <p:nvSpPr>
-          <p:cNvPr id="23" name="TextBox 22"/>
+          <p:cNvPr id="22" name="TextBox 21"/>
           <p:cNvSpPr txBox="1"/>
           <p:nvPr/>
         </p:nvSpPr>
@@ -18691,7 +18523,7 @@
       </p:sp>
       <p:sp>
         <p:nvSpPr>
-          <p:cNvPr id="24" name="TextBox 23"/>
+          <p:cNvPr id="23" name="TextBox 22"/>
           <p:cNvSpPr txBox="1"/>
           <p:nvPr/>
         </p:nvSpPr>
@@ -18726,7 +18558,7 @@
       </p:sp>
       <p:sp>
         <p:nvSpPr>
-          <p:cNvPr id="25" name="Rectangle 24"/>
+          <p:cNvPr id="24" name="Rectangle 23"/>
           <p:cNvSpPr/>
           <p:nvPr/>
         </p:nvSpPr>
@@ -18772,7 +18604,7 @@
       </p:sp>
       <p:sp>
         <p:nvSpPr>
-          <p:cNvPr id="26" name="TextBox 25"/>
+          <p:cNvPr id="25" name="TextBox 24"/>
           <p:cNvSpPr txBox="1"/>
           <p:nvPr/>
         </p:nvSpPr>
@@ -18806,7 +18638,7 @@
       </p:sp>
       <p:sp>
         <p:nvSpPr>
-          <p:cNvPr id="27" name="TextBox 26"/>
+          <p:cNvPr id="26" name="TextBox 25"/>
           <p:cNvSpPr txBox="1"/>
           <p:nvPr/>
         </p:nvSpPr>
@@ -18841,7 +18673,7 @@
       </p:sp>
       <p:sp>
         <p:nvSpPr>
-          <p:cNvPr id="28" name="Rectangle 27"/>
+          <p:cNvPr id="27" name="Rectangle 26"/>
           <p:cNvSpPr/>
           <p:nvPr/>
         </p:nvSpPr>
@@ -18887,7 +18719,7 @@
       </p:sp>
       <p:sp>
         <p:nvSpPr>
-          <p:cNvPr id="29" name="TextBox 28"/>
+          <p:cNvPr id="28" name="TextBox 27"/>
           <p:cNvSpPr txBox="1"/>
           <p:nvPr/>
         </p:nvSpPr>
@@ -18921,7 +18753,7 @@
       </p:sp>
       <p:sp>
         <p:nvSpPr>
-          <p:cNvPr id="30" name="TextBox 29"/>
+          <p:cNvPr id="29" name="TextBox 28"/>
           <p:cNvSpPr txBox="1"/>
           <p:nvPr/>
         </p:nvSpPr>
@@ -18956,7 +18788,7 @@
       </p:sp>
       <p:sp>
         <p:nvSpPr>
-          <p:cNvPr id="31" name="Rectangle 30"/>
+          <p:cNvPr id="30" name="Rectangle 29"/>
           <p:cNvSpPr/>
           <p:nvPr/>
         </p:nvSpPr>
@@ -19002,7 +18834,7 @@
       </p:sp>
       <p:sp>
         <p:nvSpPr>
-          <p:cNvPr id="32" name="TextBox 31"/>
+          <p:cNvPr id="31" name="TextBox 30"/>
           <p:cNvSpPr txBox="1"/>
           <p:nvPr/>
         </p:nvSpPr>
@@ -19036,7 +18868,7 @@
       </p:sp>
       <p:sp>
         <p:nvSpPr>
-          <p:cNvPr id="33" name="TextBox 32"/>
+          <p:cNvPr id="32" name="TextBox 31"/>
           <p:cNvSpPr txBox="1"/>
           <p:nvPr/>
         </p:nvSpPr>
@@ -19071,7 +18903,7 @@
       </p:sp>
       <p:sp>
         <p:nvSpPr>
-          <p:cNvPr id="34" name="TextBox 33"/>
+          <p:cNvPr id="33" name="TextBox 32"/>
           <p:cNvSpPr txBox="1"/>
           <p:nvPr/>
         </p:nvSpPr>
@@ -19105,7 +18937,7 @@
       </p:sp>
       <p:sp>
         <p:nvSpPr>
-          <p:cNvPr id="35" name="Rectangle 34"/>
+          <p:cNvPr id="34" name="Rectangle 33"/>
           <p:cNvSpPr/>
           <p:nvPr/>
         </p:nvSpPr>
@@ -19151,7 +18983,7 @@
       </p:sp>
       <p:sp>
         <p:nvSpPr>
-          <p:cNvPr id="36" name="Rectangle 35"/>
+          <p:cNvPr id="35" name="Rectangle 34"/>
           <p:cNvSpPr/>
           <p:nvPr/>
         </p:nvSpPr>
@@ -19195,7 +19027,7 @@
       </p:sp>
       <p:sp>
         <p:nvSpPr>
-          <p:cNvPr id="37" name="TextBox 36"/>
+          <p:cNvPr id="36" name="TextBox 35"/>
           <p:cNvSpPr txBox="1"/>
           <p:nvPr/>
         </p:nvSpPr>
@@ -19229,7 +19061,7 @@
       </p:sp>
       <p:sp>
         <p:nvSpPr>
-          <p:cNvPr id="38" name="TextBox 37"/>
+          <p:cNvPr id="37" name="TextBox 36"/>
           <p:cNvSpPr txBox="1"/>
           <p:nvPr/>
         </p:nvSpPr>
@@ -19268,7 +19100,7 @@
       </p:sp>
       <p:sp>
         <p:nvSpPr>
-          <p:cNvPr id="39" name="Rectangle 38"/>
+          <p:cNvPr id="38" name="Rectangle 37"/>
           <p:cNvSpPr/>
           <p:nvPr/>
         </p:nvSpPr>
@@ -19314,7 +19146,7 @@
       </p:sp>
       <p:sp>
         <p:nvSpPr>
-          <p:cNvPr id="40" name="Rectangle 39"/>
+          <p:cNvPr id="39" name="Rectangle 38"/>
           <p:cNvSpPr/>
           <p:nvPr/>
         </p:nvSpPr>
@@ -19358,7 +19190,7 @@
       </p:sp>
       <p:sp>
         <p:nvSpPr>
-          <p:cNvPr id="41" name="TextBox 40"/>
+          <p:cNvPr id="40" name="TextBox 39"/>
           <p:cNvSpPr txBox="1"/>
           <p:nvPr/>
         </p:nvSpPr>
@@ -19392,7 +19224,7 @@
       </p:sp>
       <p:sp>
         <p:nvSpPr>
-          <p:cNvPr id="42" name="TextBox 41"/>
+          <p:cNvPr id="41" name="TextBox 40"/>
           <p:cNvSpPr txBox="1"/>
           <p:nvPr/>
         </p:nvSpPr>
@@ -19431,7 +19263,7 @@
       </p:sp>
       <p:sp>
         <p:nvSpPr>
-          <p:cNvPr id="43" name="Rectangle 42"/>
+          <p:cNvPr id="42" name="Rectangle 41"/>
           <p:cNvSpPr/>
           <p:nvPr/>
         </p:nvSpPr>
@@ -19477,7 +19309,7 @@
       </p:sp>
       <p:sp>
         <p:nvSpPr>
-          <p:cNvPr id="44" name="Rectangle 43"/>
+          <p:cNvPr id="43" name="Rectangle 42"/>
           <p:cNvSpPr/>
           <p:nvPr/>
         </p:nvSpPr>
@@ -19521,7 +19353,7 @@
       </p:sp>
       <p:sp>
         <p:nvSpPr>
-          <p:cNvPr id="45" name="TextBox 44"/>
+          <p:cNvPr id="44" name="TextBox 43"/>
           <p:cNvSpPr txBox="1"/>
           <p:nvPr/>
         </p:nvSpPr>
@@ -19555,7 +19387,7 @@
       </p:sp>
       <p:sp>
         <p:nvSpPr>
-          <p:cNvPr id="46" name="TextBox 45"/>
+          <p:cNvPr id="45" name="TextBox 44"/>
           <p:cNvSpPr txBox="1"/>
           <p:nvPr/>
         </p:nvSpPr>
@@ -19594,7 +19426,7 @@
       </p:sp>
       <p:sp>
         <p:nvSpPr>
-          <p:cNvPr id="47" name="TextBox 46"/>
+          <p:cNvPr id="46" name="TextBox 45"/>
           <p:cNvSpPr txBox="1"/>
           <p:nvPr/>
         </p:nvSpPr>
@@ -19691,33 +19523,9 @@
           <a:p/>
         </p:txBody>
       </p:sp>
-      <p:pic>
-        <p:nvPicPr>
-          <p:cNvPr id="3" name="Picture 2" descr="image.png"/>
-          <p:cNvPicPr>
-            <a:picLocks noChangeAspect="1"/>
-          </p:cNvPicPr>
-          <p:nvPr/>
-        </p:nvPicPr>
-        <p:blipFill>
-          <a:blip r:embed="rId2"/>
-          <a:stretch>
-            <a:fillRect/>
-          </a:stretch>
-        </p:blipFill>
-        <p:spPr>
-          <a:xfrm>
-            <a:off x="9893808" y="6163056"/>
-            <a:ext cx="1938528" cy="621792"/>
-          </a:xfrm>
-          <a:prstGeom prst="rect">
-            <a:avLst/>
-          </a:prstGeom>
-        </p:spPr>
-      </p:pic>
-      <p:sp>
-        <p:nvSpPr>
-          <p:cNvPr id="4" name="TextBox 3"/>
+      <p:sp>
+        <p:nvSpPr>
+          <p:cNvPr id="3" name="TextBox 2"/>
           <p:cNvSpPr txBox="1"/>
           <p:nvPr/>
         </p:nvSpPr>
@@ -19751,7 +19559,7 @@
       </p:sp>
       <p:sp>
         <p:nvSpPr>
-          <p:cNvPr id="5" name="TextBox 4"/>
+          <p:cNvPr id="4" name="TextBox 3"/>
           <p:cNvSpPr txBox="1"/>
           <p:nvPr/>
         </p:nvSpPr>
@@ -19785,7 +19593,7 @@
       </p:sp>
       <p:cxnSp>
         <p:nvCxnSpPr>
-          <p:cNvPr id="6" name="Connector 5"/>
+          <p:cNvPr id="5" name="Connector 4"/>
           <p:cNvCxnSpPr/>
           <p:nvPr/>
         </p:nvCxnSpPr>
@@ -19820,7 +19628,7 @@
       </p:cxnSp>
       <p:sp>
         <p:nvSpPr>
-          <p:cNvPr id="7" name="Rectangle 6"/>
+          <p:cNvPr id="6" name="Rectangle 5"/>
           <p:cNvSpPr/>
           <p:nvPr/>
         </p:nvSpPr>
@@ -19866,7 +19674,7 @@
       </p:sp>
       <p:sp>
         <p:nvSpPr>
-          <p:cNvPr id="8" name="TextBox 7"/>
+          <p:cNvPr id="7" name="TextBox 6"/>
           <p:cNvSpPr txBox="1"/>
           <p:nvPr/>
         </p:nvSpPr>
@@ -19900,7 +19708,7 @@
       </p:sp>
       <p:sp>
         <p:nvSpPr>
-          <p:cNvPr id="9" name="TextBox 8"/>
+          <p:cNvPr id="8" name="TextBox 7"/>
           <p:cNvSpPr txBox="1"/>
           <p:nvPr/>
         </p:nvSpPr>
@@ -19935,7 +19743,7 @@
       </p:sp>
       <p:sp>
         <p:nvSpPr>
-          <p:cNvPr id="10" name="Rectangle 9"/>
+          <p:cNvPr id="9" name="Rectangle 8"/>
           <p:cNvSpPr/>
           <p:nvPr/>
         </p:nvSpPr>
@@ -19981,7 +19789,7 @@
       </p:sp>
       <p:sp>
         <p:nvSpPr>
-          <p:cNvPr id="11" name="TextBox 10"/>
+          <p:cNvPr id="10" name="TextBox 9"/>
           <p:cNvSpPr txBox="1"/>
           <p:nvPr/>
         </p:nvSpPr>
@@ -20015,7 +19823,7 @@
       </p:sp>
       <p:sp>
         <p:nvSpPr>
-          <p:cNvPr id="12" name="TextBox 11"/>
+          <p:cNvPr id="11" name="TextBox 10"/>
           <p:cNvSpPr txBox="1"/>
           <p:nvPr/>
         </p:nvSpPr>
@@ -20050,7 +19858,7 @@
       </p:sp>
       <p:sp>
         <p:nvSpPr>
-          <p:cNvPr id="13" name="Rectangle 12"/>
+          <p:cNvPr id="12" name="Rectangle 11"/>
           <p:cNvSpPr/>
           <p:nvPr/>
         </p:nvSpPr>
@@ -20096,7 +19904,7 @@
       </p:sp>
       <p:sp>
         <p:nvSpPr>
-          <p:cNvPr id="14" name="TextBox 13"/>
+          <p:cNvPr id="13" name="TextBox 12"/>
           <p:cNvSpPr txBox="1"/>
           <p:nvPr/>
         </p:nvSpPr>
@@ -20130,7 +19938,7 @@
       </p:sp>
       <p:sp>
         <p:nvSpPr>
-          <p:cNvPr id="15" name="TextBox 14"/>
+          <p:cNvPr id="14" name="TextBox 13"/>
           <p:cNvSpPr txBox="1"/>
           <p:nvPr/>
         </p:nvSpPr>
@@ -20165,7 +19973,7 @@
       </p:sp>
       <p:sp>
         <p:nvSpPr>
-          <p:cNvPr id="16" name="Rectangle 15"/>
+          <p:cNvPr id="15" name="Rectangle 14"/>
           <p:cNvSpPr/>
           <p:nvPr/>
         </p:nvSpPr>
@@ -20211,7 +20019,7 @@
       </p:sp>
       <p:sp>
         <p:nvSpPr>
-          <p:cNvPr id="17" name="TextBox 16"/>
+          <p:cNvPr id="16" name="TextBox 15"/>
           <p:cNvSpPr txBox="1"/>
           <p:nvPr/>
         </p:nvSpPr>
@@ -20245,7 +20053,7 @@
       </p:sp>
       <p:sp>
         <p:nvSpPr>
-          <p:cNvPr id="18" name="TextBox 17"/>
+          <p:cNvPr id="17" name="TextBox 16"/>
           <p:cNvSpPr txBox="1"/>
           <p:nvPr/>
         </p:nvSpPr>
@@ -20280,7 +20088,7 @@
       </p:sp>
       <p:sp>
         <p:nvSpPr>
-          <p:cNvPr id="19" name="Rectangle 18"/>
+          <p:cNvPr id="18" name="Rectangle 17"/>
           <p:cNvSpPr/>
           <p:nvPr/>
         </p:nvSpPr>
@@ -20326,7 +20134,7 @@
       </p:sp>
       <p:sp>
         <p:nvSpPr>
-          <p:cNvPr id="20" name="TextBox 19"/>
+          <p:cNvPr id="19" name="TextBox 18"/>
           <p:cNvSpPr txBox="1"/>
           <p:nvPr/>
         </p:nvSpPr>
@@ -20360,7 +20168,7 @@
       </p:sp>
       <p:sp>
         <p:nvSpPr>
-          <p:cNvPr id="21" name="TextBox 20"/>
+          <p:cNvPr id="20" name="TextBox 19"/>
           <p:cNvSpPr txBox="1"/>
           <p:nvPr/>
         </p:nvSpPr>
@@ -20395,7 +20203,7 @@
       </p:sp>
       <p:sp>
         <p:nvSpPr>
-          <p:cNvPr id="22" name="Rectangle 21"/>
+          <p:cNvPr id="21" name="Rectangle 20"/>
           <p:cNvSpPr/>
           <p:nvPr/>
         </p:nvSpPr>
@@ -20441,7 +20249,7 @@
       </p:sp>
       <p:sp>
         <p:nvSpPr>
-          <p:cNvPr id="23" name="TextBox 22"/>
+          <p:cNvPr id="22" name="TextBox 21"/>
           <p:cNvSpPr txBox="1"/>
           <p:nvPr/>
         </p:nvSpPr>
@@ -20475,7 +20283,7 @@
       </p:sp>
       <p:sp>
         <p:nvSpPr>
-          <p:cNvPr id="24" name="TextBox 23"/>
+          <p:cNvPr id="23" name="TextBox 22"/>
           <p:cNvSpPr txBox="1"/>
           <p:nvPr/>
         </p:nvSpPr>
@@ -20510,7 +20318,7 @@
       </p:sp>
       <p:sp>
         <p:nvSpPr>
-          <p:cNvPr id="25" name="Rectangle 24"/>
+          <p:cNvPr id="24" name="Rectangle 23"/>
           <p:cNvSpPr/>
           <p:nvPr/>
         </p:nvSpPr>
@@ -20556,7 +20364,7 @@
       </p:sp>
       <p:sp>
         <p:nvSpPr>
-          <p:cNvPr id="26" name="TextBox 25"/>
+          <p:cNvPr id="25" name="TextBox 24"/>
           <p:cNvSpPr txBox="1"/>
           <p:nvPr/>
         </p:nvSpPr>
@@ -20590,7 +20398,7 @@
       </p:sp>
       <p:sp>
         <p:nvSpPr>
-          <p:cNvPr id="27" name="TextBox 26"/>
+          <p:cNvPr id="26" name="TextBox 25"/>
           <p:cNvSpPr txBox="1"/>
           <p:nvPr/>
         </p:nvSpPr>
@@ -20625,7 +20433,7 @@
       </p:sp>
       <p:sp>
         <p:nvSpPr>
-          <p:cNvPr id="28" name="Rectangle 27"/>
+          <p:cNvPr id="27" name="Rectangle 26"/>
           <p:cNvSpPr/>
           <p:nvPr/>
         </p:nvSpPr>
@@ -20671,7 +20479,7 @@
       </p:sp>
       <p:sp>
         <p:nvSpPr>
-          <p:cNvPr id="29" name="TextBox 28"/>
+          <p:cNvPr id="28" name="TextBox 27"/>
           <p:cNvSpPr txBox="1"/>
           <p:nvPr/>
         </p:nvSpPr>
@@ -20705,7 +20513,7 @@
       </p:sp>
       <p:sp>
         <p:nvSpPr>
-          <p:cNvPr id="30" name="TextBox 29"/>
+          <p:cNvPr id="29" name="TextBox 28"/>
           <p:cNvSpPr txBox="1"/>
           <p:nvPr/>
         </p:nvSpPr>
@@ -20740,7 +20548,7 @@
       </p:sp>
       <p:sp>
         <p:nvSpPr>
-          <p:cNvPr id="31" name="Rectangle 30"/>
+          <p:cNvPr id="30" name="Rectangle 29"/>
           <p:cNvSpPr/>
           <p:nvPr/>
         </p:nvSpPr>
@@ -20786,7 +20594,7 @@
       </p:sp>
       <p:sp>
         <p:nvSpPr>
-          <p:cNvPr id="32" name="TextBox 31"/>
+          <p:cNvPr id="31" name="TextBox 30"/>
           <p:cNvSpPr txBox="1"/>
           <p:nvPr/>
         </p:nvSpPr>
@@ -20820,7 +20628,7 @@
       </p:sp>
       <p:sp>
         <p:nvSpPr>
-          <p:cNvPr id="33" name="TextBox 32"/>
+          <p:cNvPr id="32" name="TextBox 31"/>
           <p:cNvSpPr txBox="1"/>
           <p:nvPr/>
         </p:nvSpPr>
@@ -20855,7 +20663,7 @@
       </p:sp>
       <p:sp>
         <p:nvSpPr>
-          <p:cNvPr id="34" name="TextBox 33"/>
+          <p:cNvPr id="33" name="TextBox 32"/>
           <p:cNvSpPr txBox="1"/>
           <p:nvPr/>
         </p:nvSpPr>
@@ -20889,7 +20697,7 @@
       </p:sp>
       <p:sp>
         <p:nvSpPr>
-          <p:cNvPr id="35" name="Rectangle 34"/>
+          <p:cNvPr id="34" name="Rectangle 33"/>
           <p:cNvSpPr/>
           <p:nvPr/>
         </p:nvSpPr>
@@ -20935,7 +20743,7 @@
       </p:sp>
       <p:sp>
         <p:nvSpPr>
-          <p:cNvPr id="36" name="Rectangle 35"/>
+          <p:cNvPr id="35" name="Rectangle 34"/>
           <p:cNvSpPr/>
           <p:nvPr/>
         </p:nvSpPr>
@@ -20979,7 +20787,7 @@
       </p:sp>
       <p:sp>
         <p:nvSpPr>
-          <p:cNvPr id="37" name="TextBox 36"/>
+          <p:cNvPr id="36" name="TextBox 35"/>
           <p:cNvSpPr txBox="1"/>
           <p:nvPr/>
         </p:nvSpPr>
@@ -21013,7 +20821,7 @@
       </p:sp>
       <p:sp>
         <p:nvSpPr>
-          <p:cNvPr id="38" name="TextBox 37"/>
+          <p:cNvPr id="37" name="TextBox 36"/>
           <p:cNvSpPr txBox="1"/>
           <p:nvPr/>
         </p:nvSpPr>
@@ -21052,7 +20860,7 @@
       </p:sp>
       <p:sp>
         <p:nvSpPr>
-          <p:cNvPr id="39" name="Rectangle 38"/>
+          <p:cNvPr id="38" name="Rectangle 37"/>
           <p:cNvSpPr/>
           <p:nvPr/>
         </p:nvSpPr>
@@ -21098,7 +20906,7 @@
       </p:sp>
       <p:sp>
         <p:nvSpPr>
-          <p:cNvPr id="40" name="Rectangle 39"/>
+          <p:cNvPr id="39" name="Rectangle 38"/>
           <p:cNvSpPr/>
           <p:nvPr/>
         </p:nvSpPr>
@@ -21142,7 +20950,7 @@
       </p:sp>
       <p:sp>
         <p:nvSpPr>
-          <p:cNvPr id="41" name="TextBox 40"/>
+          <p:cNvPr id="40" name="TextBox 39"/>
           <p:cNvSpPr txBox="1"/>
           <p:nvPr/>
         </p:nvSpPr>
@@ -21176,7 +20984,7 @@
       </p:sp>
       <p:sp>
         <p:nvSpPr>
-          <p:cNvPr id="42" name="TextBox 41"/>
+          <p:cNvPr id="41" name="TextBox 40"/>
           <p:cNvSpPr txBox="1"/>
           <p:nvPr/>
         </p:nvSpPr>
@@ -21215,7 +21023,7 @@
       </p:sp>
       <p:sp>
         <p:nvSpPr>
-          <p:cNvPr id="43" name="Rectangle 42"/>
+          <p:cNvPr id="42" name="Rectangle 41"/>
           <p:cNvSpPr/>
           <p:nvPr/>
         </p:nvSpPr>
@@ -21261,7 +21069,7 @@
       </p:sp>
       <p:sp>
         <p:nvSpPr>
-          <p:cNvPr id="44" name="Rectangle 43"/>
+          <p:cNvPr id="43" name="Rectangle 42"/>
           <p:cNvSpPr/>
           <p:nvPr/>
         </p:nvSpPr>
@@ -21305,7 +21113,7 @@
       </p:sp>
       <p:sp>
         <p:nvSpPr>
-          <p:cNvPr id="45" name="TextBox 44"/>
+          <p:cNvPr id="44" name="TextBox 43"/>
           <p:cNvSpPr txBox="1"/>
           <p:nvPr/>
         </p:nvSpPr>
@@ -21339,7 +21147,7 @@
       </p:sp>
       <p:sp>
         <p:nvSpPr>
-          <p:cNvPr id="46" name="TextBox 45"/>
+          <p:cNvPr id="45" name="TextBox 44"/>
           <p:cNvSpPr txBox="1"/>
           <p:nvPr/>
         </p:nvSpPr>
@@ -21378,7 +21186,7 @@
       </p:sp>
       <p:sp>
         <p:nvSpPr>
-          <p:cNvPr id="47" name="TextBox 46"/>
+          <p:cNvPr id="46" name="TextBox 45"/>
           <p:cNvSpPr txBox="1"/>
           <p:nvPr/>
         </p:nvSpPr>
@@ -21475,33 +21283,9 @@
           <a:p/>
         </p:txBody>
       </p:sp>
-      <p:pic>
-        <p:nvPicPr>
-          <p:cNvPr id="3" name="Picture 2" descr="image.png"/>
-          <p:cNvPicPr>
-            <a:picLocks noChangeAspect="1"/>
-          </p:cNvPicPr>
-          <p:nvPr/>
-        </p:nvPicPr>
-        <p:blipFill>
-          <a:blip r:embed="rId2"/>
-          <a:stretch>
-            <a:fillRect/>
-          </a:stretch>
-        </p:blipFill>
-        <p:spPr>
-          <a:xfrm>
-            <a:off x="9893808" y="6163056"/>
-            <a:ext cx="1938528" cy="621792"/>
-          </a:xfrm>
-          <a:prstGeom prst="rect">
-            <a:avLst/>
-          </a:prstGeom>
-        </p:spPr>
-      </p:pic>
-      <p:sp>
-        <p:nvSpPr>
-          <p:cNvPr id="4" name="TextBox 3"/>
+      <p:sp>
+        <p:nvSpPr>
+          <p:cNvPr id="3" name="TextBox 2"/>
           <p:cNvSpPr txBox="1"/>
           <p:nvPr/>
         </p:nvSpPr>
@@ -21535,7 +21319,7 @@
       </p:sp>
       <p:sp>
         <p:nvSpPr>
-          <p:cNvPr id="5" name="TextBox 4"/>
+          <p:cNvPr id="4" name="TextBox 3"/>
           <p:cNvSpPr txBox="1"/>
           <p:nvPr/>
         </p:nvSpPr>
@@ -21569,7 +21353,7 @@
       </p:sp>
       <p:cxnSp>
         <p:nvCxnSpPr>
-          <p:cNvPr id="6" name="Connector 5"/>
+          <p:cNvPr id="5" name="Connector 4"/>
           <p:cNvCxnSpPr/>
           <p:nvPr/>
         </p:nvCxnSpPr>
@@ -21604,7 +21388,7 @@
       </p:cxnSp>
       <p:sp>
         <p:nvSpPr>
-          <p:cNvPr id="7" name="TextBox 6"/>
+          <p:cNvPr id="6" name="TextBox 5"/>
           <p:cNvSpPr txBox="1"/>
           <p:nvPr/>
         </p:nvSpPr>
@@ -21638,7 +21422,7 @@
       </p:sp>
       <p:graphicFrame>
         <p:nvGraphicFramePr>
-          <p:cNvPr id="8" name="Table 7"/>
+          <p:cNvPr id="7" name="Table 6"/>
           <p:cNvGraphicFramePr>
             <a:graphicFrameLocks noGrp="1"/>
           </p:cNvGraphicFramePr>
@@ -22206,7 +21990,7 @@
       </p:graphicFrame>
       <p:sp>
         <p:nvSpPr>
-          <p:cNvPr id="9" name="TextBox 8"/>
+          <p:cNvPr id="8" name="TextBox 7"/>
           <p:cNvSpPr txBox="1"/>
           <p:nvPr/>
         </p:nvSpPr>
@@ -22240,7 +22024,7 @@
       </p:sp>
       <p:graphicFrame>
         <p:nvGraphicFramePr>
-          <p:cNvPr id="10" name="Table 9"/>
+          <p:cNvPr id="9" name="Table 8"/>
           <p:cNvGraphicFramePr>
             <a:graphicFrameLocks noGrp="1"/>
           </p:cNvGraphicFramePr>
@@ -22672,7 +22456,7 @@
       </p:graphicFrame>
       <p:sp>
         <p:nvSpPr>
-          <p:cNvPr id="11" name="TextBox 10"/>
+          <p:cNvPr id="10" name="TextBox 9"/>
           <p:cNvSpPr txBox="1"/>
           <p:nvPr/>
         </p:nvSpPr>
@@ -22769,33 +22553,9 @@
           <a:p/>
         </p:txBody>
       </p:sp>
-      <p:pic>
-        <p:nvPicPr>
-          <p:cNvPr id="3" name="Picture 2" descr="image.png"/>
-          <p:cNvPicPr>
-            <a:picLocks noChangeAspect="1"/>
-          </p:cNvPicPr>
-          <p:nvPr/>
-        </p:nvPicPr>
-        <p:blipFill>
-          <a:blip r:embed="rId2"/>
-          <a:stretch>
-            <a:fillRect/>
-          </a:stretch>
-        </p:blipFill>
-        <p:spPr>
-          <a:xfrm>
-            <a:off x="9893808" y="6163056"/>
-            <a:ext cx="1938528" cy="621792"/>
-          </a:xfrm>
-          <a:prstGeom prst="rect">
-            <a:avLst/>
-          </a:prstGeom>
-        </p:spPr>
-      </p:pic>
-      <p:sp>
-        <p:nvSpPr>
-          <p:cNvPr id="4" name="TextBox 3"/>
+      <p:sp>
+        <p:nvSpPr>
+          <p:cNvPr id="3" name="TextBox 2"/>
           <p:cNvSpPr txBox="1"/>
           <p:nvPr/>
         </p:nvSpPr>
@@ -22829,7 +22589,7 @@
       </p:sp>
       <p:sp>
         <p:nvSpPr>
-          <p:cNvPr id="5" name="TextBox 4"/>
+          <p:cNvPr id="4" name="TextBox 3"/>
           <p:cNvSpPr txBox="1"/>
           <p:nvPr/>
         </p:nvSpPr>
@@ -22863,7 +22623,7 @@
       </p:sp>
       <p:cxnSp>
         <p:nvCxnSpPr>
-          <p:cNvPr id="6" name="Connector 5"/>
+          <p:cNvPr id="5" name="Connector 4"/>
           <p:cNvCxnSpPr/>
           <p:nvPr/>
         </p:nvCxnSpPr>
@@ -22898,7 +22658,7 @@
       </p:cxnSp>
       <p:sp>
         <p:nvSpPr>
-          <p:cNvPr id="7" name="Rectangle 6"/>
+          <p:cNvPr id="6" name="Rectangle 5"/>
           <p:cNvSpPr/>
           <p:nvPr/>
         </p:nvSpPr>
@@ -22944,7 +22704,7 @@
       </p:sp>
       <p:sp>
         <p:nvSpPr>
-          <p:cNvPr id="8" name="Rectangle 7"/>
+          <p:cNvPr id="7" name="Rectangle 6"/>
           <p:cNvSpPr/>
           <p:nvPr/>
         </p:nvSpPr>
@@ -22988,7 +22748,7 @@
       </p:sp>
       <p:sp>
         <p:nvSpPr>
-          <p:cNvPr id="9" name="TextBox 8"/>
+          <p:cNvPr id="8" name="TextBox 7"/>
           <p:cNvSpPr txBox="1"/>
           <p:nvPr/>
         </p:nvSpPr>
@@ -23022,7 +22782,7 @@
       </p:sp>
       <p:sp>
         <p:nvSpPr>
-          <p:cNvPr id="10" name="TextBox 9"/>
+          <p:cNvPr id="9" name="TextBox 8"/>
           <p:cNvSpPr txBox="1"/>
           <p:nvPr/>
         </p:nvSpPr>
@@ -23061,7 +22821,7 @@
       </p:sp>
       <p:sp>
         <p:nvSpPr>
-          <p:cNvPr id="11" name="Rectangle 10"/>
+          <p:cNvPr id="10" name="Rectangle 9"/>
           <p:cNvSpPr/>
           <p:nvPr/>
         </p:nvSpPr>
@@ -23107,7 +22867,7 @@
       </p:sp>
       <p:sp>
         <p:nvSpPr>
-          <p:cNvPr id="12" name="Rectangle 11"/>
+          <p:cNvPr id="11" name="Rectangle 10"/>
           <p:cNvSpPr/>
           <p:nvPr/>
         </p:nvSpPr>
@@ -23151,7 +22911,7 @@
       </p:sp>
       <p:sp>
         <p:nvSpPr>
-          <p:cNvPr id="13" name="TextBox 12"/>
+          <p:cNvPr id="12" name="TextBox 11"/>
           <p:cNvSpPr txBox="1"/>
           <p:nvPr/>
         </p:nvSpPr>
@@ -23185,7 +22945,7 @@
       </p:sp>
       <p:sp>
         <p:nvSpPr>
-          <p:cNvPr id="14" name="TextBox 13"/>
+          <p:cNvPr id="13" name="TextBox 12"/>
           <p:cNvSpPr txBox="1"/>
           <p:nvPr/>
         </p:nvSpPr>
@@ -23224,7 +22984,7 @@
       </p:sp>
       <p:sp>
         <p:nvSpPr>
-          <p:cNvPr id="15" name="Rectangle 14"/>
+          <p:cNvPr id="14" name="Rectangle 13"/>
           <p:cNvSpPr/>
           <p:nvPr/>
         </p:nvSpPr>
@@ -23270,7 +23030,7 @@
       </p:sp>
       <p:sp>
         <p:nvSpPr>
-          <p:cNvPr id="16" name="Rectangle 15"/>
+          <p:cNvPr id="15" name="Rectangle 14"/>
           <p:cNvSpPr/>
           <p:nvPr/>
         </p:nvSpPr>
@@ -23314,7 +23074,7 @@
       </p:sp>
       <p:sp>
         <p:nvSpPr>
-          <p:cNvPr id="17" name="TextBox 16"/>
+          <p:cNvPr id="16" name="TextBox 15"/>
           <p:cNvSpPr txBox="1"/>
           <p:nvPr/>
         </p:nvSpPr>
@@ -23348,7 +23108,7 @@
       </p:sp>
       <p:sp>
         <p:nvSpPr>
-          <p:cNvPr id="18" name="TextBox 17"/>
+          <p:cNvPr id="17" name="TextBox 16"/>
           <p:cNvSpPr txBox="1"/>
           <p:nvPr/>
         </p:nvSpPr>
@@ -23387,7 +23147,7 @@
       </p:sp>
       <p:sp>
         <p:nvSpPr>
-          <p:cNvPr id="19" name="TextBox 18"/>
+          <p:cNvPr id="18" name="TextBox 17"/>
           <p:cNvSpPr txBox="1"/>
           <p:nvPr/>
         </p:nvSpPr>
@@ -23421,7 +23181,7 @@
       </p:sp>
       <p:graphicFrame>
         <p:nvGraphicFramePr>
-          <p:cNvPr id="20" name="Table 19"/>
+          <p:cNvPr id="19" name="Table 18"/>
           <p:cNvGraphicFramePr>
             <a:graphicFrameLocks noGrp="1"/>
           </p:cNvGraphicFramePr>
@@ -23989,7 +23749,7 @@
       </p:graphicFrame>
       <p:sp>
         <p:nvSpPr>
-          <p:cNvPr id="21" name="TextBox 20"/>
+          <p:cNvPr id="20" name="TextBox 19"/>
           <p:cNvSpPr txBox="1"/>
           <p:nvPr/>
         </p:nvSpPr>
@@ -24086,33 +23846,9 @@
           <a:p/>
         </p:txBody>
       </p:sp>
-      <p:pic>
-        <p:nvPicPr>
-          <p:cNvPr id="3" name="Picture 2" descr="image.png"/>
-          <p:cNvPicPr>
-            <a:picLocks noChangeAspect="1"/>
-          </p:cNvPicPr>
-          <p:nvPr/>
-        </p:nvPicPr>
-        <p:blipFill>
-          <a:blip r:embed="rId2"/>
-          <a:stretch>
-            <a:fillRect/>
-          </a:stretch>
-        </p:blipFill>
-        <p:spPr>
-          <a:xfrm>
-            <a:off x="9893808" y="6163056"/>
-            <a:ext cx="1938528" cy="621792"/>
-          </a:xfrm>
-          <a:prstGeom prst="rect">
-            <a:avLst/>
-          </a:prstGeom>
-        </p:spPr>
-      </p:pic>
-      <p:sp>
-        <p:nvSpPr>
-          <p:cNvPr id="4" name="TextBox 3"/>
+      <p:sp>
+        <p:nvSpPr>
+          <p:cNvPr id="3" name="TextBox 2"/>
           <p:cNvSpPr txBox="1"/>
           <p:nvPr/>
         </p:nvSpPr>
@@ -24146,7 +23882,7 @@
       </p:sp>
       <p:sp>
         <p:nvSpPr>
-          <p:cNvPr id="5" name="TextBox 4"/>
+          <p:cNvPr id="4" name="TextBox 3"/>
           <p:cNvSpPr txBox="1"/>
           <p:nvPr/>
         </p:nvSpPr>
@@ -24173,14 +23909,14 @@
                 </a:solidFill>
                 <a:latin typeface="Cambria"/>
               </a:rPr>
-              <a:t>Metrics: Definitions</a:t>
+              <a:t>Metrics: Formal Definitions</a:t>
             </a:r>
           </a:p>
         </p:txBody>
       </p:sp>
       <p:cxnSp>
         <p:nvCxnSpPr>
-          <p:cNvPr id="6" name="Connector 5"/>
+          <p:cNvPr id="5" name="Connector 4"/>
           <p:cNvCxnSpPr/>
           <p:nvPr/>
         </p:nvCxnSpPr>
@@ -24213,17 +23949,457 @@
           </a:fontRef>
         </p:style>
       </p:cxnSp>
+      <p:sp>
+        <p:nvSpPr>
+          <p:cNvPr id="6" name="TextBox 5"/>
+          <p:cNvSpPr txBox="1"/>
+          <p:nvPr/>
+        </p:nvSpPr>
+        <p:spPr>
+          <a:xfrm>
+            <a:off x="594360" y="1554480"/>
+            <a:ext cx="4892040" cy="219456"/>
+          </a:xfrm>
+          <a:prstGeom prst="rect">
+            <a:avLst/>
+          </a:prstGeom>
+          <a:noFill/>
+        </p:spPr>
+        <p:txBody>
+          <a:bodyPr wrap="square" anchor="t" lIns="0" rIns="0" tIns="0" bIns="0">
+            <a:spAutoFit/>
+          </a:bodyPr>
+          <a:lstStyle/>
+          <a:p>
+            <a:r>
+              <a:rPr sz="900" b="1" i="0" spc="150">
+                <a:solidFill>
+                  <a:srgbClr val="B6114D"/>
+                </a:solidFill>
+                <a:latin typeface="Calibri"/>
+              </a:rPr>
+              <a:t>BASIS — PER-CLASS CONFUSION COUNTS</a:t>
+            </a:r>
+          </a:p>
+        </p:txBody>
+      </p:sp>
+      <p:sp>
+        <p:nvSpPr>
+          <p:cNvPr id="7" name="Rectangle 6"/>
+          <p:cNvSpPr/>
+          <p:nvPr/>
+        </p:nvSpPr>
+        <p:spPr>
+          <a:xfrm>
+            <a:off x="594360" y="1792224"/>
+            <a:ext cx="4892040" cy="1060704"/>
+          </a:xfrm>
+          <a:prstGeom prst="rect">
+            <a:avLst/>
+          </a:prstGeom>
+          <a:solidFill>
+            <a:srgbClr val="F7F4F5"/>
+          </a:solidFill>
+          <a:ln w="12700">
+            <a:solidFill>
+              <a:srgbClr val="E4D9DD"/>
+            </a:solidFill>
+          </a:ln>
+          <a:effectLst/>
+        </p:spPr>
+        <p:style>
+          <a:lnRef idx="1">
+            <a:schemeClr val="accent1"/>
+          </a:lnRef>
+          <a:fillRef idx="3">
+            <a:schemeClr val="accent1"/>
+          </a:fillRef>
+          <a:effectRef idx="2">
+            <a:schemeClr val="accent1"/>
+          </a:effectRef>
+          <a:fontRef idx="minor">
+            <a:schemeClr val="lt1"/>
+          </a:fontRef>
+        </p:style>
+        <p:txBody>
+          <a:bodyPr rtlCol="0" anchor="ctr" wrap="square"/>
+          <a:lstStyle/>
+          <a:p>
+            <a:pPr algn="ctr"/>
+          </a:p>
+        </p:txBody>
+      </p:sp>
+      <p:sp>
+        <p:nvSpPr>
+          <p:cNvPr id="8" name="TextBox 7"/>
+          <p:cNvSpPr txBox="1"/>
+          <p:nvPr/>
+        </p:nvSpPr>
+        <p:spPr>
+          <a:xfrm>
+            <a:off x="822960" y="1901952"/>
+            <a:ext cx="4480560" cy="877824"/>
+          </a:xfrm>
+          <a:prstGeom prst="rect">
+            <a:avLst/>
+          </a:prstGeom>
+          <a:noFill/>
+        </p:spPr>
+        <p:txBody>
+          <a:bodyPr wrap="square" anchor="t" lIns="0" rIns="0" tIns="0" bIns="0">
+            <a:spAutoFit/>
+          </a:bodyPr>
+          <a:lstStyle/>
+          <a:p>
+            <a:pPr>
+              <a:lnSpc>
+                <a:spcPct val="118000"/>
+              </a:lnSpc>
+            </a:pPr>
+            <a:r>
+              <a:rPr sz="1050" b="1" i="0">
+                <a:solidFill>
+                  <a:srgbClr val="B6114D"/>
+                </a:solidFill>
+                <a:latin typeface="Consolas"/>
+              </a:rPr>
+              <a:t>TP  </a:t>
+            </a:r>
+            <a:r>
+              <a:rPr sz="1000" b="0" i="0">
+                <a:solidFill>
+                  <a:srgbClr val="5A5A5A"/>
+                </a:solidFill>
+                <a:latin typeface="Calibri"/>
+              </a:rPr>
+              <a:t>predicted class c, and truly class c</a:t>
+            </a:r>
+          </a:p>
+          <a:p>
+            <a:pPr>
+              <a:lnSpc>
+                <a:spcPct val="118000"/>
+              </a:lnSpc>
+            </a:pPr>
+            <a:r>
+              <a:rPr sz="1050" b="1" i="0">
+                <a:solidFill>
+                  <a:srgbClr val="B6114D"/>
+                </a:solidFill>
+                <a:latin typeface="Consolas"/>
+              </a:rPr>
+              <a:t>FP  </a:t>
+            </a:r>
+            <a:r>
+              <a:rPr sz="1000" b="0" i="0">
+                <a:solidFill>
+                  <a:srgbClr val="5A5A5A"/>
+                </a:solidFill>
+                <a:latin typeface="Calibri"/>
+              </a:rPr>
+              <a:t>predicted class c, but actually another class</a:t>
+            </a:r>
+          </a:p>
+          <a:p>
+            <a:pPr>
+              <a:lnSpc>
+                <a:spcPct val="118000"/>
+              </a:lnSpc>
+            </a:pPr>
+            <a:r>
+              <a:rPr sz="1050" b="1" i="0">
+                <a:solidFill>
+                  <a:srgbClr val="B6114D"/>
+                </a:solidFill>
+                <a:latin typeface="Consolas"/>
+              </a:rPr>
+              <a:t>FN  </a:t>
+            </a:r>
+            <a:r>
+              <a:rPr sz="1000" b="0" i="0">
+                <a:solidFill>
+                  <a:srgbClr val="5A5A5A"/>
+                </a:solidFill>
+                <a:latin typeface="Calibri"/>
+              </a:rPr>
+              <a:t>truly class c, but predicted as another</a:t>
+            </a:r>
+          </a:p>
+          <a:p>
+            <a:pPr>
+              <a:lnSpc>
+                <a:spcPct val="118000"/>
+              </a:lnSpc>
+            </a:pPr>
+            <a:r>
+              <a:rPr sz="1050" b="1" i="0">
+                <a:solidFill>
+                  <a:srgbClr val="B6114D"/>
+                </a:solidFill>
+                <a:latin typeface="Consolas"/>
+              </a:rPr>
+              <a:t>TN  </a:t>
+            </a:r>
+            <a:r>
+              <a:rPr sz="1000" b="0" i="0">
+                <a:solidFill>
+                  <a:srgbClr val="5A5A5A"/>
+                </a:solidFill>
+                <a:latin typeface="Calibri"/>
+              </a:rPr>
+              <a:t>neither predicted nor truly class c</a:t>
+            </a:r>
+          </a:p>
+        </p:txBody>
+      </p:sp>
+      <p:sp>
+        <p:nvSpPr>
+          <p:cNvPr id="9" name="TextBox 8"/>
+          <p:cNvSpPr txBox="1"/>
+          <p:nvPr/>
+        </p:nvSpPr>
+        <p:spPr>
+          <a:xfrm>
+            <a:off x="5669280" y="1554480"/>
+            <a:ext cx="5349240" cy="219456"/>
+          </a:xfrm>
+          <a:prstGeom prst="rect">
+            <a:avLst/>
+          </a:prstGeom>
+          <a:noFill/>
+        </p:spPr>
+        <p:txBody>
+          <a:bodyPr wrap="square" anchor="t" lIns="0" rIns="0" tIns="0" bIns="0">
+            <a:spAutoFit/>
+          </a:bodyPr>
+          <a:lstStyle/>
+          <a:p>
+            <a:r>
+              <a:rPr sz="900" b="1" i="0" spc="150">
+                <a:solidFill>
+                  <a:srgbClr val="086072"/>
+                </a:solidFill>
+                <a:latin typeface="Calibri"/>
+              </a:rPr>
+              <a:t>NOTATION</a:t>
+            </a:r>
+          </a:p>
+        </p:txBody>
+      </p:sp>
+      <p:sp>
+        <p:nvSpPr>
+          <p:cNvPr id="10" name="Rectangle 9"/>
+          <p:cNvSpPr/>
+          <p:nvPr/>
+        </p:nvSpPr>
+        <p:spPr>
+          <a:xfrm>
+            <a:off x="5669280" y="1792224"/>
+            <a:ext cx="5349240" cy="1060704"/>
+          </a:xfrm>
+          <a:prstGeom prst="rect">
+            <a:avLst/>
+          </a:prstGeom>
+          <a:solidFill>
+            <a:srgbClr val="F7F4F5"/>
+          </a:solidFill>
+          <a:ln w="12700">
+            <a:solidFill>
+              <a:srgbClr val="E4D9DD"/>
+            </a:solidFill>
+          </a:ln>
+          <a:effectLst/>
+        </p:spPr>
+        <p:style>
+          <a:lnRef idx="1">
+            <a:schemeClr val="accent1"/>
+          </a:lnRef>
+          <a:fillRef idx="3">
+            <a:schemeClr val="accent1"/>
+          </a:fillRef>
+          <a:effectRef idx="2">
+            <a:schemeClr val="accent1"/>
+          </a:effectRef>
+          <a:fontRef idx="minor">
+            <a:schemeClr val="lt1"/>
+          </a:fontRef>
+        </p:style>
+        <p:txBody>
+          <a:bodyPr rtlCol="0" anchor="ctr" wrap="square"/>
+          <a:lstStyle/>
+          <a:p>
+            <a:pPr algn="ctr"/>
+          </a:p>
+        </p:txBody>
+      </p:sp>
+      <p:sp>
+        <p:nvSpPr>
+          <p:cNvPr id="11" name="TextBox 10"/>
+          <p:cNvSpPr txBox="1"/>
+          <p:nvPr/>
+        </p:nvSpPr>
+        <p:spPr>
+          <a:xfrm>
+            <a:off x="5897880" y="1901952"/>
+            <a:ext cx="4937760" cy="877824"/>
+          </a:xfrm>
+          <a:prstGeom prst="rect">
+            <a:avLst/>
+          </a:prstGeom>
+          <a:noFill/>
+        </p:spPr>
+        <p:txBody>
+          <a:bodyPr wrap="square" anchor="t" lIns="0" rIns="0" tIns="0" bIns="0">
+            <a:spAutoFit/>
+          </a:bodyPr>
+          <a:lstStyle/>
+          <a:p>
+            <a:pPr>
+              <a:lnSpc>
+                <a:spcPct val="118000"/>
+              </a:lnSpc>
+            </a:pPr>
+            <a:r>
+              <a:rPr sz="1050" b="1" i="0">
+                <a:solidFill>
+                  <a:srgbClr val="086072"/>
+                </a:solidFill>
+                <a:latin typeface="Consolas"/>
+              </a:rPr>
+              <a:t>N  </a:t>
+            </a:r>
+            <a:r>
+              <a:rPr sz="1000" b="0" i="0">
+                <a:solidFill>
+                  <a:srgbClr val="5A5A5A"/>
+                </a:solidFill>
+                <a:latin typeface="Calibri"/>
+              </a:rPr>
+              <a:t>number of classes  =  261</a:t>
+            </a:r>
+          </a:p>
+          <a:p>
+            <a:pPr>
+              <a:lnSpc>
+                <a:spcPct val="118000"/>
+              </a:lnSpc>
+            </a:pPr>
+            <a:r>
+              <a:rPr sz="1050" b="1" i="0">
+                <a:solidFill>
+                  <a:srgbClr val="086072"/>
+                </a:solidFill>
+                <a:latin typeface="Consolas"/>
+              </a:rPr>
+              <a:t>n  </a:t>
+            </a:r>
+            <a:r>
+              <a:rPr sz="1000" b="0" i="0">
+                <a:solidFill>
+                  <a:srgbClr val="5A5A5A"/>
+                </a:solidFill>
+                <a:latin typeface="Calibri"/>
+              </a:rPr>
+              <a:t>number of test samples  =  642</a:t>
+            </a:r>
+          </a:p>
+          <a:p>
+            <a:pPr>
+              <a:lnSpc>
+                <a:spcPct val="118000"/>
+              </a:lnSpc>
+            </a:pPr>
+            <a:r>
+              <a:rPr sz="1050" b="1" i="0">
+                <a:solidFill>
+                  <a:srgbClr val="086072"/>
+                </a:solidFill>
+                <a:latin typeface="Consolas"/>
+              </a:rPr>
+              <a:t>c  </a:t>
+            </a:r>
+            <a:r>
+              <a:rPr sz="1000" b="0" i="0">
+                <a:solidFill>
+                  <a:srgbClr val="5A5A5A"/>
+                </a:solidFill>
+                <a:latin typeface="Calibri"/>
+              </a:rPr>
+              <a:t>index over classes,  c = 1 … N</a:t>
+            </a:r>
+          </a:p>
+          <a:p>
+            <a:pPr>
+              <a:lnSpc>
+                <a:spcPct val="118000"/>
+              </a:lnSpc>
+            </a:pPr>
+            <a:r>
+              <a:rPr sz="1050" b="1" i="0">
+                <a:solidFill>
+                  <a:srgbClr val="086072"/>
+                </a:solidFill>
+                <a:latin typeface="Consolas"/>
+              </a:rPr>
+              <a:t>1[·]  </a:t>
+            </a:r>
+            <a:r>
+              <a:rPr sz="1000" b="0" i="0">
+                <a:solidFill>
+                  <a:srgbClr val="5A5A5A"/>
+                </a:solidFill>
+                <a:latin typeface="Calibri"/>
+              </a:rPr>
+              <a:t>indicator: 1 if the condition holds, else 0</a:t>
+            </a:r>
+          </a:p>
+        </p:txBody>
+      </p:sp>
+      <p:sp>
+        <p:nvSpPr>
+          <p:cNvPr id="12" name="TextBox 11"/>
+          <p:cNvSpPr txBox="1"/>
+          <p:nvPr/>
+        </p:nvSpPr>
+        <p:spPr>
+          <a:xfrm>
+            <a:off x="594360" y="2980944"/>
+            <a:ext cx="10424160" cy="219456"/>
+          </a:xfrm>
+          <a:prstGeom prst="rect">
+            <a:avLst/>
+          </a:prstGeom>
+          <a:noFill/>
+        </p:spPr>
+        <p:txBody>
+          <a:bodyPr wrap="square" anchor="t" lIns="0" rIns="0" tIns="0" bIns="0">
+            <a:spAutoFit/>
+          </a:bodyPr>
+          <a:lstStyle/>
+          <a:p>
+            <a:r>
+              <a:rPr sz="900" b="1" i="0" spc="150">
+                <a:solidFill>
+                  <a:srgbClr val="B6114D"/>
+                </a:solidFill>
+                <a:latin typeface="Calibri"/>
+              </a:rPr>
+              <a:t>METRICS REPORTED</a:t>
+            </a:r>
+          </a:p>
+        </p:txBody>
+      </p:sp>
       <p:graphicFrame>
         <p:nvGraphicFramePr>
-          <p:cNvPr id="7" name="Table 6"/>
+          <p:cNvPr id="13" name="Table 12"/>
           <p:cNvGraphicFramePr>
             <a:graphicFrameLocks noGrp="1"/>
           </p:cNvGraphicFramePr>
           <p:nvPr/>
         </p:nvGraphicFramePr>
         <p:xfrm>
-          <a:off x="502920" y="1645920"/>
-          <a:ext cx="11155680" cy="4206240"/>
+          <a:off x="594360" y="3218688"/>
+          <a:ext cx="10424160" cy="2596896"/>
         </p:xfrm>
         <a:graphic>
           <a:graphicData uri="http://schemas.openxmlformats.org/drawingml/2006/table">
@@ -24232,11 +24408,11 @@
                 <a:tableStyleId>{5C22544A-7EE6-4342-B048-85BDC9FD1C3A}</a:tableStyleId>
               </a:tblPr>
               <a:tblGrid>
-                <a:gridCol w="1691640"/>
-                <a:gridCol w="4343400"/>
-                <a:gridCol w="5120640"/>
+                <a:gridCol w="1965960"/>
+                <a:gridCol w="3611880"/>
+                <a:gridCol w="4846320"/>
               </a:tblGrid>
-              <a:tr h="329184">
+              <a:tr h="292608">
                 <a:tc>
                   <a:txBody>
                     <a:bodyPr wrap="square"/>
@@ -24271,7 +24447,7 @@
                           </a:solidFill>
                           <a:latin typeface="Calibri"/>
                         </a:rPr>
-                        <a:t>Definition</a:t>
+                        <a:t>Formula</a:t>
                       </a:r>
                     </a:p>
                   </a:txBody>
@@ -24293,7 +24469,7 @@
                           </a:solidFill>
                           <a:latin typeface="Calibri"/>
                         </a:rPr>
-                        <a:t>Why it is reported here</a:t>
+                        <a:t>What it captures / why reported</a:t>
                       </a:r>
                     </a:p>
                   </a:txBody>
@@ -24304,7 +24480,7 @@
                   </a:tcPr>
                 </a:tc>
               </a:tr>
-              <a:tr h="484632">
+              <a:tr h="256032">
                 <a:tc>
                   <a:txBody>
                     <a:bodyPr wrap="square"/>
@@ -24317,7 +24493,7 @@
                           </a:solidFill>
                           <a:latin typeface="Calibri"/>
                         </a:rPr>
-                        <a:t>Test accuracy</a:t>
+                        <a:t>Accuracy</a:t>
                       </a:r>
                     </a:p>
                   </a:txBody>
@@ -24339,7 +24515,7 @@
                           </a:solidFill>
                           <a:latin typeface="Calibri"/>
                         </a:rPr>
-                        <a:t>Correct predictions ÷ total predictions on the held-out test split.</a:t>
+                        <a:t>(TP + TN) / (TP + TN + FP + FN)</a:t>
                       </a:r>
                     </a:p>
                   </a:txBody>
@@ -24361,7 +24537,7 @@
                           </a:solidFill>
                           <a:latin typeface="Calibri"/>
                         </a:rPr>
-                        <a:t>Headline number, but misleading alone when class counts are uneven.</a:t>
+                        <a:t>Overall correctness. Misleading alone when class support is uneven.</a:t>
                       </a:r>
                     </a:p>
                   </a:txBody>
@@ -24372,7 +24548,7 @@
                   </a:tcPr>
                 </a:tc>
               </a:tr>
-              <a:tr h="484632">
+              <a:tr h="256032">
                 <a:tc>
                   <a:txBody>
                     <a:bodyPr wrap="square"/>
@@ -24385,7 +24561,7 @@
                           </a:solidFill>
                           <a:latin typeface="Calibri"/>
                         </a:rPr>
-                        <a:t>Macro F1</a:t>
+                        <a:t>Precision  (Pᶜ)</a:t>
                       </a:r>
                     </a:p>
                   </a:txBody>
@@ -24407,7 +24583,7 @@
                           </a:solidFill>
                           <a:latin typeface="Calibri"/>
                         </a:rPr>
-                        <a:t>Unweighted mean of per-class F1 = 2PR / (P + R).</a:t>
+                        <a:t>TPᶜ / (TPᶜ + FPᶜ)</a:t>
                       </a:r>
                     </a:p>
                   </a:txBody>
@@ -24429,7 +24605,7 @@
                           </a:solidFill>
                           <a:latin typeface="Calibri"/>
                         </a:rPr>
-                        <a:t>Treats a rare sign as equally important as a common one — the honest score for an imbalanced vocabulary.</a:t>
+                        <a:t>Of everything called class c, how much really was c.</a:t>
                       </a:r>
                     </a:p>
                   </a:txBody>
@@ -24440,7 +24616,7 @@
                   </a:tcPr>
                 </a:tc>
               </a:tr>
-              <a:tr h="484632">
+              <a:tr h="256032">
                 <a:tc>
                   <a:txBody>
                     <a:bodyPr wrap="square"/>
@@ -24453,7 +24629,7 @@
                           </a:solidFill>
                           <a:latin typeface="Calibri"/>
                         </a:rPr>
-                        <a:t>Weighted F1</a:t>
+                        <a:t>Recall  (Rᶜ)</a:t>
                       </a:r>
                     </a:p>
                   </a:txBody>
@@ -24475,7 +24651,7 @@
                           </a:solidFill>
                           <a:latin typeface="Calibri"/>
                         </a:rPr>
-                        <a:t>Per-class F1 averaged in proportion to class support.</a:t>
+                        <a:t>TPᶜ / (TPᶜ + FNᶜ)</a:t>
                       </a:r>
                     </a:p>
                   </a:txBody>
@@ -24497,7 +24673,7 @@
                           </a:solidFill>
                           <a:latin typeface="Calibri"/>
                         </a:rPr>
-                        <a:t>Reflects performance a user experiences if signs occur at their natural frequency.</a:t>
+                        <a:t>Of all true c, how much the model actually found.</a:t>
                       </a:r>
                     </a:p>
                   </a:txBody>
@@ -24508,7 +24684,7 @@
                   </a:tcPr>
                 </a:tc>
               </a:tr>
-              <a:tr h="484632">
+              <a:tr h="256032">
                 <a:tc>
                   <a:txBody>
                     <a:bodyPr wrap="square"/>
@@ -24521,7 +24697,7 @@
                           </a:solidFill>
                           <a:latin typeface="Calibri"/>
                         </a:rPr>
-                        <a:t>Top-k accuracy</a:t>
+                        <a:t>F1  (per class)</a:t>
                       </a:r>
                     </a:p>
                   </a:txBody>
@@ -24543,7 +24719,7 @@
                           </a:solidFill>
                           <a:latin typeface="Calibri"/>
                         </a:rPr>
-                        <a:t>Fraction of samples whose true label falls in the k highest-probability classes.</a:t>
+                        <a:t>2 · Pᶜ · Rᶜ / (Pᶜ + Rᶜ)</a:t>
                       </a:r>
                     </a:p>
                   </a:txBody>
@@ -24565,7 +24741,7 @@
                           </a:solidFill>
                           <a:latin typeface="Calibri"/>
                         </a:rPr>
-                        <a:t>Directly models the correction-chip UX: the user is offered the top candidates, not just one.</a:t>
+                        <a:t>Harmonic mean — punishes a model that trades one for the other.</a:t>
                       </a:r>
                     </a:p>
                   </a:txBody>
@@ -24576,7 +24752,7 @@
                   </a:tcPr>
                 </a:tc>
               </a:tr>
-              <a:tr h="484632">
+              <a:tr h="256032">
                 <a:tc>
                   <a:txBody>
                     <a:bodyPr wrap="square"/>
@@ -24589,7 +24765,7 @@
                           </a:solidFill>
                           <a:latin typeface="Calibri"/>
                         </a:rPr>
-                        <a:t>Per-class F1</a:t>
+                        <a:t>Macro F1</a:t>
                       </a:r>
                     </a:p>
                   </a:txBody>
@@ -24611,7 +24787,7 @@
                           </a:solidFill>
                           <a:latin typeface="Calibri"/>
                         </a:rPr>
-                        <a:t>F1 computed separately for every sign label.</a:t>
+                        <a:t>(1/N) · Σᶜ F1ᶜ</a:t>
                       </a:r>
                     </a:p>
                   </a:txBody>
@@ -24633,7 +24809,7 @@
                           </a:solidFill>
                           <a:latin typeface="Calibri"/>
                         </a:rPr>
-                        <a:t>Surfaces which specific signs fail — the actionable diagnostic.</a:t>
+                        <a:t>Unweighted class mean: a rare sign counts as much as a common one.</a:t>
                       </a:r>
                     </a:p>
                   </a:txBody>
@@ -24644,7 +24820,7 @@
                   </a:tcPr>
                 </a:tc>
               </a:tr>
-              <a:tr h="484632">
+              <a:tr h="256032">
                 <a:tc>
                   <a:txBody>
                     <a:bodyPr wrap="square"/>
@@ -24657,7 +24833,7 @@
                           </a:solidFill>
                           <a:latin typeface="Calibri"/>
                         </a:rPr>
-                        <a:t>Confusion matrix</a:t>
+                        <a:t>Weighted F1</a:t>
                       </a:r>
                     </a:p>
                   </a:txBody>
@@ -24679,7 +24855,7 @@
                           </a:solidFill>
                           <a:latin typeface="Calibri"/>
                         </a:rPr>
-                        <a:t>Row-normalised matrix of true label against predicted label.</a:t>
+                        <a:t>Σᶜ (supportᶜ / n) · F1ᶜ</a:t>
                       </a:r>
                     </a:p>
                   </a:txBody>
@@ -24701,7 +24877,7 @@
                           </a:solidFill>
                           <a:latin typeface="Calibri"/>
                         </a:rPr>
-                        <a:t>Shows whether errors are random or concentrated between visually similar signs.</a:t>
+                        <a:t>Weighted by class frequency — what a typical user experiences.</a:t>
                       </a:r>
                     </a:p>
                   </a:txBody>
@@ -24712,7 +24888,143 @@
                   </a:tcPr>
                 </a:tc>
               </a:tr>
-              <a:tr h="484632">
+              <a:tr h="256032">
+                <a:tc>
+                  <a:txBody>
+                    <a:bodyPr wrap="square"/>
+                    <a:lstStyle/>
+                    <a:p>
+                      <a:r>
+                        <a:rPr sz="950" b="1" i="0">
+                          <a:solidFill>
+                            <a:srgbClr val="222222"/>
+                          </a:solidFill>
+                          <a:latin typeface="Calibri"/>
+                        </a:rPr>
+                        <a:t>Top-k accuracy</a:t>
+                      </a:r>
+                    </a:p>
+                  </a:txBody>
+                  <a:tcPr marL="82296" marR="82296" marT="27432" marB="27432" anchor="ctr">
+                    <a:solidFill>
+                      <a:srgbClr val="FFFFFF"/>
+                    </a:solidFill>
+                  </a:tcPr>
+                </a:tc>
+                <a:tc>
+                  <a:txBody>
+                    <a:bodyPr wrap="square"/>
+                    <a:lstStyle/>
+                    <a:p>
+                      <a:r>
+                        <a:rPr sz="950" b="0" i="0">
+                          <a:solidFill>
+                            <a:srgbClr val="222222"/>
+                          </a:solidFill>
+                          <a:latin typeface="Calibri"/>
+                        </a:rPr>
+                        <a:t>(1/n) · Σᵢ 1[ yᵢ ∈ top-k( pᵢ ) ]</a:t>
+                      </a:r>
+                    </a:p>
+                  </a:txBody>
+                  <a:tcPr marL="82296" marR="82296" marT="27432" marB="27432" anchor="ctr">
+                    <a:solidFill>
+                      <a:srgbClr val="FFFFFF"/>
+                    </a:solidFill>
+                  </a:tcPr>
+                </a:tc>
+                <a:tc>
+                  <a:txBody>
+                    <a:bodyPr wrap="square"/>
+                    <a:lstStyle/>
+                    <a:p>
+                      <a:r>
+                        <a:rPr sz="950" b="0" i="0">
+                          <a:solidFill>
+                            <a:srgbClr val="222222"/>
+                          </a:solidFill>
+                          <a:latin typeface="Calibri"/>
+                        </a:rPr>
+                        <a:t>Models the correction-chip UX: k candidates are offered, not one.</a:t>
+                      </a:r>
+                    </a:p>
+                  </a:txBody>
+                  <a:tcPr marL="82296" marR="82296" marT="27432" marB="27432" anchor="ctr">
+                    <a:solidFill>
+                      <a:srgbClr val="FFFFFF"/>
+                    </a:solidFill>
+                  </a:tcPr>
+                </a:tc>
+              </a:tr>
+              <a:tr h="256032">
+                <a:tc>
+                  <a:txBody>
+                    <a:bodyPr wrap="square"/>
+                    <a:lstStyle/>
+                    <a:p>
+                      <a:r>
+                        <a:rPr sz="950" b="1" i="0">
+                          <a:solidFill>
+                            <a:srgbClr val="222222"/>
+                          </a:solidFill>
+                          <a:latin typeface="Calibri"/>
+                        </a:rPr>
+                        <a:t>Confusion  Cᵢⱼ</a:t>
+                      </a:r>
+                    </a:p>
+                  </a:txBody>
+                  <a:tcPr marL="82296" marR="82296" marT="27432" marB="27432" anchor="ctr">
+                    <a:solidFill>
+                      <a:srgbClr val="F7F4F5"/>
+                    </a:solidFill>
+                  </a:tcPr>
+                </a:tc>
+                <a:tc>
+                  <a:txBody>
+                    <a:bodyPr wrap="square"/>
+                    <a:lstStyle/>
+                    <a:p>
+                      <a:r>
+                        <a:rPr sz="950" b="0" i="0">
+                          <a:solidFill>
+                            <a:srgbClr val="222222"/>
+                          </a:solidFill>
+                          <a:latin typeface="Calibri"/>
+                        </a:rPr>
+                        <a:t>Cᵢⱼ / Σⱼ Cᵢⱼ   (row-normalised)</a:t>
+                      </a:r>
+                    </a:p>
+                  </a:txBody>
+                  <a:tcPr marL="82296" marR="82296" marT="27432" marB="27432" anchor="ctr">
+                    <a:solidFill>
+                      <a:srgbClr val="F7F4F5"/>
+                    </a:solidFill>
+                  </a:tcPr>
+                </a:tc>
+                <a:tc>
+                  <a:txBody>
+                    <a:bodyPr wrap="square"/>
+                    <a:lstStyle/>
+                    <a:p>
+                      <a:r>
+                        <a:rPr sz="950" b="0" i="0">
+                          <a:solidFill>
+                            <a:srgbClr val="222222"/>
+                          </a:solidFill>
+                          <a:latin typeface="Calibri"/>
+                        </a:rPr>
+                        <a:t>Whether errors are random or concentrated on similar signs.</a:t>
+                      </a:r>
+                    </a:p>
+                  </a:txBody>
+                  <a:tcPr marL="82296" marR="82296" marT="27432" marB="27432" anchor="ctr">
+                    <a:solidFill>
+                      <a:srgbClr val="F7F4F5"/>
+                    </a:solidFill>
+                  </a:tcPr>
+                </a:tc>
+              </a:tr>
+              <a:tr h="256032">
                 <a:tc>
                   <a:txBody>
                     <a:bodyPr wrap="square"/>
@@ -24747,7 +25059,7 @@
                           </a:solidFill>
                           <a:latin typeface="Calibri"/>
                         </a:rPr>
-                        <a:t>Wall-clock time for one forward pass, after warm-up.</a:t>
+                        <a:t>mean / 95th percentile of one forward pass</a:t>
                       </a:r>
                     </a:p>
                   </a:txBody>
@@ -24769,7 +25081,7 @@
                           </a:solidFill>
                           <a:latin typeface="Calibri"/>
                         </a:rPr>
-                        <a:t>Real-time viability. p95 matters more than the mean for perceived responsiveness.</a:t>
+                        <a:t>Real-time viability. p95 governs perceived responsiveness.</a:t>
                       </a:r>
                     </a:p>
                   </a:txBody>
@@ -24780,78 +25092,49 @@
                   </a:tcPr>
                 </a:tc>
               </a:tr>
-              <a:tr h="484632">
-                <a:tc>
-                  <a:txBody>
-                    <a:bodyPr wrap="square"/>
-                    <a:lstStyle/>
-                    <a:p>
-                      <a:r>
-                        <a:rPr sz="950" b="1" i="0">
-                          <a:solidFill>
-                            <a:srgbClr val="222222"/>
-                          </a:solidFill>
-                          <a:latin typeface="Calibri"/>
-                        </a:rPr>
-                        <a:t>Parameter count</a:t>
-                      </a:r>
-                    </a:p>
-                  </a:txBody>
-                  <a:tcPr marL="82296" marR="82296" marT="27432" marB="27432" anchor="ctr">
-                    <a:solidFill>
-                      <a:srgbClr val="F7F4F5"/>
-                    </a:solidFill>
-                  </a:tcPr>
-                </a:tc>
-                <a:tc>
-                  <a:txBody>
-                    <a:bodyPr wrap="square"/>
-                    <a:lstStyle/>
-                    <a:p>
-                      <a:r>
-                        <a:rPr sz="950" b="0" i="0">
-                          <a:solidFill>
-                            <a:srgbClr val="222222"/>
-                          </a:solidFill>
-                          <a:latin typeface="Calibri"/>
-                        </a:rPr>
-                        <a:t>Trainable parameters in the model.</a:t>
-                      </a:r>
-                    </a:p>
-                  </a:txBody>
-                  <a:tcPr marL="82296" marR="82296" marT="27432" marB="27432" anchor="ctr">
-                    <a:solidFill>
-                      <a:srgbClr val="F7F4F5"/>
-                    </a:solidFill>
-                  </a:tcPr>
-                </a:tc>
-                <a:tc>
-                  <a:txBody>
-                    <a:bodyPr wrap="square"/>
-                    <a:lstStyle/>
-                    <a:p>
-                      <a:r>
-                        <a:rPr sz="950" b="0" i="0">
-                          <a:solidFill>
-                            <a:srgbClr val="222222"/>
-                          </a:solidFill>
-                          <a:latin typeface="Calibri"/>
-                        </a:rPr>
-                        <a:t>Accuracy per parameter is the fair way to compare models of different sizes.</a:t>
-                      </a:r>
-                    </a:p>
-                  </a:txBody>
-                  <a:tcPr marL="82296" marR="82296" marT="27432" marB="27432" anchor="ctr">
-                    <a:solidFill>
-                      <a:srgbClr val="F7F4F5"/>
-                    </a:solidFill>
-                  </a:tcPr>
-                </a:tc>
-              </a:tr>
             </a:tbl>
           </a:graphicData>
         </a:graphic>
       </p:graphicFrame>
+      <p:sp>
+        <p:nvSpPr>
+          <p:cNvPr id="14" name="TextBox 13"/>
+          <p:cNvSpPr txBox="1"/>
+          <p:nvPr/>
+        </p:nvSpPr>
+        <p:spPr>
+          <a:xfrm>
+            <a:off x="594360" y="5797296"/>
+            <a:ext cx="10424160" cy="274320"/>
+          </a:xfrm>
+          <a:prstGeom prst="rect">
+            <a:avLst/>
+          </a:prstGeom>
+          <a:noFill/>
+        </p:spPr>
+        <p:txBody>
+          <a:bodyPr wrap="square" anchor="t" lIns="0" rIns="0" tIns="0" bIns="0">
+            <a:spAutoFit/>
+          </a:bodyPr>
+          <a:lstStyle/>
+          <a:p>
+            <a:pPr>
+              <a:lnSpc>
+                <a:spcPct val="105000"/>
+              </a:lnSpc>
+            </a:pPr>
+            <a:r>
+              <a:rPr sz="900" b="0" i="1">
+                <a:solidFill>
+                  <a:srgbClr val="5A5A5A"/>
+                </a:solidFill>
+                <a:latin typeface="Calibri"/>
+              </a:rPr>
+              <a:t>Computed by ml/scripts/evaluate.py using sklearn classification_report, top_k_accuracy_score and confusion_matrix on the 642-clip held-out test split.</a:t>
+            </a:r>
+          </a:p>
+        </p:txBody>
+      </p:sp>
     </p:spTree>
   </p:cSld>
   <p:clrMapOvr>
@@ -24912,33 +25195,9 @@
           <a:p/>
         </p:txBody>
       </p:sp>
-      <p:pic>
-        <p:nvPicPr>
-          <p:cNvPr id="3" name="Picture 2" descr="image.png"/>
-          <p:cNvPicPr>
-            <a:picLocks noChangeAspect="1"/>
-          </p:cNvPicPr>
-          <p:nvPr/>
-        </p:nvPicPr>
-        <p:blipFill>
-          <a:blip r:embed="rId2"/>
-          <a:stretch>
-            <a:fillRect/>
-          </a:stretch>
-        </p:blipFill>
-        <p:spPr>
-          <a:xfrm>
-            <a:off x="9893808" y="6163056"/>
-            <a:ext cx="1938528" cy="621792"/>
-          </a:xfrm>
-          <a:prstGeom prst="rect">
-            <a:avLst/>
-          </a:prstGeom>
-        </p:spPr>
-      </p:pic>
-      <p:sp>
-        <p:nvSpPr>
-          <p:cNvPr id="4" name="TextBox 3"/>
+      <p:sp>
+        <p:nvSpPr>
+          <p:cNvPr id="3" name="TextBox 2"/>
           <p:cNvSpPr txBox="1"/>
           <p:nvPr/>
         </p:nvSpPr>
@@ -24972,7 +25231,7 @@
       </p:sp>
       <p:sp>
         <p:nvSpPr>
-          <p:cNvPr id="5" name="TextBox 4"/>
+          <p:cNvPr id="4" name="TextBox 3"/>
           <p:cNvSpPr txBox="1"/>
           <p:nvPr/>
         </p:nvSpPr>
@@ -25006,7 +25265,7 @@
       </p:sp>
       <p:cxnSp>
         <p:nvCxnSpPr>
-          <p:cNvPr id="6" name="Connector 5"/>
+          <p:cNvPr id="5" name="Connector 4"/>
           <p:cNvCxnSpPr/>
           <p:nvPr/>
         </p:nvCxnSpPr>
@@ -25041,7 +25300,7 @@
       </p:cxnSp>
       <p:sp>
         <p:nvSpPr>
-          <p:cNvPr id="7" name="Rectangle 6"/>
+          <p:cNvPr id="6" name="Rectangle 5"/>
           <p:cNvSpPr/>
           <p:nvPr/>
         </p:nvSpPr>
@@ -25087,7 +25346,7 @@
       </p:sp>
       <p:sp>
         <p:nvSpPr>
-          <p:cNvPr id="8" name="Rectangle 7"/>
+          <p:cNvPr id="7" name="Rectangle 6"/>
           <p:cNvSpPr/>
           <p:nvPr/>
         </p:nvSpPr>
@@ -25131,7 +25390,7 @@
       </p:sp>
       <p:sp>
         <p:nvSpPr>
-          <p:cNvPr id="9" name="TextBox 8"/>
+          <p:cNvPr id="8" name="TextBox 7"/>
           <p:cNvSpPr txBox="1"/>
           <p:nvPr/>
         </p:nvSpPr>
@@ -25179,7 +25438,7 @@
       </p:sp>
       <p:graphicFrame>
         <p:nvGraphicFramePr>
-          <p:cNvPr id="10" name="Table 9"/>
+          <p:cNvPr id="9" name="Table 8"/>
           <p:cNvGraphicFramePr>
             <a:graphicFrameLocks noGrp="1"/>
           </p:cNvGraphicFramePr>
@@ -26328,7 +26587,7 @@
       </p:graphicFrame>
       <p:sp>
         <p:nvSpPr>
-          <p:cNvPr id="11" name="TextBox 10"/>
+          <p:cNvPr id="10" name="TextBox 9"/>
           <p:cNvSpPr txBox="1"/>
           <p:nvPr/>
         </p:nvSpPr>
@@ -26434,33 +26693,9 @@
           <a:p/>
         </p:txBody>
       </p:sp>
-      <p:pic>
-        <p:nvPicPr>
-          <p:cNvPr id="3" name="Picture 2" descr="image.png"/>
-          <p:cNvPicPr>
-            <a:picLocks noChangeAspect="1"/>
-          </p:cNvPicPr>
-          <p:nvPr/>
-        </p:nvPicPr>
-        <p:blipFill>
-          <a:blip r:embed="rId2"/>
-          <a:stretch>
-            <a:fillRect/>
-          </a:stretch>
-        </p:blipFill>
-        <p:spPr>
-          <a:xfrm>
-            <a:off x="9893808" y="6163056"/>
-            <a:ext cx="1938528" cy="621792"/>
-          </a:xfrm>
-          <a:prstGeom prst="rect">
-            <a:avLst/>
-          </a:prstGeom>
-        </p:spPr>
-      </p:pic>
-      <p:sp>
-        <p:nvSpPr>
-          <p:cNvPr id="4" name="TextBox 3"/>
+      <p:sp>
+        <p:nvSpPr>
+          <p:cNvPr id="3" name="TextBox 2"/>
           <p:cNvSpPr txBox="1"/>
           <p:nvPr/>
         </p:nvSpPr>
@@ -26494,7 +26729,7 @@
       </p:sp>
       <p:sp>
         <p:nvSpPr>
-          <p:cNvPr id="5" name="TextBox 4"/>
+          <p:cNvPr id="4" name="TextBox 3"/>
           <p:cNvSpPr txBox="1"/>
           <p:nvPr/>
         </p:nvSpPr>
@@ -26528,7 +26763,7 @@
       </p:sp>
       <p:cxnSp>
         <p:nvCxnSpPr>
-          <p:cNvPr id="6" name="Connector 5"/>
+          <p:cNvPr id="5" name="Connector 4"/>
           <p:cNvCxnSpPr/>
           <p:nvPr/>
         </p:nvCxnSpPr>
@@ -26563,7 +26798,7 @@
       </p:cxnSp>
       <p:sp>
         <p:nvSpPr>
-          <p:cNvPr id="7" name="Rectangle 6"/>
+          <p:cNvPr id="6" name="Rectangle 5"/>
           <p:cNvSpPr/>
           <p:nvPr/>
         </p:nvSpPr>
@@ -26609,7 +26844,7 @@
       </p:sp>
       <p:sp>
         <p:nvSpPr>
-          <p:cNvPr id="8" name="Rectangle 7"/>
+          <p:cNvPr id="7" name="Rectangle 6"/>
           <p:cNvSpPr/>
           <p:nvPr/>
         </p:nvSpPr>
@@ -26653,7 +26888,7 @@
       </p:sp>
       <p:sp>
         <p:nvSpPr>
-          <p:cNvPr id="9" name="TextBox 8"/>
+          <p:cNvPr id="8" name="TextBox 7"/>
           <p:cNvSpPr txBox="1"/>
           <p:nvPr/>
         </p:nvSpPr>
@@ -26687,7 +26922,7 @@
       </p:sp>
       <p:sp>
         <p:nvSpPr>
-          <p:cNvPr id="10" name="TextBox 9"/>
+          <p:cNvPr id="9" name="TextBox 8"/>
           <p:cNvSpPr txBox="1"/>
           <p:nvPr/>
         </p:nvSpPr>
@@ -26726,7 +26961,7 @@
       </p:sp>
       <p:sp>
         <p:nvSpPr>
-          <p:cNvPr id="11" name="Rectangle 10"/>
+          <p:cNvPr id="10" name="Rectangle 9"/>
           <p:cNvSpPr/>
           <p:nvPr/>
         </p:nvSpPr>
@@ -26772,7 +27007,7 @@
       </p:sp>
       <p:sp>
         <p:nvSpPr>
-          <p:cNvPr id="12" name="Rectangle 11"/>
+          <p:cNvPr id="11" name="Rectangle 10"/>
           <p:cNvSpPr/>
           <p:nvPr/>
         </p:nvSpPr>
@@ -26816,7 +27051,7 @@
       </p:sp>
       <p:sp>
         <p:nvSpPr>
-          <p:cNvPr id="13" name="TextBox 12"/>
+          <p:cNvPr id="12" name="TextBox 11"/>
           <p:cNvSpPr txBox="1"/>
           <p:nvPr/>
         </p:nvSpPr>
@@ -26850,7 +27085,7 @@
       </p:sp>
       <p:sp>
         <p:nvSpPr>
-          <p:cNvPr id="14" name="TextBox 13"/>
+          <p:cNvPr id="13" name="TextBox 12"/>
           <p:cNvSpPr txBox="1"/>
           <p:nvPr/>
         </p:nvSpPr>
@@ -26889,7 +27124,7 @@
       </p:sp>
       <p:sp>
         <p:nvSpPr>
-          <p:cNvPr id="15" name="Rectangle 14"/>
+          <p:cNvPr id="14" name="Rectangle 13"/>
           <p:cNvSpPr/>
           <p:nvPr/>
         </p:nvSpPr>
@@ -26935,7 +27170,7 @@
       </p:sp>
       <p:sp>
         <p:nvSpPr>
-          <p:cNvPr id="16" name="Rectangle 15"/>
+          <p:cNvPr id="15" name="Rectangle 14"/>
           <p:cNvSpPr/>
           <p:nvPr/>
         </p:nvSpPr>
@@ -26979,7 +27214,7 @@
       </p:sp>
       <p:sp>
         <p:nvSpPr>
-          <p:cNvPr id="17" name="TextBox 16"/>
+          <p:cNvPr id="16" name="TextBox 15"/>
           <p:cNvSpPr txBox="1"/>
           <p:nvPr/>
         </p:nvSpPr>
@@ -27013,7 +27248,7 @@
       </p:sp>
       <p:sp>
         <p:nvSpPr>
-          <p:cNvPr id="18" name="TextBox 17"/>
+          <p:cNvPr id="17" name="TextBox 16"/>
           <p:cNvSpPr txBox="1"/>
           <p:nvPr/>
         </p:nvSpPr>
@@ -27052,7 +27287,7 @@
       </p:sp>
       <p:sp>
         <p:nvSpPr>
-          <p:cNvPr id="19" name="Rectangle 18"/>
+          <p:cNvPr id="18" name="Rectangle 17"/>
           <p:cNvSpPr/>
           <p:nvPr/>
         </p:nvSpPr>
@@ -27098,7 +27333,7 @@
       </p:sp>
       <p:sp>
         <p:nvSpPr>
-          <p:cNvPr id="20" name="Rectangle 19"/>
+          <p:cNvPr id="19" name="Rectangle 18"/>
           <p:cNvSpPr/>
           <p:nvPr/>
         </p:nvSpPr>
@@ -27142,7 +27377,7 @@
       </p:sp>
       <p:sp>
         <p:nvSpPr>
-          <p:cNvPr id="21" name="TextBox 20"/>
+          <p:cNvPr id="20" name="TextBox 19"/>
           <p:cNvSpPr txBox="1"/>
           <p:nvPr/>
         </p:nvSpPr>
@@ -27176,7 +27411,7 @@
       </p:sp>
       <p:sp>
         <p:nvSpPr>
-          <p:cNvPr id="22" name="TextBox 21"/>
+          <p:cNvPr id="21" name="TextBox 20"/>
           <p:cNvSpPr txBox="1"/>
           <p:nvPr/>
         </p:nvSpPr>
@@ -27215,7 +27450,7 @@
       </p:sp>
       <p:sp>
         <p:nvSpPr>
-          <p:cNvPr id="23" name="Rectangle 22"/>
+          <p:cNvPr id="22" name="Rectangle 21"/>
           <p:cNvSpPr/>
           <p:nvPr/>
         </p:nvSpPr>
@@ -27261,7 +27496,7 @@
       </p:sp>
       <p:sp>
         <p:nvSpPr>
-          <p:cNvPr id="24" name="Rectangle 23"/>
+          <p:cNvPr id="23" name="Rectangle 22"/>
           <p:cNvSpPr/>
           <p:nvPr/>
         </p:nvSpPr>
@@ -27305,7 +27540,7 @@
       </p:sp>
       <p:sp>
         <p:nvSpPr>
-          <p:cNvPr id="25" name="TextBox 24"/>
+          <p:cNvPr id="24" name="TextBox 23"/>
           <p:cNvSpPr txBox="1"/>
           <p:nvPr/>
         </p:nvSpPr>
@@ -27339,7 +27574,7 @@
       </p:sp>
       <p:sp>
         <p:nvSpPr>
-          <p:cNvPr id="26" name="TextBox 25"/>
+          <p:cNvPr id="25" name="TextBox 24"/>
           <p:cNvSpPr txBox="1"/>
           <p:nvPr/>
         </p:nvSpPr>
@@ -27378,7 +27613,7 @@
       </p:sp>
       <p:sp>
         <p:nvSpPr>
-          <p:cNvPr id="27" name="Rectangle 26"/>
+          <p:cNvPr id="26" name="Rectangle 25"/>
           <p:cNvSpPr/>
           <p:nvPr/>
         </p:nvSpPr>
@@ -27424,7 +27659,7 @@
       </p:sp>
       <p:sp>
         <p:nvSpPr>
-          <p:cNvPr id="28" name="Rectangle 27"/>
+          <p:cNvPr id="27" name="Rectangle 26"/>
           <p:cNvSpPr/>
           <p:nvPr/>
         </p:nvSpPr>
@@ -27468,7 +27703,7 @@
       </p:sp>
       <p:sp>
         <p:nvSpPr>
-          <p:cNvPr id="29" name="TextBox 28"/>
+          <p:cNvPr id="28" name="TextBox 27"/>
           <p:cNvSpPr txBox="1"/>
           <p:nvPr/>
         </p:nvSpPr>
@@ -27502,7 +27737,7 @@
       </p:sp>
       <p:sp>
         <p:nvSpPr>
-          <p:cNvPr id="30" name="TextBox 29"/>
+          <p:cNvPr id="29" name="TextBox 28"/>
           <p:cNvSpPr txBox="1"/>
           <p:nvPr/>
         </p:nvSpPr>
@@ -27541,7 +27776,7 @@
       </p:sp>
       <p:sp>
         <p:nvSpPr>
-          <p:cNvPr id="31" name="TextBox 30"/>
+          <p:cNvPr id="30" name="TextBox 29"/>
           <p:cNvSpPr txBox="1"/>
           <p:nvPr/>
         </p:nvSpPr>
@@ -27966,33 +28201,9 @@
           <a:p/>
         </p:txBody>
       </p:sp>
-      <p:pic>
-        <p:nvPicPr>
-          <p:cNvPr id="3" name="Picture 2" descr="image.png"/>
-          <p:cNvPicPr>
-            <a:picLocks noChangeAspect="1"/>
-          </p:cNvPicPr>
-          <p:nvPr/>
-        </p:nvPicPr>
-        <p:blipFill>
-          <a:blip r:embed="rId2"/>
-          <a:stretch>
-            <a:fillRect/>
-          </a:stretch>
-        </p:blipFill>
-        <p:spPr>
-          <a:xfrm>
-            <a:off x="9893808" y="6163056"/>
-            <a:ext cx="1938528" cy="621792"/>
-          </a:xfrm>
-          <a:prstGeom prst="rect">
-            <a:avLst/>
-          </a:prstGeom>
-        </p:spPr>
-      </p:pic>
-      <p:sp>
-        <p:nvSpPr>
-          <p:cNvPr id="4" name="TextBox 3"/>
+      <p:sp>
+        <p:nvSpPr>
+          <p:cNvPr id="3" name="TextBox 2"/>
           <p:cNvSpPr txBox="1"/>
           <p:nvPr/>
         </p:nvSpPr>
@@ -28026,7 +28237,7 @@
       </p:sp>
       <p:sp>
         <p:nvSpPr>
-          <p:cNvPr id="5" name="TextBox 4"/>
+          <p:cNvPr id="4" name="TextBox 3"/>
           <p:cNvSpPr txBox="1"/>
           <p:nvPr/>
         </p:nvSpPr>
@@ -28060,7 +28271,7 @@
       </p:sp>
       <p:cxnSp>
         <p:nvCxnSpPr>
-          <p:cNvPr id="6" name="Connector 5"/>
+          <p:cNvPr id="5" name="Connector 4"/>
           <p:cNvCxnSpPr/>
           <p:nvPr/>
         </p:nvCxnSpPr>
@@ -28095,7 +28306,7 @@
       </p:cxnSp>
       <p:sp>
         <p:nvSpPr>
-          <p:cNvPr id="7" name="Rectangle 6"/>
+          <p:cNvPr id="6" name="Rectangle 5"/>
           <p:cNvSpPr/>
           <p:nvPr/>
         </p:nvSpPr>
@@ -28141,7 +28352,7 @@
       </p:sp>
       <p:sp>
         <p:nvSpPr>
-          <p:cNvPr id="8" name="Rectangle 7"/>
+          <p:cNvPr id="7" name="Rectangle 6"/>
           <p:cNvSpPr/>
           <p:nvPr/>
         </p:nvSpPr>
@@ -28185,7 +28396,7 @@
       </p:sp>
       <p:sp>
         <p:nvSpPr>
-          <p:cNvPr id="9" name="TextBox 8"/>
+          <p:cNvPr id="8" name="TextBox 7"/>
           <p:cNvSpPr txBox="1"/>
           <p:nvPr/>
         </p:nvSpPr>
@@ -28219,7 +28430,7 @@
       </p:sp>
       <p:sp>
         <p:nvSpPr>
-          <p:cNvPr id="10" name="TextBox 9"/>
+          <p:cNvPr id="9" name="TextBox 8"/>
           <p:cNvSpPr txBox="1"/>
           <p:nvPr/>
         </p:nvSpPr>
@@ -28253,7 +28464,7 @@
       </p:sp>
       <p:sp>
         <p:nvSpPr>
-          <p:cNvPr id="11" name="TextBox 10"/>
+          <p:cNvPr id="10" name="TextBox 9"/>
           <p:cNvSpPr txBox="1"/>
           <p:nvPr/>
         </p:nvSpPr>
@@ -28292,7 +28503,7 @@
       </p:sp>
       <p:sp>
         <p:nvSpPr>
-          <p:cNvPr id="12" name="TextBox 11"/>
+          <p:cNvPr id="11" name="TextBox 10"/>
           <p:cNvSpPr txBox="1"/>
           <p:nvPr/>
         </p:nvSpPr>
@@ -28327,7 +28538,7 @@
       </p:sp>
       <p:sp>
         <p:nvSpPr>
-          <p:cNvPr id="13" name="Rectangle 12"/>
+          <p:cNvPr id="12" name="Rectangle 11"/>
           <p:cNvSpPr/>
           <p:nvPr/>
         </p:nvSpPr>
@@ -28373,7 +28584,7 @@
       </p:sp>
       <p:sp>
         <p:nvSpPr>
-          <p:cNvPr id="14" name="Rectangle 13"/>
+          <p:cNvPr id="13" name="Rectangle 12"/>
           <p:cNvSpPr/>
           <p:nvPr/>
         </p:nvSpPr>
@@ -28417,7 +28628,7 @@
       </p:sp>
       <p:sp>
         <p:nvSpPr>
-          <p:cNvPr id="15" name="TextBox 14"/>
+          <p:cNvPr id="14" name="TextBox 13"/>
           <p:cNvSpPr txBox="1"/>
           <p:nvPr/>
         </p:nvSpPr>
@@ -28451,7 +28662,7 @@
       </p:sp>
       <p:sp>
         <p:nvSpPr>
-          <p:cNvPr id="16" name="TextBox 15"/>
+          <p:cNvPr id="15" name="TextBox 14"/>
           <p:cNvSpPr txBox="1"/>
           <p:nvPr/>
         </p:nvSpPr>
@@ -28485,7 +28696,7 @@
       </p:sp>
       <p:sp>
         <p:nvSpPr>
-          <p:cNvPr id="17" name="TextBox 16"/>
+          <p:cNvPr id="16" name="TextBox 15"/>
           <p:cNvSpPr txBox="1"/>
           <p:nvPr/>
         </p:nvSpPr>
@@ -28524,7 +28735,7 @@
       </p:sp>
       <p:sp>
         <p:nvSpPr>
-          <p:cNvPr id="18" name="TextBox 17"/>
+          <p:cNvPr id="17" name="TextBox 16"/>
           <p:cNvSpPr txBox="1"/>
           <p:nvPr/>
         </p:nvSpPr>
@@ -28559,7 +28770,7 @@
       </p:sp>
       <p:sp>
         <p:nvSpPr>
-          <p:cNvPr id="19" name="Rectangle 18"/>
+          <p:cNvPr id="18" name="Rectangle 17"/>
           <p:cNvSpPr/>
           <p:nvPr/>
         </p:nvSpPr>
@@ -28605,7 +28816,7 @@
       </p:sp>
       <p:sp>
         <p:nvSpPr>
-          <p:cNvPr id="20" name="Rectangle 19"/>
+          <p:cNvPr id="19" name="Rectangle 18"/>
           <p:cNvSpPr/>
           <p:nvPr/>
         </p:nvSpPr>
@@ -28649,7 +28860,7 @@
       </p:sp>
       <p:sp>
         <p:nvSpPr>
-          <p:cNvPr id="21" name="TextBox 20"/>
+          <p:cNvPr id="20" name="TextBox 19"/>
           <p:cNvSpPr txBox="1"/>
           <p:nvPr/>
         </p:nvSpPr>
@@ -28683,7 +28894,7 @@
       </p:sp>
       <p:sp>
         <p:nvSpPr>
-          <p:cNvPr id="22" name="TextBox 21"/>
+          <p:cNvPr id="21" name="TextBox 20"/>
           <p:cNvSpPr txBox="1"/>
           <p:nvPr/>
         </p:nvSpPr>
@@ -28717,7 +28928,7 @@
       </p:sp>
       <p:sp>
         <p:nvSpPr>
-          <p:cNvPr id="23" name="TextBox 22"/>
+          <p:cNvPr id="22" name="TextBox 21"/>
           <p:cNvSpPr txBox="1"/>
           <p:nvPr/>
         </p:nvSpPr>
@@ -28756,7 +28967,7 @@
       </p:sp>
       <p:sp>
         <p:nvSpPr>
-          <p:cNvPr id="24" name="TextBox 23"/>
+          <p:cNvPr id="23" name="TextBox 22"/>
           <p:cNvSpPr txBox="1"/>
           <p:nvPr/>
         </p:nvSpPr>
@@ -28791,7 +29002,7 @@
       </p:sp>
       <p:sp>
         <p:nvSpPr>
-          <p:cNvPr id="25" name="Rectangle 24"/>
+          <p:cNvPr id="24" name="Rectangle 23"/>
           <p:cNvSpPr/>
           <p:nvPr/>
         </p:nvSpPr>
@@ -28837,7 +29048,7 @@
       </p:sp>
       <p:sp>
         <p:nvSpPr>
-          <p:cNvPr id="26" name="Rectangle 25"/>
+          <p:cNvPr id="25" name="Rectangle 24"/>
           <p:cNvSpPr/>
           <p:nvPr/>
         </p:nvSpPr>
@@ -28881,7 +29092,7 @@
       </p:sp>
       <p:sp>
         <p:nvSpPr>
-          <p:cNvPr id="27" name="TextBox 26"/>
+          <p:cNvPr id="26" name="TextBox 25"/>
           <p:cNvSpPr txBox="1"/>
           <p:nvPr/>
         </p:nvSpPr>
@@ -28915,7 +29126,7 @@
       </p:sp>
       <p:sp>
         <p:nvSpPr>
-          <p:cNvPr id="28" name="TextBox 27"/>
+          <p:cNvPr id="27" name="TextBox 26"/>
           <p:cNvSpPr txBox="1"/>
           <p:nvPr/>
         </p:nvSpPr>
@@ -28949,7 +29160,7 @@
       </p:sp>
       <p:sp>
         <p:nvSpPr>
-          <p:cNvPr id="29" name="TextBox 28"/>
+          <p:cNvPr id="28" name="TextBox 27"/>
           <p:cNvSpPr txBox="1"/>
           <p:nvPr/>
         </p:nvSpPr>
@@ -28988,7 +29199,7 @@
       </p:sp>
       <p:sp>
         <p:nvSpPr>
-          <p:cNvPr id="30" name="TextBox 29"/>
+          <p:cNvPr id="29" name="TextBox 28"/>
           <p:cNvSpPr txBox="1"/>
           <p:nvPr/>
         </p:nvSpPr>
@@ -29023,7 +29234,7 @@
       </p:sp>
       <p:sp>
         <p:nvSpPr>
-          <p:cNvPr id="31" name="Rectangle 30"/>
+          <p:cNvPr id="30" name="Rectangle 29"/>
           <p:cNvSpPr/>
           <p:nvPr/>
         </p:nvSpPr>
@@ -29069,7 +29280,7 @@
       </p:sp>
       <p:sp>
         <p:nvSpPr>
-          <p:cNvPr id="32" name="Rectangle 31"/>
+          <p:cNvPr id="31" name="Rectangle 30"/>
           <p:cNvSpPr/>
           <p:nvPr/>
         </p:nvSpPr>
@@ -29113,7 +29324,7 @@
       </p:sp>
       <p:sp>
         <p:nvSpPr>
-          <p:cNvPr id="33" name="TextBox 32"/>
+          <p:cNvPr id="32" name="TextBox 31"/>
           <p:cNvSpPr txBox="1"/>
           <p:nvPr/>
         </p:nvSpPr>
@@ -29147,7 +29358,7 @@
       </p:sp>
       <p:sp>
         <p:nvSpPr>
-          <p:cNvPr id="34" name="TextBox 33"/>
+          <p:cNvPr id="33" name="TextBox 32"/>
           <p:cNvSpPr txBox="1"/>
           <p:nvPr/>
         </p:nvSpPr>
@@ -29181,7 +29392,7 @@
       </p:sp>
       <p:sp>
         <p:nvSpPr>
-          <p:cNvPr id="35" name="TextBox 34"/>
+          <p:cNvPr id="34" name="TextBox 33"/>
           <p:cNvSpPr txBox="1"/>
           <p:nvPr/>
         </p:nvSpPr>
@@ -29220,7 +29431,7 @@
       </p:sp>
       <p:sp>
         <p:nvSpPr>
-          <p:cNvPr id="36" name="TextBox 35"/>
+          <p:cNvPr id="35" name="TextBox 34"/>
           <p:cNvSpPr txBox="1"/>
           <p:nvPr/>
         </p:nvSpPr>
@@ -29254,7 +29465,7 @@
       </p:sp>
       <p:sp>
         <p:nvSpPr>
-          <p:cNvPr id="37" name="Rectangle 36"/>
+          <p:cNvPr id="36" name="Rectangle 35"/>
           <p:cNvSpPr/>
           <p:nvPr/>
         </p:nvSpPr>
@@ -29300,7 +29511,7 @@
       </p:sp>
       <p:sp>
         <p:nvSpPr>
-          <p:cNvPr id="38" name="Rectangle 37"/>
+          <p:cNvPr id="37" name="Rectangle 36"/>
           <p:cNvSpPr/>
           <p:nvPr/>
         </p:nvSpPr>
@@ -29344,7 +29555,7 @@
       </p:sp>
       <p:sp>
         <p:nvSpPr>
-          <p:cNvPr id="39" name="TextBox 38"/>
+          <p:cNvPr id="38" name="TextBox 37"/>
           <p:cNvSpPr txBox="1"/>
           <p:nvPr/>
         </p:nvSpPr>
@@ -29378,7 +29589,7 @@
       </p:sp>
       <p:sp>
         <p:nvSpPr>
-          <p:cNvPr id="40" name="TextBox 39"/>
+          <p:cNvPr id="39" name="TextBox 38"/>
           <p:cNvSpPr txBox="1"/>
           <p:nvPr/>
         </p:nvSpPr>
@@ -29417,7 +29628,7 @@
       </p:sp>
       <p:sp>
         <p:nvSpPr>
-          <p:cNvPr id="41" name="Rectangle 40"/>
+          <p:cNvPr id="40" name="Rectangle 39"/>
           <p:cNvSpPr/>
           <p:nvPr/>
         </p:nvSpPr>
@@ -29463,7 +29674,7 @@
       </p:sp>
       <p:sp>
         <p:nvSpPr>
-          <p:cNvPr id="42" name="Rectangle 41"/>
+          <p:cNvPr id="41" name="Rectangle 40"/>
           <p:cNvSpPr/>
           <p:nvPr/>
         </p:nvSpPr>
@@ -29507,7 +29718,7 @@
       </p:sp>
       <p:sp>
         <p:nvSpPr>
-          <p:cNvPr id="43" name="TextBox 42"/>
+          <p:cNvPr id="42" name="TextBox 41"/>
           <p:cNvSpPr txBox="1"/>
           <p:nvPr/>
         </p:nvSpPr>
@@ -29541,7 +29752,7 @@
       </p:sp>
       <p:sp>
         <p:nvSpPr>
-          <p:cNvPr id="44" name="TextBox 43"/>
+          <p:cNvPr id="43" name="TextBox 42"/>
           <p:cNvSpPr txBox="1"/>
           <p:nvPr/>
         </p:nvSpPr>
@@ -29580,7 +29791,7 @@
       </p:sp>
       <p:sp>
         <p:nvSpPr>
-          <p:cNvPr id="45" name="Rectangle 44"/>
+          <p:cNvPr id="44" name="Rectangle 43"/>
           <p:cNvSpPr/>
           <p:nvPr/>
         </p:nvSpPr>
@@ -29626,7 +29837,7 @@
       </p:sp>
       <p:sp>
         <p:nvSpPr>
-          <p:cNvPr id="46" name="Rectangle 45"/>
+          <p:cNvPr id="45" name="Rectangle 44"/>
           <p:cNvSpPr/>
           <p:nvPr/>
         </p:nvSpPr>
@@ -29670,7 +29881,7 @@
       </p:sp>
       <p:sp>
         <p:nvSpPr>
-          <p:cNvPr id="47" name="TextBox 46"/>
+          <p:cNvPr id="46" name="TextBox 45"/>
           <p:cNvSpPr txBox="1"/>
           <p:nvPr/>
         </p:nvSpPr>
@@ -29704,7 +29915,7 @@
       </p:sp>
       <p:sp>
         <p:nvSpPr>
-          <p:cNvPr id="48" name="TextBox 47"/>
+          <p:cNvPr id="47" name="TextBox 46"/>
           <p:cNvSpPr txBox="1"/>
           <p:nvPr/>
         </p:nvSpPr>
@@ -29743,7 +29954,7 @@
       </p:sp>
       <p:sp>
         <p:nvSpPr>
-          <p:cNvPr id="49" name="TextBox 48"/>
+          <p:cNvPr id="48" name="TextBox 47"/>
           <p:cNvSpPr txBox="1"/>
           <p:nvPr/>
         </p:nvSpPr>

</xml_diff>